<commit_message>
--chatroomPosts: - edit posts - mark edited posts
</commit_message>
<xml_diff>
--- a/ExaminerB/.appCatalog/ExaminerB notes 1404.pptx
+++ b/ExaminerB/.appCatalog/ExaminerB notes 1404.pptx
@@ -280,7 +280,7 @@
             </a:pPr>
             <a:fld id="{BCC18F51-09EC-435C-A3BA-64A766E099C0}" type="datetimeFigureOut">
               <a:rPr lang="fa-IR"/>
-              <a:t>20/09/1447</a:t>
+              <a:t>27/09/1447</a:t>
             </a:fld>
             <a:endParaRPr/>
           </a:p>
@@ -459,7 +459,7 @@
             </a:pPr>
             <a:fld id="{BCC18F51-09EC-435C-A3BA-64A766E099C0}" type="datetimeFigureOut">
               <a:rPr lang="fa-IR"/>
-              <a:t>20/09/1447</a:t>
+              <a:t>27/09/1447</a:t>
             </a:fld>
             <a:endParaRPr/>
           </a:p>
@@ -648,7 +648,7 @@
             </a:pPr>
             <a:fld id="{BCC18F51-09EC-435C-A3BA-64A766E099C0}" type="datetimeFigureOut">
               <a:rPr lang="fa-IR"/>
-              <a:t>20/09/1447</a:t>
+              <a:t>27/09/1447</a:t>
             </a:fld>
             <a:endParaRPr/>
           </a:p>
@@ -827,7 +827,7 @@
             </a:pPr>
             <a:fld id="{BCC18F51-09EC-435C-A3BA-64A766E099C0}" type="datetimeFigureOut">
               <a:rPr lang="fa-IR"/>
-              <a:t>20/09/1447</a:t>
+              <a:t>27/09/1447</a:t>
             </a:fld>
             <a:endParaRPr/>
           </a:p>
@@ -1079,7 +1079,7 @@
             </a:pPr>
             <a:fld id="{BCC18F51-09EC-435C-A3BA-64A766E099C0}" type="datetimeFigureOut">
               <a:rPr lang="fa-IR"/>
-              <a:t>20/09/1447</a:t>
+              <a:t>27/09/1447</a:t>
             </a:fld>
             <a:endParaRPr/>
           </a:p>
@@ -1324,7 +1324,7 @@
             </a:pPr>
             <a:fld id="{BCC18F51-09EC-435C-A3BA-64A766E099C0}" type="datetimeFigureOut">
               <a:rPr lang="fa-IR"/>
-              <a:t>20/09/1447</a:t>
+              <a:t>27/09/1447</a:t>
             </a:fld>
             <a:endParaRPr/>
           </a:p>
@@ -1706,7 +1706,7 @@
             </a:pPr>
             <a:fld id="{BCC18F51-09EC-435C-A3BA-64A766E099C0}" type="datetimeFigureOut">
               <a:rPr lang="fa-IR"/>
-              <a:t>20/09/1447</a:t>
+              <a:t>27/09/1447</a:t>
             </a:fld>
             <a:endParaRPr/>
           </a:p>
@@ -1829,7 +1829,7 @@
             </a:pPr>
             <a:fld id="{BCC18F51-09EC-435C-A3BA-64A766E099C0}" type="datetimeFigureOut">
               <a:rPr lang="fa-IR"/>
-              <a:t>20/09/1447</a:t>
+              <a:t>27/09/1447</a:t>
             </a:fld>
             <a:endParaRPr/>
           </a:p>
@@ -1928,7 +1928,7 @@
             </a:pPr>
             <a:fld id="{BCC18F51-09EC-435C-A3BA-64A766E099C0}" type="datetimeFigureOut">
               <a:rPr lang="fa-IR"/>
-              <a:t>20/09/1447</a:t>
+              <a:t>27/09/1447</a:t>
             </a:fld>
             <a:endParaRPr/>
           </a:p>
@@ -2215,7 +2215,7 @@
             </a:pPr>
             <a:fld id="{BCC18F51-09EC-435C-A3BA-64A766E099C0}" type="datetimeFigureOut">
               <a:rPr lang="fa-IR"/>
-              <a:t>20/09/1447</a:t>
+              <a:t>27/09/1447</a:t>
             </a:fld>
             <a:endParaRPr/>
           </a:p>
@@ -2479,7 +2479,7 @@
             </a:pPr>
             <a:fld id="{BCC18F51-09EC-435C-A3BA-64A766E099C0}" type="datetimeFigureOut">
               <a:rPr lang="fa-IR"/>
-              <a:t>20/09/1447</a:t>
+              <a:t>27/09/1447</a:t>
             </a:fld>
             <a:endParaRPr/>
           </a:p>
@@ -2701,7 +2701,7 @@
             </a:pPr>
             <a:fld id="{BCC18F51-09EC-435C-A3BA-64A766E099C0}" type="datetimeFigureOut">
               <a:rPr lang="fa-IR"/>
-              <a:t>20/09/1447</a:t>
+              <a:t>27/09/1447</a:t>
             </a:fld>
             <a:endParaRPr/>
           </a:p>
@@ -7895,8 +7895,8 @@
         </p:nvSpPr>
         <p:spPr bwMode="auto">
           <a:xfrm>
-            <a:off x="771596" y="1684762"/>
-            <a:ext cx="1990011" cy="259346"/>
+            <a:off x="779315" y="1829793"/>
+            <a:ext cx="2013126" cy="259346"/>
           </a:xfrm>
           <a:prstGeom prst="borderCallout2">
             <a:avLst>
@@ -8339,11 +8339,11 @@
         <p:spPr bwMode="auto">
           <a:xfrm>
             <a:off x="48639" y="157639"/>
-            <a:ext cx="1445914" cy="1196534"/>
+            <a:ext cx="1445914" cy="1642462"/>
           </a:xfrm>
           <a:prstGeom prst="roundRect">
             <a:avLst>
-              <a:gd name="adj" fmla="val 9941"/>
+              <a:gd name="adj" fmla="val 6742"/>
             </a:avLst>
           </a:prstGeom>
           <a:solidFill>
@@ -8486,6 +8486,66 @@
                 <a:cs typeface="Segoe UI" panose="020B0502040204020203" pitchFamily="34" charset="0"/>
               </a:rPr>
               <a:t>PostText</a:t>
+            </a:r>
+          </a:p>
+          <a:p>
+            <a:pPr rtl="0">
+              <a:defRPr/>
+            </a:pPr>
+            <a:r>
+              <a:rPr lang="en-US" sz="853">
+                <a:solidFill>
+                  <a:schemeClr val="tx1"/>
+                </a:solidFill>
+                <a:latin typeface="Segoe UI" panose="020B0502040204020203" pitchFamily="34" charset="0"/>
+                <a:cs typeface="Segoe UI" panose="020B0502040204020203" pitchFamily="34" charset="0"/>
+              </a:rPr>
+              <a:t>PostTags</a:t>
+            </a:r>
+          </a:p>
+          <a:p>
+            <a:pPr rtl="0">
+              <a:defRPr/>
+            </a:pPr>
+            <a:r>
+              <a:rPr lang="en-US" sz="800">
+                <a:solidFill>
+                  <a:schemeClr val="tx1"/>
+                </a:solidFill>
+                <a:latin typeface="Segoe UI" panose="020B0502040204020203" pitchFamily="34" charset="0"/>
+                <a:cs typeface="Segoe UI" panose="020B0502040204020203" pitchFamily="34" charset="0"/>
+              </a:rPr>
+              <a:t>  1:NeedReply</a:t>
+            </a:r>
+          </a:p>
+          <a:p>
+            <a:pPr rtl="0">
+              <a:defRPr/>
+            </a:pPr>
+            <a:r>
+              <a:rPr lang="en-US" sz="800">
+                <a:solidFill>
+                  <a:schemeClr val="tx1"/>
+                </a:solidFill>
+                <a:latin typeface="Segoe UI" panose="020B0502040204020203" pitchFamily="34" charset="0"/>
+                <a:cs typeface="Segoe UI" panose="020B0502040204020203" pitchFamily="34" charset="0"/>
+              </a:rPr>
+              <a:t>  2:IsEdited</a:t>
+            </a:r>
+          </a:p>
+          <a:p>
+            <a:pPr rtl="0">
+              <a:defRPr/>
+            </a:pPr>
+            <a:r>
+              <a:rPr lang="en-US" sz="800">
+                <a:solidFill>
+                  <a:schemeClr val="tx1"/>
+                </a:solidFill>
+                <a:latin typeface="Segoe UI" panose="020B0502040204020203" pitchFamily="34" charset="0"/>
+                <a:cs typeface="Segoe UI" panose="020B0502040204020203" pitchFamily="34" charset="0"/>
+              </a:rPr>
+              <a:t>  4:IsDeleted</a:t>
             </a:r>
           </a:p>
         </p:txBody>

</xml_diff>

<commit_message>
-replace SP Note --- OK
</commit_message>
<xml_diff>
--- a/ExaminerB/.appCatalog/ExaminerB notes 1404.pptx
+++ b/ExaminerB/.appCatalog/ExaminerB notes 1404.pptx
@@ -280,7 +280,7 @@
             </a:pPr>
             <a:fld id="{BCC18F51-09EC-435C-A3BA-64A766E099C0}" type="datetimeFigureOut">
               <a:rPr lang="fa-IR"/>
-              <a:t>27/09/1447</a:t>
+              <a:t>26/10/1447</a:t>
             </a:fld>
             <a:endParaRPr/>
           </a:p>
@@ -459,7 +459,7 @@
             </a:pPr>
             <a:fld id="{BCC18F51-09EC-435C-A3BA-64A766E099C0}" type="datetimeFigureOut">
               <a:rPr lang="fa-IR"/>
-              <a:t>27/09/1447</a:t>
+              <a:t>26/10/1447</a:t>
             </a:fld>
             <a:endParaRPr/>
           </a:p>
@@ -648,7 +648,7 @@
             </a:pPr>
             <a:fld id="{BCC18F51-09EC-435C-A3BA-64A766E099C0}" type="datetimeFigureOut">
               <a:rPr lang="fa-IR"/>
-              <a:t>27/09/1447</a:t>
+              <a:t>26/10/1447</a:t>
             </a:fld>
             <a:endParaRPr/>
           </a:p>
@@ -827,7 +827,7 @@
             </a:pPr>
             <a:fld id="{BCC18F51-09EC-435C-A3BA-64A766E099C0}" type="datetimeFigureOut">
               <a:rPr lang="fa-IR"/>
-              <a:t>27/09/1447</a:t>
+              <a:t>26/10/1447</a:t>
             </a:fld>
             <a:endParaRPr/>
           </a:p>
@@ -1079,7 +1079,7 @@
             </a:pPr>
             <a:fld id="{BCC18F51-09EC-435C-A3BA-64A766E099C0}" type="datetimeFigureOut">
               <a:rPr lang="fa-IR"/>
-              <a:t>27/09/1447</a:t>
+              <a:t>26/10/1447</a:t>
             </a:fld>
             <a:endParaRPr/>
           </a:p>
@@ -1324,7 +1324,7 @@
             </a:pPr>
             <a:fld id="{BCC18F51-09EC-435C-A3BA-64A766E099C0}" type="datetimeFigureOut">
               <a:rPr lang="fa-IR"/>
-              <a:t>27/09/1447</a:t>
+              <a:t>26/10/1447</a:t>
             </a:fld>
             <a:endParaRPr/>
           </a:p>
@@ -1706,7 +1706,7 @@
             </a:pPr>
             <a:fld id="{BCC18F51-09EC-435C-A3BA-64A766E099C0}" type="datetimeFigureOut">
               <a:rPr lang="fa-IR"/>
-              <a:t>27/09/1447</a:t>
+              <a:t>26/10/1447</a:t>
             </a:fld>
             <a:endParaRPr/>
           </a:p>
@@ -1829,7 +1829,7 @@
             </a:pPr>
             <a:fld id="{BCC18F51-09EC-435C-A3BA-64A766E099C0}" type="datetimeFigureOut">
               <a:rPr lang="fa-IR"/>
-              <a:t>27/09/1447</a:t>
+              <a:t>26/10/1447</a:t>
             </a:fld>
             <a:endParaRPr/>
           </a:p>
@@ -1928,7 +1928,7 @@
             </a:pPr>
             <a:fld id="{BCC18F51-09EC-435C-A3BA-64A766E099C0}" type="datetimeFigureOut">
               <a:rPr lang="fa-IR"/>
-              <a:t>27/09/1447</a:t>
+              <a:t>26/10/1447</a:t>
             </a:fld>
             <a:endParaRPr/>
           </a:p>
@@ -2215,7 +2215,7 @@
             </a:pPr>
             <a:fld id="{BCC18F51-09EC-435C-A3BA-64A766E099C0}" type="datetimeFigureOut">
               <a:rPr lang="fa-IR"/>
-              <a:t>27/09/1447</a:t>
+              <a:t>26/10/1447</a:t>
             </a:fld>
             <a:endParaRPr/>
           </a:p>
@@ -2479,7 +2479,7 @@
             </a:pPr>
             <a:fld id="{BCC18F51-09EC-435C-A3BA-64A766E099C0}" type="datetimeFigureOut">
               <a:rPr lang="fa-IR"/>
-              <a:t>27/09/1447</a:t>
+              <a:t>26/10/1447</a:t>
             </a:fld>
             <a:endParaRPr/>
           </a:p>
@@ -2701,7 +2701,7 @@
             </a:pPr>
             <a:fld id="{BCC18F51-09EC-435C-A3BA-64A766E099C0}" type="datetimeFigureOut">
               <a:rPr lang="fa-IR"/>
-              <a:t>27/09/1447</a:t>
+              <a:t>26/10/1447</a:t>
             </a:fld>
             <a:endParaRPr/>
           </a:p>
@@ -7131,8 +7131,8 @@
         </p:nvSpPr>
         <p:spPr>
           <a:xfrm>
-            <a:off x="1585325" y="6149939"/>
-            <a:ext cx="1316313" cy="1166425"/>
+            <a:off x="1585325" y="6149940"/>
+            <a:ext cx="1316313" cy="1122060"/>
           </a:xfrm>
           <a:prstGeom prst="roundRect">
             <a:avLst>
@@ -7628,7 +7628,7 @@
         </p:nvSpPr>
         <p:spPr bwMode="auto">
           <a:xfrm>
-            <a:off x="230644" y="7616978"/>
+            <a:off x="595546" y="7759508"/>
             <a:ext cx="2306092" cy="326683"/>
           </a:xfrm>
           <a:prstGeom prst="borderCallout2">
@@ -7980,7 +7980,7 @@
         </p:nvSpPr>
         <p:spPr bwMode="auto">
           <a:xfrm>
-            <a:off x="2735908" y="7900267"/>
+            <a:off x="3164545" y="7770744"/>
             <a:ext cx="2891549" cy="355614"/>
           </a:xfrm>
           <a:prstGeom prst="borderCallout2">
@@ -8087,7 +8087,7 @@
         </p:nvSpPr>
         <p:spPr bwMode="auto">
           <a:xfrm>
-            <a:off x="229840" y="7190422"/>
+            <a:off x="171698" y="7182323"/>
             <a:ext cx="1152128" cy="355613"/>
           </a:xfrm>
           <a:prstGeom prst="borderCallout2">

</xml_diff>

<commit_message>
grant/deny: access, retry and review for courses and exams for selected students OK
</commit_message>
<xml_diff>
--- a/ExaminerB/.appCatalog/ExaminerB notes 1404.pptx
+++ b/ExaminerB/.appCatalog/ExaminerB notes 1404.pptx
@@ -280,7 +280,7 @@
             </a:pPr>
             <a:fld id="{BCC18F51-09EC-435C-A3BA-64A766E099C0}" type="datetimeFigureOut">
               <a:rPr lang="fa-IR"/>
-              <a:t>26/10/1447</a:t>
+              <a:t>02/11/1447</a:t>
             </a:fld>
             <a:endParaRPr/>
           </a:p>
@@ -459,7 +459,7 @@
             </a:pPr>
             <a:fld id="{BCC18F51-09EC-435C-A3BA-64A766E099C0}" type="datetimeFigureOut">
               <a:rPr lang="fa-IR"/>
-              <a:t>26/10/1447</a:t>
+              <a:t>02/11/1447</a:t>
             </a:fld>
             <a:endParaRPr/>
           </a:p>
@@ -648,7 +648,7 @@
             </a:pPr>
             <a:fld id="{BCC18F51-09EC-435C-A3BA-64A766E099C0}" type="datetimeFigureOut">
               <a:rPr lang="fa-IR"/>
-              <a:t>26/10/1447</a:t>
+              <a:t>02/11/1447</a:t>
             </a:fld>
             <a:endParaRPr/>
           </a:p>
@@ -827,7 +827,7 @@
             </a:pPr>
             <a:fld id="{BCC18F51-09EC-435C-A3BA-64A766E099C0}" type="datetimeFigureOut">
               <a:rPr lang="fa-IR"/>
-              <a:t>26/10/1447</a:t>
+              <a:t>02/11/1447</a:t>
             </a:fld>
             <a:endParaRPr/>
           </a:p>
@@ -1079,7 +1079,7 @@
             </a:pPr>
             <a:fld id="{BCC18F51-09EC-435C-A3BA-64A766E099C0}" type="datetimeFigureOut">
               <a:rPr lang="fa-IR"/>
-              <a:t>26/10/1447</a:t>
+              <a:t>02/11/1447</a:t>
             </a:fld>
             <a:endParaRPr/>
           </a:p>
@@ -1324,7 +1324,7 @@
             </a:pPr>
             <a:fld id="{BCC18F51-09EC-435C-A3BA-64A766E099C0}" type="datetimeFigureOut">
               <a:rPr lang="fa-IR"/>
-              <a:t>26/10/1447</a:t>
+              <a:t>02/11/1447</a:t>
             </a:fld>
             <a:endParaRPr/>
           </a:p>
@@ -1706,7 +1706,7 @@
             </a:pPr>
             <a:fld id="{BCC18F51-09EC-435C-A3BA-64A766E099C0}" type="datetimeFigureOut">
               <a:rPr lang="fa-IR"/>
-              <a:t>26/10/1447</a:t>
+              <a:t>02/11/1447</a:t>
             </a:fld>
             <a:endParaRPr/>
           </a:p>
@@ -1829,7 +1829,7 @@
             </a:pPr>
             <a:fld id="{BCC18F51-09EC-435C-A3BA-64A766E099C0}" type="datetimeFigureOut">
               <a:rPr lang="fa-IR"/>
-              <a:t>26/10/1447</a:t>
+              <a:t>02/11/1447</a:t>
             </a:fld>
             <a:endParaRPr/>
           </a:p>
@@ -1928,7 +1928,7 @@
             </a:pPr>
             <a:fld id="{BCC18F51-09EC-435C-A3BA-64A766E099C0}" type="datetimeFigureOut">
               <a:rPr lang="fa-IR"/>
-              <a:t>26/10/1447</a:t>
+              <a:t>02/11/1447</a:t>
             </a:fld>
             <a:endParaRPr/>
           </a:p>
@@ -2215,7 +2215,7 @@
             </a:pPr>
             <a:fld id="{BCC18F51-09EC-435C-A3BA-64A766E099C0}" type="datetimeFigureOut">
               <a:rPr lang="fa-IR"/>
-              <a:t>26/10/1447</a:t>
+              <a:t>02/11/1447</a:t>
             </a:fld>
             <a:endParaRPr/>
           </a:p>
@@ -2479,7 +2479,7 @@
             </a:pPr>
             <a:fld id="{BCC18F51-09EC-435C-A3BA-64A766E099C0}" type="datetimeFigureOut">
               <a:rPr lang="fa-IR"/>
-              <a:t>26/10/1447</a:t>
+              <a:t>02/11/1447</a:t>
             </a:fld>
             <a:endParaRPr/>
           </a:p>
@@ -2701,7 +2701,7 @@
             </a:pPr>
             <a:fld id="{BCC18F51-09EC-435C-A3BA-64A766E099C0}" type="datetimeFigureOut">
               <a:rPr lang="fa-IR"/>
-              <a:t>26/10/1447</a:t>
+              <a:t>02/11/1447</a:t>
             </a:fld>
             <a:endParaRPr/>
           </a:p>
@@ -6043,7 +6043,7 @@
                 <a:latin typeface="Segoe UI" panose="020B0502040204020203" pitchFamily="34" charset="0"/>
                 <a:cs typeface="Segoe UI" panose="020B0502040204020203" pitchFamily="34" charset="0"/>
               </a:rPr>
-              <a:t>1:act 2:st, 4:fin, 8:rev</a:t>
+              <a:t>1:act 2:strt, 4:fin, 8:rev</a:t>
             </a:r>
           </a:p>
           <a:p>

</xml_diff>

<commit_message>
-Exam Components: 2 levels     TestLevelFrom, testLevelTo OK
</commit_message>
<xml_diff>
--- a/ExaminerB/.appCatalog/ExaminerB notes 1404.pptx
+++ b/ExaminerB/.appCatalog/ExaminerB notes 1404.pptx
@@ -280,7 +280,7 @@
             </a:pPr>
             <a:fld id="{BCC18F51-09EC-435C-A3BA-64A766E099C0}" type="datetimeFigureOut">
               <a:rPr lang="fa-IR"/>
-              <a:t>06/11/1447</a:t>
+              <a:t>07/11/1447</a:t>
             </a:fld>
             <a:endParaRPr/>
           </a:p>
@@ -459,7 +459,7 @@
             </a:pPr>
             <a:fld id="{BCC18F51-09EC-435C-A3BA-64A766E099C0}" type="datetimeFigureOut">
               <a:rPr lang="fa-IR"/>
-              <a:t>06/11/1447</a:t>
+              <a:t>07/11/1447</a:t>
             </a:fld>
             <a:endParaRPr/>
           </a:p>
@@ -648,7 +648,7 @@
             </a:pPr>
             <a:fld id="{BCC18F51-09EC-435C-A3BA-64A766E099C0}" type="datetimeFigureOut">
               <a:rPr lang="fa-IR"/>
-              <a:t>06/11/1447</a:t>
+              <a:t>07/11/1447</a:t>
             </a:fld>
             <a:endParaRPr/>
           </a:p>
@@ -827,7 +827,7 @@
             </a:pPr>
             <a:fld id="{BCC18F51-09EC-435C-A3BA-64A766E099C0}" type="datetimeFigureOut">
               <a:rPr lang="fa-IR"/>
-              <a:t>06/11/1447</a:t>
+              <a:t>07/11/1447</a:t>
             </a:fld>
             <a:endParaRPr/>
           </a:p>
@@ -1079,7 +1079,7 @@
             </a:pPr>
             <a:fld id="{BCC18F51-09EC-435C-A3BA-64A766E099C0}" type="datetimeFigureOut">
               <a:rPr lang="fa-IR"/>
-              <a:t>06/11/1447</a:t>
+              <a:t>07/11/1447</a:t>
             </a:fld>
             <a:endParaRPr/>
           </a:p>
@@ -1324,7 +1324,7 @@
             </a:pPr>
             <a:fld id="{BCC18F51-09EC-435C-A3BA-64A766E099C0}" type="datetimeFigureOut">
               <a:rPr lang="fa-IR"/>
-              <a:t>06/11/1447</a:t>
+              <a:t>07/11/1447</a:t>
             </a:fld>
             <a:endParaRPr/>
           </a:p>
@@ -1706,7 +1706,7 @@
             </a:pPr>
             <a:fld id="{BCC18F51-09EC-435C-A3BA-64A766E099C0}" type="datetimeFigureOut">
               <a:rPr lang="fa-IR"/>
-              <a:t>06/11/1447</a:t>
+              <a:t>07/11/1447</a:t>
             </a:fld>
             <a:endParaRPr/>
           </a:p>
@@ -1829,7 +1829,7 @@
             </a:pPr>
             <a:fld id="{BCC18F51-09EC-435C-A3BA-64A766E099C0}" type="datetimeFigureOut">
               <a:rPr lang="fa-IR"/>
-              <a:t>06/11/1447</a:t>
+              <a:t>07/11/1447</a:t>
             </a:fld>
             <a:endParaRPr/>
           </a:p>
@@ -1928,7 +1928,7 @@
             </a:pPr>
             <a:fld id="{BCC18F51-09EC-435C-A3BA-64A766E099C0}" type="datetimeFigureOut">
               <a:rPr lang="fa-IR"/>
-              <a:t>06/11/1447</a:t>
+              <a:t>07/11/1447</a:t>
             </a:fld>
             <a:endParaRPr/>
           </a:p>
@@ -2215,7 +2215,7 @@
             </a:pPr>
             <a:fld id="{BCC18F51-09EC-435C-A3BA-64A766E099C0}" type="datetimeFigureOut">
               <a:rPr lang="fa-IR"/>
-              <a:t>06/11/1447</a:t>
+              <a:t>07/11/1447</a:t>
             </a:fld>
             <a:endParaRPr/>
           </a:p>
@@ -2479,7 +2479,7 @@
             </a:pPr>
             <a:fld id="{BCC18F51-09EC-435C-A3BA-64A766E099C0}" type="datetimeFigureOut">
               <a:rPr lang="fa-IR"/>
-              <a:t>06/11/1447</a:t>
+              <a:t>07/11/1447</a:t>
             </a:fld>
             <a:endParaRPr/>
           </a:p>
@@ -2701,7 +2701,7 @@
             </a:pPr>
             <a:fld id="{BCC18F51-09EC-435C-A3BA-64A766E099C0}" type="datetimeFigureOut">
               <a:rPr lang="fa-IR"/>
-              <a:t>06/11/1447</a:t>
+              <a:t>07/11/1447</a:t>
             </a:fld>
             <a:endParaRPr/>
           </a:p>
@@ -7639,8 +7639,8 @@
         </p:nvSpPr>
         <p:spPr bwMode="auto">
           <a:xfrm>
-            <a:off x="737837" y="7800331"/>
-            <a:ext cx="2306092" cy="326683"/>
+            <a:off x="1359988" y="7446793"/>
+            <a:ext cx="1331097" cy="1122060"/>
           </a:xfrm>
           <a:prstGeom prst="borderCallout2">
             <a:avLst>
@@ -7689,7 +7689,7 @@
                 <a:ea typeface="Calibri" panose="020F0502020204030204" pitchFamily="34" charset="0"/>
                 <a:cs typeface="Calibri Light" panose="020F0302020204030204" pitchFamily="34" charset="0"/>
               </a:rPr>
-              <a:t>parentTypes</a:t>
+              <a:t>parentTypes:</a:t>
             </a:r>
           </a:p>
           <a:p>
@@ -7705,7 +7705,103 @@
                 <a:ea typeface="Calibri" panose="020F0502020204030204" pitchFamily="34" charset="0"/>
                 <a:cs typeface="Calibri Light" panose="020F0302020204030204" pitchFamily="34" charset="0"/>
               </a:rPr>
-              <a:t>1:U, 2:SP, 3:S, 4:G, 5:C, 6:E, 7:SN</a:t>
+              <a:t> 1: quickNote by T</a:t>
+            </a:r>
+          </a:p>
+          <a:p>
+            <a:pPr rtl="0">
+              <a:buNone/>
+            </a:pPr>
+            <a:r>
+              <a:rPr lang="en-US" sz="853" kern="100">
+                <a:solidFill>
+                  <a:schemeClr val="tx1"/>
+                </a:solidFill>
+                <a:latin typeface="Consolas" panose="020B0609020204030204" pitchFamily="49" charset="0"/>
+                <a:ea typeface="Calibri" panose="020F0502020204030204" pitchFamily="34" charset="0"/>
+                <a:cs typeface="Calibri Light" panose="020F0302020204030204" pitchFamily="34" charset="0"/>
+              </a:rPr>
+              <a:t> 2: section Note</a:t>
+            </a:r>
+          </a:p>
+          <a:p>
+            <a:pPr rtl="0">
+              <a:buNone/>
+            </a:pPr>
+            <a:r>
+              <a:rPr lang="en-US" sz="853" kern="100">
+                <a:solidFill>
+                  <a:schemeClr val="tx1"/>
+                </a:solidFill>
+                <a:latin typeface="Consolas" panose="020B0609020204030204" pitchFamily="49" charset="0"/>
+                <a:ea typeface="Calibri" panose="020F0502020204030204" pitchFamily="34" charset="0"/>
+                <a:cs typeface="Calibri Light" panose="020F0302020204030204" pitchFamily="34" charset="0"/>
+              </a:rPr>
+              <a:t> 3: note on Student</a:t>
+            </a:r>
+          </a:p>
+          <a:p>
+            <a:pPr rtl="0">
+              <a:buNone/>
+            </a:pPr>
+            <a:r>
+              <a:rPr lang="en-US" sz="853" kern="100">
+                <a:solidFill>
+                  <a:schemeClr val="tx1"/>
+                </a:solidFill>
+                <a:latin typeface="Consolas" panose="020B0609020204030204" pitchFamily="49" charset="0"/>
+                <a:ea typeface="Calibri" panose="020F0502020204030204" pitchFamily="34" charset="0"/>
+                <a:cs typeface="Calibri Light" panose="020F0302020204030204" pitchFamily="34" charset="0"/>
+              </a:rPr>
+              <a:t> 4: note on Group</a:t>
+            </a:r>
+          </a:p>
+          <a:p>
+            <a:pPr rtl="0">
+              <a:buNone/>
+            </a:pPr>
+            <a:r>
+              <a:rPr lang="en-US" sz="853" kern="100">
+                <a:solidFill>
+                  <a:schemeClr val="tx1"/>
+                </a:solidFill>
+                <a:latin typeface="Consolas" panose="020B0609020204030204" pitchFamily="49" charset="0"/>
+                <a:ea typeface="Calibri" panose="020F0502020204030204" pitchFamily="34" charset="0"/>
+                <a:cs typeface="Calibri Light" panose="020F0302020204030204" pitchFamily="34" charset="0"/>
+              </a:rPr>
+              <a:t> 5: note on Course</a:t>
+            </a:r>
+          </a:p>
+          <a:p>
+            <a:pPr rtl="0">
+              <a:buNone/>
+            </a:pPr>
+            <a:r>
+              <a:rPr lang="en-US" sz="853" kern="100">
+                <a:solidFill>
+                  <a:schemeClr val="tx1"/>
+                </a:solidFill>
+                <a:latin typeface="Consolas" panose="020B0609020204030204" pitchFamily="49" charset="0"/>
+                <a:ea typeface="Calibri" panose="020F0502020204030204" pitchFamily="34" charset="0"/>
+                <a:cs typeface="Calibri Light" panose="020F0302020204030204" pitchFamily="34" charset="0"/>
+              </a:rPr>
+              <a:t> 6: note on Exam</a:t>
+            </a:r>
+          </a:p>
+          <a:p>
+            <a:pPr rtl="0">
+              <a:buNone/>
+            </a:pPr>
+            <a:r>
+              <a:rPr lang="en-US" sz="853" kern="100">
+                <a:solidFill>
+                  <a:schemeClr val="tx1"/>
+                </a:solidFill>
+                <a:latin typeface="Consolas" panose="020B0609020204030204" pitchFamily="49" charset="0"/>
+                <a:ea typeface="Calibri" panose="020F0502020204030204" pitchFamily="34" charset="0"/>
+                <a:cs typeface="Calibri Light" panose="020F0302020204030204" pitchFamily="34" charset="0"/>
+              </a:rPr>
+              <a:t> 7: quickNote by S</a:t>
             </a:r>
           </a:p>
         </p:txBody>
@@ -7991,8 +8087,8 @@
         </p:nvSpPr>
         <p:spPr bwMode="auto">
           <a:xfrm>
-            <a:off x="3172878" y="7800331"/>
-            <a:ext cx="2891549" cy="355614"/>
+            <a:off x="2735908" y="7920781"/>
+            <a:ext cx="1584176" cy="620356"/>
           </a:xfrm>
           <a:prstGeom prst="borderCallout2">
             <a:avLst>
@@ -8057,19 +8153,48 @@
                 <a:ea typeface="Calibri" panose="020F0502020204030204" pitchFamily="34" charset="0"/>
                 <a:cs typeface="Calibri Light" panose="020F0302020204030204" pitchFamily="34" charset="0"/>
               </a:rPr>
-              <a:t>1:rtl 2:done 4:shared 8:</a:t>
-            </a:r>
+              <a:t> 1:rtl      2:done</a:t>
+            </a:r>
+          </a:p>
+          <a:p>
+            <a:pPr rtl="0">
+              <a:buNone/>
+            </a:pPr>
             <a:r>
               <a:rPr lang="en-US" sz="853" kern="100">
                 <a:solidFill>
-                  <a:srgbClr val="FF0000"/>
+                  <a:schemeClr val="tx1"/>
                 </a:solidFill>
                 <a:latin typeface="Consolas" panose="020B0609020204030204" pitchFamily="49" charset="0"/>
                 <a:ea typeface="Calibri" panose="020F0502020204030204" pitchFamily="34" charset="0"/>
                 <a:cs typeface="Calibri Light" panose="020F0302020204030204" pitchFamily="34" charset="0"/>
               </a:rPr>
+              <a:t> 4:shared   8:</a:t>
+            </a:r>
+            <a:r>
+              <a:rPr lang="en-US" sz="853" kern="100">
+                <a:solidFill>
+                  <a:srgbClr val="FF0000"/>
+                </a:solidFill>
+                <a:latin typeface="Consolas" panose="020B0609020204030204" pitchFamily="49" charset="0"/>
+                <a:ea typeface="Calibri" panose="020F0502020204030204" pitchFamily="34" charset="0"/>
+                <a:cs typeface="Calibri Light" panose="020F0302020204030204" pitchFamily="34" charset="0"/>
+              </a:rPr>
               <a:t>readonly</a:t>
             </a:r>
+            <a:endParaRPr lang="en-US" sz="853" kern="100">
+              <a:solidFill>
+                <a:schemeClr val="tx1"/>
+              </a:solidFill>
+              <a:latin typeface="Consolas" panose="020B0609020204030204" pitchFamily="49" charset="0"/>
+              <a:ea typeface="Calibri" panose="020F0502020204030204" pitchFamily="34" charset="0"/>
+              <a:cs typeface="Calibri Light" panose="020F0302020204030204" pitchFamily="34" charset="0"/>
+            </a:endParaRPr>
+          </a:p>
+          <a:p>
+            <a:pPr rtl="0">
+              <a:buNone/>
+            </a:pPr>
             <a:r>
               <a:rPr lang="en-US" sz="853" kern="100">
                 <a:solidFill>
@@ -8098,8 +8223,8 @@
         </p:nvSpPr>
         <p:spPr bwMode="auto">
           <a:xfrm>
-            <a:off x="171697" y="7182323"/>
-            <a:ext cx="1372612" cy="563993"/>
+            <a:off x="184856" y="7242193"/>
+            <a:ext cx="890894" cy="822604"/>
           </a:xfrm>
           <a:prstGeom prst="borderCallout2">
             <a:avLst>
@@ -8164,7 +8289,7 @@
                 <a:ea typeface="Calibri" panose="020F0502020204030204" pitchFamily="34" charset="0"/>
                 <a:cs typeface="Calibri Light" panose="020F0302020204030204" pitchFamily="34" charset="0"/>
               </a:rPr>
-              <a:t>1:Teacher 2:Student </a:t>
+              <a:t> 1:Teacher</a:t>
             </a:r>
           </a:p>
           <a:p>
@@ -8180,7 +8305,7 @@
                 <a:ea typeface="Calibri" panose="020F0502020204030204" pitchFamily="34" charset="0"/>
                 <a:cs typeface="Calibri Light" panose="020F0302020204030204" pitchFamily="34" charset="0"/>
               </a:rPr>
-              <a:t>ProjectTags</a:t>
+              <a:t> 2:Student</a:t>
             </a:r>
           </a:p>
           <a:p>
@@ -8196,7 +8321,39 @@
                 <a:ea typeface="Calibri" panose="020F0502020204030204" pitchFamily="34" charset="0"/>
                 <a:cs typeface="Calibri Light" panose="020F0302020204030204" pitchFamily="34" charset="0"/>
               </a:rPr>
-              <a:t>1:active</a:t>
+              <a:t> </a:t>
+            </a:r>
+          </a:p>
+          <a:p>
+            <a:pPr rtl="0">
+              <a:buNone/>
+            </a:pPr>
+            <a:r>
+              <a:rPr lang="en-US" sz="853" kern="100">
+                <a:solidFill>
+                  <a:schemeClr val="tx1"/>
+                </a:solidFill>
+                <a:latin typeface="Consolas" panose="020B0609020204030204" pitchFamily="49" charset="0"/>
+                <a:ea typeface="Calibri" panose="020F0502020204030204" pitchFamily="34" charset="0"/>
+                <a:cs typeface="Calibri Light" panose="020F0302020204030204" pitchFamily="34" charset="0"/>
+              </a:rPr>
+              <a:t>ProjectTags</a:t>
+            </a:r>
+          </a:p>
+          <a:p>
+            <a:pPr rtl="0">
+              <a:buNone/>
+            </a:pPr>
+            <a:r>
+              <a:rPr lang="en-US" sz="853" kern="100">
+                <a:solidFill>
+                  <a:schemeClr val="tx1"/>
+                </a:solidFill>
+                <a:latin typeface="Consolas" panose="020B0609020204030204" pitchFamily="49" charset="0"/>
+                <a:ea typeface="Calibri" panose="020F0502020204030204" pitchFamily="34" charset="0"/>
+                <a:cs typeface="Calibri Light" panose="020F0302020204030204" pitchFamily="34" charset="0"/>
+              </a:rPr>
+              <a:t> 1:active</a:t>
             </a:r>
           </a:p>
         </p:txBody>
@@ -21623,6 +21780,49 @@
     </a:fmtScheme>
   </a:themeElements>
   <a:objectDefaults>
+    <a:spDef>
+      <a:spPr bwMode="auto">
+        <a:solidFill>
+          <a:schemeClr val="bg1"/>
+        </a:solidFill>
+        <a:ln w="28575">
+          <a:solidFill>
+            <a:schemeClr val="tx1"/>
+          </a:solidFill>
+          <a:prstDash val="solid"/>
+        </a:ln>
+        <a:effectLst/>
+      </a:spPr>
+      <a:bodyPr rtlCol="1" anchor="ctr"/>
+      <a:lstStyle>
+        <a:defPPr algn="r" rtl="1">
+          <a:defRPr sz="4400" b="1" smtClean="0">
+            <a:solidFill>
+              <a:schemeClr val="bg1"/>
+            </a:solidFill>
+            <a:highlight>
+              <a:srgbClr val="800080"/>
+            </a:highlight>
+            <a:latin typeface="Segoe UI" panose="020B0502040204020203" pitchFamily="34" charset="0"/>
+            <a:cs typeface="Segoe UI" panose="020B0502040204020203" pitchFamily="34" charset="0"/>
+          </a:defRPr>
+        </a:defPPr>
+      </a:lstStyle>
+      <a:style>
+        <a:lnRef idx="0">
+          <a:schemeClr val="accent4"/>
+        </a:lnRef>
+        <a:fillRef idx="3">
+          <a:schemeClr val="accent4"/>
+        </a:fillRef>
+        <a:effectRef idx="3">
+          <a:schemeClr val="accent4"/>
+        </a:effectRef>
+        <a:fontRef idx="minor">
+          <a:schemeClr val="lt1"/>
+        </a:fontRef>
+      </a:style>
+    </a:spDef>
     <a:txDef>
       <a:spPr>
         <a:noFill/>

</xml_diff>

<commit_message>
- persian calendar as settings for users
</commit_message>
<xml_diff>
--- a/ExaminerB/.appCatalog/ExaminerB notes 1404.pptx
+++ b/ExaminerB/.appCatalog/ExaminerB notes 1404.pptx
@@ -280,7 +280,7 @@
             </a:pPr>
             <a:fld id="{BCC18F51-09EC-435C-A3BA-64A766E099C0}" type="datetimeFigureOut">
               <a:rPr lang="fa-IR"/>
-              <a:t>07/11/1447</a:t>
+              <a:t>22/12/1447</a:t>
             </a:fld>
             <a:endParaRPr/>
           </a:p>
@@ -459,7 +459,7 @@
             </a:pPr>
             <a:fld id="{BCC18F51-09EC-435C-A3BA-64A766E099C0}" type="datetimeFigureOut">
               <a:rPr lang="fa-IR"/>
-              <a:t>07/11/1447</a:t>
+              <a:t>22/12/1447</a:t>
             </a:fld>
             <a:endParaRPr/>
           </a:p>
@@ -648,7 +648,7 @@
             </a:pPr>
             <a:fld id="{BCC18F51-09EC-435C-A3BA-64A766E099C0}" type="datetimeFigureOut">
               <a:rPr lang="fa-IR"/>
-              <a:t>07/11/1447</a:t>
+              <a:t>22/12/1447</a:t>
             </a:fld>
             <a:endParaRPr/>
           </a:p>
@@ -827,7 +827,7 @@
             </a:pPr>
             <a:fld id="{BCC18F51-09EC-435C-A3BA-64A766E099C0}" type="datetimeFigureOut">
               <a:rPr lang="fa-IR"/>
-              <a:t>07/11/1447</a:t>
+              <a:t>22/12/1447</a:t>
             </a:fld>
             <a:endParaRPr/>
           </a:p>
@@ -1079,7 +1079,7 @@
             </a:pPr>
             <a:fld id="{BCC18F51-09EC-435C-A3BA-64A766E099C0}" type="datetimeFigureOut">
               <a:rPr lang="fa-IR"/>
-              <a:t>07/11/1447</a:t>
+              <a:t>22/12/1447</a:t>
             </a:fld>
             <a:endParaRPr/>
           </a:p>
@@ -1324,7 +1324,7 @@
             </a:pPr>
             <a:fld id="{BCC18F51-09EC-435C-A3BA-64A766E099C0}" type="datetimeFigureOut">
               <a:rPr lang="fa-IR"/>
-              <a:t>07/11/1447</a:t>
+              <a:t>22/12/1447</a:t>
             </a:fld>
             <a:endParaRPr/>
           </a:p>
@@ -1706,7 +1706,7 @@
             </a:pPr>
             <a:fld id="{BCC18F51-09EC-435C-A3BA-64A766E099C0}" type="datetimeFigureOut">
               <a:rPr lang="fa-IR"/>
-              <a:t>07/11/1447</a:t>
+              <a:t>22/12/1447</a:t>
             </a:fld>
             <a:endParaRPr/>
           </a:p>
@@ -1829,7 +1829,7 @@
             </a:pPr>
             <a:fld id="{BCC18F51-09EC-435C-A3BA-64A766E099C0}" type="datetimeFigureOut">
               <a:rPr lang="fa-IR"/>
-              <a:t>07/11/1447</a:t>
+              <a:t>22/12/1447</a:t>
             </a:fld>
             <a:endParaRPr/>
           </a:p>
@@ -1928,7 +1928,7 @@
             </a:pPr>
             <a:fld id="{BCC18F51-09EC-435C-A3BA-64A766E099C0}" type="datetimeFigureOut">
               <a:rPr lang="fa-IR"/>
-              <a:t>07/11/1447</a:t>
+              <a:t>22/12/1447</a:t>
             </a:fld>
             <a:endParaRPr/>
           </a:p>
@@ -2215,7 +2215,7 @@
             </a:pPr>
             <a:fld id="{BCC18F51-09EC-435C-A3BA-64A766E099C0}" type="datetimeFigureOut">
               <a:rPr lang="fa-IR"/>
-              <a:t>07/11/1447</a:t>
+              <a:t>22/12/1447</a:t>
             </a:fld>
             <a:endParaRPr/>
           </a:p>
@@ -2479,7 +2479,7 @@
             </a:pPr>
             <a:fld id="{BCC18F51-09EC-435C-A3BA-64A766E099C0}" type="datetimeFigureOut">
               <a:rPr lang="fa-IR"/>
-              <a:t>07/11/1447</a:t>
+              <a:t>22/12/1447</a:t>
             </a:fld>
             <a:endParaRPr/>
           </a:p>
@@ -2701,7 +2701,7 @@
             </a:pPr>
             <a:fld id="{BCC18F51-09EC-435C-A3BA-64A766E099C0}" type="datetimeFigureOut">
               <a:rPr lang="fa-IR"/>
-              <a:t>07/11/1447</a:t>
+              <a:t>22/12/1447</a:t>
             </a:fld>
             <a:endParaRPr/>
           </a:p>
@@ -4360,7 +4360,7 @@
         <p:spPr bwMode="auto">
           <a:xfrm>
             <a:off x="3860208" y="2944397"/>
-            <a:ext cx="1855656" cy="2435984"/>
+            <a:ext cx="1855656" cy="2528112"/>
           </a:xfrm>
           <a:prstGeom prst="roundRect">
             <a:avLst>
@@ -4542,48 +4542,138 @@
             </a:r>
           </a:p>
           <a:p>
-            <a:pPr marL="189651" rtl="0">
-              <a:defRPr/>
-            </a:pPr>
-            <a:r>
-              <a:rPr lang="en-US" sz="853">
+            <a:pPr marL="176213" rtl="0">
+              <a:defRPr/>
+            </a:pPr>
+            <a:r>
+              <a:rPr lang="en-US" sz="700">
                 <a:solidFill>
                   <a:srgbClr val="C00000"/>
                 </a:solidFill>
                 <a:latin typeface="Segoe UI" panose="020B0502040204020203" pitchFamily="34" charset="0"/>
                 <a:cs typeface="Segoe UI" panose="020B0502040204020203" pitchFamily="34" charset="0"/>
               </a:rPr>
-              <a:t>1:act 2:pass</a:t>
-            </a:r>
-          </a:p>
-          <a:p>
-            <a:pPr marL="189651" rtl="0">
-              <a:defRPr/>
-            </a:pPr>
-            <a:r>
-              <a:rPr lang="en-US" sz="853">
+              <a:t>1:IsActive</a:t>
+            </a:r>
+          </a:p>
+          <a:p>
+            <a:pPr marL="176213" rtl="0">
+              <a:defRPr/>
+            </a:pPr>
+            <a:r>
+              <a:rPr lang="en-US" sz="700">
                 <a:solidFill>
                   <a:srgbClr val="C00000"/>
                 </a:solidFill>
                 <a:latin typeface="Segoe UI" panose="020B0502040204020203" pitchFamily="34" charset="0"/>
                 <a:cs typeface="Segoe UI" panose="020B0502040204020203" pitchFamily="34" charset="0"/>
               </a:rPr>
-              <a:t>4,8,16,32: x </a:t>
-            </a:r>
-          </a:p>
-          <a:p>
-            <a:pPr marL="189651" rtl="0">
-              <a:defRPr/>
-            </a:pPr>
-            <a:r>
-              <a:rPr lang="en-US" sz="853">
+              <a:t>2:ChangePass</a:t>
+            </a:r>
+          </a:p>
+          <a:p>
+            <a:pPr marL="176213" rtl="0">
+              <a:defRPr/>
+            </a:pPr>
+            <a:r>
+              <a:rPr lang="en-US" sz="700">
                 <a:solidFill>
                   <a:srgbClr val="C00000"/>
                 </a:solidFill>
                 <a:latin typeface="Segoe UI" panose="020B0502040204020203" pitchFamily="34" charset="0"/>
                 <a:cs typeface="Segoe UI" panose="020B0502040204020203" pitchFamily="34" charset="0"/>
               </a:rPr>
-              <a:t>64:selected</a:t>
+              <a:t>4:ReviewEx</a:t>
+            </a:r>
+          </a:p>
+          <a:p>
+            <a:pPr marL="176213" rtl="0">
+              <a:defRPr/>
+            </a:pPr>
+            <a:r>
+              <a:rPr lang="en-US" sz="700">
+                <a:solidFill>
+                  <a:srgbClr val="C00000"/>
+                </a:solidFill>
+                <a:latin typeface="Segoe UI" panose="020B0502040204020203" pitchFamily="34" charset="0"/>
+                <a:cs typeface="Segoe UI" panose="020B0502040204020203" pitchFamily="34" charset="0"/>
+              </a:rPr>
+              <a:t>8:GetStExTests</a:t>
+            </a:r>
+          </a:p>
+          <a:p>
+            <a:pPr marL="176213" rtl="0">
+              <a:defRPr/>
+            </a:pPr>
+            <a:r>
+              <a:rPr lang="en-US" sz="700">
+                <a:solidFill>
+                  <a:srgbClr val="C00000"/>
+                </a:solidFill>
+                <a:latin typeface="Segoe UI" panose="020B0502040204020203" pitchFamily="34" charset="0"/>
+                <a:cs typeface="Segoe UI" panose="020B0502040204020203" pitchFamily="34" charset="0"/>
+              </a:rPr>
+              <a:t>16:CorrectStExTests</a:t>
+            </a:r>
+          </a:p>
+          <a:p>
+            <a:pPr marL="176213" rtl="0">
+              <a:defRPr/>
+            </a:pPr>
+            <a:r>
+              <a:rPr lang="en-US" sz="700">
+                <a:solidFill>
+                  <a:srgbClr val="C00000"/>
+                </a:solidFill>
+                <a:latin typeface="Segoe UI" panose="020B0502040204020203" pitchFamily="34" charset="0"/>
+                <a:cs typeface="Segoe UI" panose="020B0502040204020203" pitchFamily="34" charset="0"/>
+              </a:rPr>
+              <a:t>32:RevStExTests</a:t>
+            </a:r>
+          </a:p>
+          <a:p>
+            <a:pPr marL="176213" rtl="0">
+              <a:defRPr/>
+            </a:pPr>
+            <a:r>
+              <a:rPr lang="en-US" sz="700">
+                <a:solidFill>
+                  <a:srgbClr val="C00000"/>
+                </a:solidFill>
+                <a:latin typeface="Segoe UI" panose="020B0502040204020203" pitchFamily="34" charset="0"/>
+                <a:cs typeface="Segoe UI" panose="020B0502040204020203" pitchFamily="34" charset="0"/>
+              </a:rPr>
+              <a:t>64: IsSelected</a:t>
+            </a:r>
+          </a:p>
+          <a:p>
+            <a:pPr marL="176213" rtl="0">
+              <a:defRPr/>
+            </a:pPr>
+            <a:r>
+              <a:rPr lang="en-US" sz="700">
+                <a:solidFill>
+                  <a:srgbClr val="C00000"/>
+                </a:solidFill>
+                <a:latin typeface="Segoe UI" panose="020B0502040204020203" pitchFamily="34" charset="0"/>
+                <a:cs typeface="Segoe UI" panose="020B0502040204020203" pitchFamily="34" charset="0"/>
+              </a:rPr>
+              <a:t>128:</a:t>
+            </a:r>
+          </a:p>
+          <a:p>
+            <a:pPr marL="176213" rtl="0">
+              <a:defRPr/>
+            </a:pPr>
+            <a:r>
+              <a:rPr lang="en-US" sz="700">
+                <a:solidFill>
+                  <a:srgbClr val="C00000"/>
+                </a:solidFill>
+                <a:latin typeface="Segoe UI" panose="020B0502040204020203" pitchFamily="34" charset="0"/>
+                <a:cs typeface="Segoe UI" panose="020B0502040204020203" pitchFamily="34" charset="0"/>
+              </a:rPr>
+              <a:t>256: CalendarFa</a:t>
             </a:r>
           </a:p>
         </p:txBody>

</xml_diff>

<commit_message>
-inject a message to exam session
</commit_message>
<xml_diff>
--- a/ExaminerB/.appCatalog/ExaminerB notes 1404.pptx
+++ b/ExaminerB/.appCatalog/ExaminerB notes 1404.pptx
@@ -280,7 +280,7 @@
             </a:pPr>
             <a:fld id="{BCC18F51-09EC-435C-A3BA-64A766E099C0}" type="datetimeFigureOut">
               <a:rPr lang="fa-IR"/>
-              <a:t>22/12/1447</a:t>
+              <a:t>06/01/1448</a:t>
             </a:fld>
             <a:endParaRPr/>
           </a:p>
@@ -459,7 +459,7 @@
             </a:pPr>
             <a:fld id="{BCC18F51-09EC-435C-A3BA-64A766E099C0}" type="datetimeFigureOut">
               <a:rPr lang="fa-IR"/>
-              <a:t>22/12/1447</a:t>
+              <a:t>06/01/1448</a:t>
             </a:fld>
             <a:endParaRPr/>
           </a:p>
@@ -648,7 +648,7 @@
             </a:pPr>
             <a:fld id="{BCC18F51-09EC-435C-A3BA-64A766E099C0}" type="datetimeFigureOut">
               <a:rPr lang="fa-IR"/>
-              <a:t>22/12/1447</a:t>
+              <a:t>06/01/1448</a:t>
             </a:fld>
             <a:endParaRPr/>
           </a:p>
@@ -827,7 +827,7 @@
             </a:pPr>
             <a:fld id="{BCC18F51-09EC-435C-A3BA-64A766E099C0}" type="datetimeFigureOut">
               <a:rPr lang="fa-IR"/>
-              <a:t>22/12/1447</a:t>
+              <a:t>06/01/1448</a:t>
             </a:fld>
             <a:endParaRPr/>
           </a:p>
@@ -1079,7 +1079,7 @@
             </a:pPr>
             <a:fld id="{BCC18F51-09EC-435C-A3BA-64A766E099C0}" type="datetimeFigureOut">
               <a:rPr lang="fa-IR"/>
-              <a:t>22/12/1447</a:t>
+              <a:t>06/01/1448</a:t>
             </a:fld>
             <a:endParaRPr/>
           </a:p>
@@ -1324,7 +1324,7 @@
             </a:pPr>
             <a:fld id="{BCC18F51-09EC-435C-A3BA-64A766E099C0}" type="datetimeFigureOut">
               <a:rPr lang="fa-IR"/>
-              <a:t>22/12/1447</a:t>
+              <a:t>06/01/1448</a:t>
             </a:fld>
             <a:endParaRPr/>
           </a:p>
@@ -1706,7 +1706,7 @@
             </a:pPr>
             <a:fld id="{BCC18F51-09EC-435C-A3BA-64A766E099C0}" type="datetimeFigureOut">
               <a:rPr lang="fa-IR"/>
-              <a:t>22/12/1447</a:t>
+              <a:t>06/01/1448</a:t>
             </a:fld>
             <a:endParaRPr/>
           </a:p>
@@ -1829,7 +1829,7 @@
             </a:pPr>
             <a:fld id="{BCC18F51-09EC-435C-A3BA-64A766E099C0}" type="datetimeFigureOut">
               <a:rPr lang="fa-IR"/>
-              <a:t>22/12/1447</a:t>
+              <a:t>06/01/1448</a:t>
             </a:fld>
             <a:endParaRPr/>
           </a:p>
@@ -1928,7 +1928,7 @@
             </a:pPr>
             <a:fld id="{BCC18F51-09EC-435C-A3BA-64A766E099C0}" type="datetimeFigureOut">
               <a:rPr lang="fa-IR"/>
-              <a:t>22/12/1447</a:t>
+              <a:t>06/01/1448</a:t>
             </a:fld>
             <a:endParaRPr/>
           </a:p>
@@ -2215,7 +2215,7 @@
             </a:pPr>
             <a:fld id="{BCC18F51-09EC-435C-A3BA-64A766E099C0}" type="datetimeFigureOut">
               <a:rPr lang="fa-IR"/>
-              <a:t>22/12/1447</a:t>
+              <a:t>06/01/1448</a:t>
             </a:fld>
             <a:endParaRPr/>
           </a:p>
@@ -2479,7 +2479,7 @@
             </a:pPr>
             <a:fld id="{BCC18F51-09EC-435C-A3BA-64A766E099C0}" type="datetimeFigureOut">
               <a:rPr lang="fa-IR"/>
-              <a:t>22/12/1447</a:t>
+              <a:t>06/01/1448</a:t>
             </a:fld>
             <a:endParaRPr/>
           </a:p>
@@ -2701,7 +2701,7 @@
             </a:pPr>
             <a:fld id="{BCC18F51-09EC-435C-A3BA-64A766E099C0}" type="datetimeFigureOut">
               <a:rPr lang="fa-IR"/>
-              <a:t>22/12/1447</a:t>
+              <a:t>06/01/1448</a:t>
             </a:fld>
             <a:endParaRPr/>
           </a:p>
@@ -7729,8 +7729,8 @@
         </p:nvSpPr>
         <p:spPr bwMode="auto">
           <a:xfrm>
-            <a:off x="1359988" y="7446793"/>
-            <a:ext cx="1331097" cy="1122060"/>
+            <a:off x="1007716" y="7332621"/>
+            <a:ext cx="1683369" cy="1236232"/>
           </a:xfrm>
           <a:prstGeom prst="borderCallout2">
             <a:avLst>
@@ -7892,6 +7892,22 @@
                 <a:cs typeface="Calibri Light" panose="020F0302020204030204" pitchFamily="34" charset="0"/>
               </a:rPr>
               <a:t> 7: quickNote by S</a:t>
+            </a:r>
+          </a:p>
+          <a:p>
+            <a:pPr rtl="0">
+              <a:buNone/>
+            </a:pPr>
+            <a:r>
+              <a:rPr lang="en-US" sz="853" kern="100">
+                <a:solidFill>
+                  <a:schemeClr val="tx1"/>
+                </a:solidFill>
+                <a:latin typeface="Consolas" panose="020B0609020204030204" pitchFamily="49" charset="0"/>
+                <a:ea typeface="Calibri" panose="020F0502020204030204" pitchFamily="34" charset="0"/>
+                <a:cs typeface="Calibri Light" panose="020F0302020204030204" pitchFamily="34" charset="0"/>
+              </a:rPr>
+              <a:t> 8: note on Examstudents</a:t>
             </a:r>
           </a:p>
         </p:txBody>
@@ -8313,8 +8329,8 @@
         </p:nvSpPr>
         <p:spPr bwMode="auto">
           <a:xfrm>
-            <a:off x="184856" y="7242193"/>
-            <a:ext cx="890894" cy="822604"/>
+            <a:off x="77984" y="7242193"/>
+            <a:ext cx="861549" cy="822604"/>
           </a:xfrm>
           <a:prstGeom prst="borderCallout2">
             <a:avLst>

</xml_diff>

<commit_message>
- Just before Starting to Unify StudentAccounts
</commit_message>
<xml_diff>
--- a/ExaminerB/.appCatalog/ExaminerB notes 1404.pptx
+++ b/ExaminerB/.appCatalog/ExaminerB notes 1404.pptx
@@ -280,7 +280,7 @@
             </a:pPr>
             <a:fld id="{BCC18F51-09EC-435C-A3BA-64A766E099C0}" type="datetimeFigureOut">
               <a:rPr lang="fa-IR"/>
-              <a:t>06/01/1448</a:t>
+              <a:t>11/01/1448</a:t>
             </a:fld>
             <a:endParaRPr/>
           </a:p>
@@ -459,7 +459,7 @@
             </a:pPr>
             <a:fld id="{BCC18F51-09EC-435C-A3BA-64A766E099C0}" type="datetimeFigureOut">
               <a:rPr lang="fa-IR"/>
-              <a:t>06/01/1448</a:t>
+              <a:t>11/01/1448</a:t>
             </a:fld>
             <a:endParaRPr/>
           </a:p>
@@ -648,7 +648,7 @@
             </a:pPr>
             <a:fld id="{BCC18F51-09EC-435C-A3BA-64A766E099C0}" type="datetimeFigureOut">
               <a:rPr lang="fa-IR"/>
-              <a:t>06/01/1448</a:t>
+              <a:t>11/01/1448</a:t>
             </a:fld>
             <a:endParaRPr/>
           </a:p>
@@ -827,7 +827,7 @@
             </a:pPr>
             <a:fld id="{BCC18F51-09EC-435C-A3BA-64A766E099C0}" type="datetimeFigureOut">
               <a:rPr lang="fa-IR"/>
-              <a:t>06/01/1448</a:t>
+              <a:t>11/01/1448</a:t>
             </a:fld>
             <a:endParaRPr/>
           </a:p>
@@ -1079,7 +1079,7 @@
             </a:pPr>
             <a:fld id="{BCC18F51-09EC-435C-A3BA-64A766E099C0}" type="datetimeFigureOut">
               <a:rPr lang="fa-IR"/>
-              <a:t>06/01/1448</a:t>
+              <a:t>11/01/1448</a:t>
             </a:fld>
             <a:endParaRPr/>
           </a:p>
@@ -1324,7 +1324,7 @@
             </a:pPr>
             <a:fld id="{BCC18F51-09EC-435C-A3BA-64A766E099C0}" type="datetimeFigureOut">
               <a:rPr lang="fa-IR"/>
-              <a:t>06/01/1448</a:t>
+              <a:t>11/01/1448</a:t>
             </a:fld>
             <a:endParaRPr/>
           </a:p>
@@ -1706,7 +1706,7 @@
             </a:pPr>
             <a:fld id="{BCC18F51-09EC-435C-A3BA-64A766E099C0}" type="datetimeFigureOut">
               <a:rPr lang="fa-IR"/>
-              <a:t>06/01/1448</a:t>
+              <a:t>11/01/1448</a:t>
             </a:fld>
             <a:endParaRPr/>
           </a:p>
@@ -1829,7 +1829,7 @@
             </a:pPr>
             <a:fld id="{BCC18F51-09EC-435C-A3BA-64A766E099C0}" type="datetimeFigureOut">
               <a:rPr lang="fa-IR"/>
-              <a:t>06/01/1448</a:t>
+              <a:t>11/01/1448</a:t>
             </a:fld>
             <a:endParaRPr/>
           </a:p>
@@ -1928,7 +1928,7 @@
             </a:pPr>
             <a:fld id="{BCC18F51-09EC-435C-A3BA-64A766E099C0}" type="datetimeFigureOut">
               <a:rPr lang="fa-IR"/>
-              <a:t>06/01/1448</a:t>
+              <a:t>11/01/1448</a:t>
             </a:fld>
             <a:endParaRPr/>
           </a:p>
@@ -2215,7 +2215,7 @@
             </a:pPr>
             <a:fld id="{BCC18F51-09EC-435C-A3BA-64A766E099C0}" type="datetimeFigureOut">
               <a:rPr lang="fa-IR"/>
-              <a:t>06/01/1448</a:t>
+              <a:t>11/01/1448</a:t>
             </a:fld>
             <a:endParaRPr/>
           </a:p>
@@ -2479,7 +2479,7 @@
             </a:pPr>
             <a:fld id="{BCC18F51-09EC-435C-A3BA-64A766E099C0}" type="datetimeFigureOut">
               <a:rPr lang="fa-IR"/>
-              <a:t>06/01/1448</a:t>
+              <a:t>11/01/1448</a:t>
             </a:fld>
             <a:endParaRPr/>
           </a:p>
@@ -2701,7 +2701,7 @@
             </a:pPr>
             <a:fld id="{BCC18F51-09EC-435C-A3BA-64A766E099C0}" type="datetimeFigureOut">
               <a:rPr lang="fa-IR"/>
-              <a:t>06/01/1448</a:t>
+              <a:t>11/01/1448</a:t>
             </a:fld>
             <a:endParaRPr/>
           </a:p>
@@ -3219,6 +3219,9 @@
                 <a:solidFill>
                   <a:schemeClr val="tx1"/>
                 </a:solidFill>
+                <a:highlight>
+                  <a:srgbClr val="FFFF00"/>
+                </a:highlight>
                 <a:latin typeface="Segoe UI" panose="020B0502040204020203" pitchFamily="34" charset="0"/>
                 <a:cs typeface="Segoe UI" panose="020B0502040204020203" pitchFamily="34" charset="0"/>
               </a:rPr>
@@ -5119,6 +5122,9 @@
                 <a:solidFill>
                   <a:schemeClr val="tx1"/>
                 </a:solidFill>
+                <a:highlight>
+                  <a:srgbClr val="FFFF00"/>
+                </a:highlight>
                 <a:latin typeface="Segoe UI" panose="020B0502040204020203" pitchFamily="34" charset="0"/>
                 <a:cs typeface="Segoe UI" panose="020B0502040204020203" pitchFamily="34" charset="0"/>
               </a:rPr>
@@ -6045,6 +6051,9 @@
                 <a:solidFill>
                   <a:schemeClr val="tx1"/>
                 </a:solidFill>
+                <a:highlight>
+                  <a:srgbClr val="FFFF00"/>
+                </a:highlight>
                 <a:latin typeface="Segoe UI" panose="020B0502040204020203" pitchFamily="34" charset="0"/>
                 <a:cs typeface="Segoe UI" panose="020B0502040204020203" pitchFamily="34" charset="0"/>
               </a:rPr>
@@ -6289,6 +6298,9 @@
                 <a:solidFill>
                   <a:schemeClr val="tx1"/>
                 </a:solidFill>
+                <a:highlight>
+                  <a:srgbClr val="FFFF00"/>
+                </a:highlight>
                 <a:latin typeface="Segoe UI" panose="020B0502040204020203" pitchFamily="34" charset="0"/>
                 <a:cs typeface="Segoe UI" panose="020B0502040204020203" pitchFamily="34" charset="0"/>
               </a:rPr>
@@ -7493,7 +7505,7 @@
         <p:spPr>
           <a:xfrm>
             <a:off x="2735908" y="6631447"/>
-            <a:ext cx="895415" cy="1128061"/>
+            <a:ext cx="895415" cy="1236232"/>
           </a:xfrm>
           <a:prstGeom prst="roundRect">
             <a:avLst>
@@ -7600,9 +7612,20 @@
               </a:rPr>
               <a:t>NoteTags</a:t>
             </a:r>
+          </a:p>
+          <a:p>
+            <a:pPr rtl="0"/>
+            <a:r>
+              <a:rPr lang="en-US" sz="853">
+                <a:solidFill>
+                  <a:schemeClr val="tx1"/>
+                </a:solidFill>
+              </a:rPr>
+              <a:t>CreatorId</a:t>
+            </a:r>
             <a:endParaRPr lang="fa-IR" sz="853" dirty="0">
               <a:solidFill>
-                <a:srgbClr val="C00000"/>
+                <a:schemeClr val="tx1"/>
               </a:solidFill>
             </a:endParaRPr>
           </a:p>
@@ -8026,6 +8049,9 @@
                 <a:solidFill>
                   <a:schemeClr val="tx1"/>
                 </a:solidFill>
+                <a:highlight>
+                  <a:srgbClr val="FFFF00"/>
+                </a:highlight>
                 <a:latin typeface="Segoe UI" panose="020B0502040204020203" pitchFamily="34" charset="0"/>
                 <a:cs typeface="Segoe UI" panose="020B0502040204020203" pitchFamily="34" charset="0"/>
               </a:rPr>
@@ -8041,6 +8067,9 @@
                 <a:solidFill>
                   <a:schemeClr val="tx1"/>
                 </a:solidFill>
+                <a:highlight>
+                  <a:srgbClr val="FFFF00"/>
+                </a:highlight>
                 <a:latin typeface="Segoe UI" panose="020B0502040204020203" pitchFamily="34" charset="0"/>
                 <a:cs typeface="Segoe UI" panose="020B0502040204020203" pitchFamily="34" charset="0"/>
               </a:rPr>
@@ -8592,6 +8621,9 @@
                 <a:solidFill>
                   <a:schemeClr val="tx1"/>
                 </a:solidFill>
+                <a:highlight>
+                  <a:srgbClr val="FFFF00"/>
+                </a:highlight>
                 <a:latin typeface="Segoe UI" panose="020B0502040204020203" pitchFamily="34" charset="0"/>
                 <a:cs typeface="Segoe UI" panose="020B0502040204020203" pitchFamily="34" charset="0"/>
               </a:rPr>
@@ -8758,6 +8790,9 @@
                 <a:solidFill>
                   <a:schemeClr val="tx1"/>
                 </a:solidFill>
+                <a:highlight>
+                  <a:srgbClr val="FFFF00"/>
+                </a:highlight>
                 <a:latin typeface="Segoe UI" panose="020B0502040204020203" pitchFamily="34" charset="0"/>
                 <a:cs typeface="Segoe UI" panose="020B0502040204020203" pitchFamily="34" charset="0"/>
               </a:rPr>

</xml_diff>

<commit_message>
- im moving TSQL codes from BE to _sp(s) of DB
</commit_message>
<xml_diff>
--- a/ExaminerB/.appCatalog/ExaminerB notes 1404.pptx
+++ b/ExaminerB/.appCatalog/ExaminerB notes 1404.pptx
@@ -3219,9 +3219,6 @@
                 <a:solidFill>
                   <a:schemeClr val="tx1"/>
                 </a:solidFill>
-                <a:highlight>
-                  <a:srgbClr val="FFFF00"/>
-                </a:highlight>
                 <a:latin typeface="Segoe UI" panose="020B0502040204020203" pitchFamily="34" charset="0"/>
                 <a:cs typeface="Segoe UI" panose="020B0502040204020203" pitchFamily="34" charset="0"/>
               </a:rPr>
@@ -4363,7 +4360,7 @@
         <p:spPr bwMode="auto">
           <a:xfrm>
             <a:off x="3860208" y="2944397"/>
-            <a:ext cx="1855656" cy="2528112"/>
+            <a:ext cx="1855656" cy="2144040"/>
           </a:xfrm>
           <a:prstGeom prst="roundRect">
             <a:avLst>
@@ -4458,21 +4455,6 @@
               <a:latin typeface="Segoe UI" panose="020B0502040204020203" pitchFamily="34" charset="0"/>
               <a:cs typeface="Segoe UI" panose="020B0502040204020203" pitchFamily="34" charset="0"/>
             </a:endParaRPr>
-          </a:p>
-          <a:p>
-            <a:pPr marL="189651" rtl="0">
-              <a:defRPr/>
-            </a:pPr>
-            <a:r>
-              <a:rPr lang="en-US" sz="853">
-                <a:solidFill>
-                  <a:schemeClr val="tx1"/>
-                </a:solidFill>
-                <a:latin typeface="Segoe UI" panose="020B0502040204020203" pitchFamily="34" charset="0"/>
-                <a:cs typeface="Segoe UI" panose="020B0502040204020203" pitchFamily="34" charset="0"/>
-              </a:rPr>
-              <a:t>TeacherId</a:t>
-            </a:r>
           </a:p>
           <a:p>
             <a:pPr marL="189651" rtl="0">
@@ -5122,9 +5104,6 @@
                 <a:solidFill>
                   <a:schemeClr val="tx1"/>
                 </a:solidFill>
-                <a:highlight>
-                  <a:srgbClr val="FFFF00"/>
-                </a:highlight>
                 <a:latin typeface="Segoe UI" panose="020B0502040204020203" pitchFamily="34" charset="0"/>
                 <a:cs typeface="Segoe UI" panose="020B0502040204020203" pitchFamily="34" charset="0"/>
               </a:rPr>
@@ -6051,9 +6030,6 @@
                 <a:solidFill>
                   <a:schemeClr val="tx1"/>
                 </a:solidFill>
-                <a:highlight>
-                  <a:srgbClr val="FFFF00"/>
-                </a:highlight>
                 <a:latin typeface="Segoe UI" panose="020B0502040204020203" pitchFamily="34" charset="0"/>
                 <a:cs typeface="Segoe UI" panose="020B0502040204020203" pitchFamily="34" charset="0"/>
               </a:rPr>
@@ -6298,9 +6274,6 @@
                 <a:solidFill>
                   <a:schemeClr val="tx1"/>
                 </a:solidFill>
-                <a:highlight>
-                  <a:srgbClr val="FFFF00"/>
-                </a:highlight>
                 <a:latin typeface="Segoe UI" panose="020B0502040204020203" pitchFamily="34" charset="0"/>
                 <a:cs typeface="Segoe UI" panose="020B0502040204020203" pitchFamily="34" charset="0"/>
               </a:rPr>
@@ -7620,6 +7593,9 @@
                 <a:solidFill>
                   <a:schemeClr val="tx1"/>
                 </a:solidFill>
+                <a:highlight>
+                  <a:srgbClr val="FFFF00"/>
+                </a:highlight>
               </a:rPr>
               <a:t>CreatorId</a:t>
             </a:r>
@@ -7627,6 +7603,9 @@
               <a:solidFill>
                 <a:schemeClr val="tx1"/>
               </a:solidFill>
+              <a:highlight>
+                <a:srgbClr val="FFFF00"/>
+              </a:highlight>
             </a:endParaRPr>
           </a:p>
         </p:txBody>
@@ -8049,9 +8028,6 @@
                 <a:solidFill>
                   <a:schemeClr val="tx1"/>
                 </a:solidFill>
-                <a:highlight>
-                  <a:srgbClr val="FFFF00"/>
-                </a:highlight>
                 <a:latin typeface="Segoe UI" panose="020B0502040204020203" pitchFamily="34" charset="0"/>
                 <a:cs typeface="Segoe UI" panose="020B0502040204020203" pitchFamily="34" charset="0"/>
               </a:rPr>
@@ -8067,9 +8043,6 @@
                 <a:solidFill>
                   <a:schemeClr val="tx1"/>
                 </a:solidFill>
-                <a:highlight>
-                  <a:srgbClr val="FFFF00"/>
-                </a:highlight>
                 <a:latin typeface="Segoe UI" panose="020B0502040204020203" pitchFamily="34" charset="0"/>
                 <a:cs typeface="Segoe UI" panose="020B0502040204020203" pitchFamily="34" charset="0"/>
               </a:rPr>
@@ -8621,9 +8594,6 @@
                 <a:solidFill>
                   <a:schemeClr val="tx1"/>
                 </a:solidFill>
-                <a:highlight>
-                  <a:srgbClr val="FFFF00"/>
-                </a:highlight>
                 <a:latin typeface="Segoe UI" panose="020B0502040204020203" pitchFamily="34" charset="0"/>
                 <a:cs typeface="Segoe UI" panose="020B0502040204020203" pitchFamily="34" charset="0"/>
               </a:rPr>
@@ -8790,9 +8760,6 @@
                 <a:solidFill>
                   <a:schemeClr val="tx1"/>
                 </a:solidFill>
-                <a:highlight>
-                  <a:srgbClr val="FFFF00"/>
-                </a:highlight>
                 <a:latin typeface="Segoe UI" panose="020B0502040204020203" pitchFamily="34" charset="0"/>
                 <a:cs typeface="Segoe UI" panose="020B0502040204020203" pitchFamily="34" charset="0"/>
               </a:rPr>

</xml_diff>

<commit_message>
=namy changes made for:  notes reference types and ids
</commit_message>
<xml_diff>
--- a/ExaminerB/.appCatalog/ExaminerB notes 1404.pptx
+++ b/ExaminerB/.appCatalog/ExaminerB notes 1404.pptx
@@ -280,7 +280,7 @@
             </a:pPr>
             <a:fld id="{BCC18F51-09EC-435C-A3BA-64A766E099C0}" type="datetimeFigureOut">
               <a:rPr lang="fa-IR"/>
-              <a:t>11/01/1448</a:t>
+              <a:t>14/01/1448</a:t>
             </a:fld>
             <a:endParaRPr/>
           </a:p>
@@ -459,7 +459,7 @@
             </a:pPr>
             <a:fld id="{BCC18F51-09EC-435C-A3BA-64A766E099C0}" type="datetimeFigureOut">
               <a:rPr lang="fa-IR"/>
-              <a:t>11/01/1448</a:t>
+              <a:t>14/01/1448</a:t>
             </a:fld>
             <a:endParaRPr/>
           </a:p>
@@ -648,7 +648,7 @@
             </a:pPr>
             <a:fld id="{BCC18F51-09EC-435C-A3BA-64A766E099C0}" type="datetimeFigureOut">
               <a:rPr lang="fa-IR"/>
-              <a:t>11/01/1448</a:t>
+              <a:t>14/01/1448</a:t>
             </a:fld>
             <a:endParaRPr/>
           </a:p>
@@ -827,7 +827,7 @@
             </a:pPr>
             <a:fld id="{BCC18F51-09EC-435C-A3BA-64A766E099C0}" type="datetimeFigureOut">
               <a:rPr lang="fa-IR"/>
-              <a:t>11/01/1448</a:t>
+              <a:t>14/01/1448</a:t>
             </a:fld>
             <a:endParaRPr/>
           </a:p>
@@ -1079,7 +1079,7 @@
             </a:pPr>
             <a:fld id="{BCC18F51-09EC-435C-A3BA-64A766E099C0}" type="datetimeFigureOut">
               <a:rPr lang="fa-IR"/>
-              <a:t>11/01/1448</a:t>
+              <a:t>14/01/1448</a:t>
             </a:fld>
             <a:endParaRPr/>
           </a:p>
@@ -1324,7 +1324,7 @@
             </a:pPr>
             <a:fld id="{BCC18F51-09EC-435C-A3BA-64A766E099C0}" type="datetimeFigureOut">
               <a:rPr lang="fa-IR"/>
-              <a:t>11/01/1448</a:t>
+              <a:t>14/01/1448</a:t>
             </a:fld>
             <a:endParaRPr/>
           </a:p>
@@ -1706,7 +1706,7 @@
             </a:pPr>
             <a:fld id="{BCC18F51-09EC-435C-A3BA-64A766E099C0}" type="datetimeFigureOut">
               <a:rPr lang="fa-IR"/>
-              <a:t>11/01/1448</a:t>
+              <a:t>14/01/1448</a:t>
             </a:fld>
             <a:endParaRPr/>
           </a:p>
@@ -1829,7 +1829,7 @@
             </a:pPr>
             <a:fld id="{BCC18F51-09EC-435C-A3BA-64A766E099C0}" type="datetimeFigureOut">
               <a:rPr lang="fa-IR"/>
-              <a:t>11/01/1448</a:t>
+              <a:t>14/01/1448</a:t>
             </a:fld>
             <a:endParaRPr/>
           </a:p>
@@ -1928,7 +1928,7 @@
             </a:pPr>
             <a:fld id="{BCC18F51-09EC-435C-A3BA-64A766E099C0}" type="datetimeFigureOut">
               <a:rPr lang="fa-IR"/>
-              <a:t>11/01/1448</a:t>
+              <a:t>14/01/1448</a:t>
             </a:fld>
             <a:endParaRPr/>
           </a:p>
@@ -2215,7 +2215,7 @@
             </a:pPr>
             <a:fld id="{BCC18F51-09EC-435C-A3BA-64A766E099C0}" type="datetimeFigureOut">
               <a:rPr lang="fa-IR"/>
-              <a:t>11/01/1448</a:t>
+              <a:t>14/01/1448</a:t>
             </a:fld>
             <a:endParaRPr/>
           </a:p>
@@ -2479,7 +2479,7 @@
             </a:pPr>
             <a:fld id="{BCC18F51-09EC-435C-A3BA-64A766E099C0}" type="datetimeFigureOut">
               <a:rPr lang="fa-IR"/>
-              <a:t>11/01/1448</a:t>
+              <a:t>14/01/1448</a:t>
             </a:fld>
             <a:endParaRPr/>
           </a:p>
@@ -2701,7 +2701,7 @@
             </a:pPr>
             <a:fld id="{BCC18F51-09EC-435C-A3BA-64A766E099C0}" type="datetimeFigureOut">
               <a:rPr lang="fa-IR"/>
-              <a:t>11/01/1448</a:t>
+              <a:t>14/01/1448</a:t>
             </a:fld>
             <a:endParaRPr/>
           </a:p>
@@ -3274,17 +3274,7 @@
                 <a:latin typeface="Segoe UI" panose="020B0502040204020203" pitchFamily="34" charset="0"/>
                 <a:cs typeface="Segoe UI" panose="020B0502040204020203" pitchFamily="34" charset="0"/>
               </a:rPr>
-              <a:t>StudentMessage</a:t>
-            </a:r>
-            <a:r>
-              <a:rPr lang="en-US" sz="853">
-                <a:solidFill>
-                  <a:srgbClr val="C00000"/>
-                </a:solidFill>
-                <a:latin typeface="Segoe UI" panose="020B0502040204020203" pitchFamily="34" charset="0"/>
-                <a:cs typeface="Segoe UI" panose="020B0502040204020203" pitchFamily="34" charset="0"/>
-              </a:rPr>
-              <a:t>Tags</a:t>
+              <a:t>StudentMessageTags</a:t>
             </a:r>
           </a:p>
           <a:p>
@@ -3292,7 +3282,7 @@
               <a:buNone/>
             </a:pPr>
             <a:r>
-              <a:rPr lang="en-US" sz="853" kern="100">
+              <a:rPr lang="en-US" sz="500" kern="100">
                 <a:solidFill>
                   <a:srgbClr val="C00000"/>
                 </a:solidFill>
@@ -3308,7 +3298,7 @@
               <a:buNone/>
             </a:pPr>
             <a:r>
-              <a:rPr lang="en-US" sz="853" kern="100">
+              <a:rPr lang="en-US" sz="500" kern="100">
                 <a:solidFill>
                   <a:srgbClr val="C00000"/>
                 </a:solidFill>
@@ -3324,7 +3314,7 @@
               <a:buNone/>
             </a:pPr>
             <a:r>
-              <a:rPr lang="en-US" sz="853" kern="100">
+              <a:rPr lang="en-US" sz="500" kern="100">
                 <a:solidFill>
                   <a:srgbClr val="C00000"/>
                 </a:solidFill>
@@ -3338,7 +3328,7 @@
           <a:p>
             <a:pPr rtl="0"/>
             <a:r>
-              <a:rPr lang="en-US" sz="853" kern="100">
+              <a:rPr lang="en-US" sz="500" kern="100">
                 <a:solidFill>
                   <a:srgbClr val="C00000"/>
                 </a:solidFill>
@@ -3354,7 +3344,7 @@
               <a:buNone/>
             </a:pPr>
             <a:r>
-              <a:rPr lang="en-US" sz="853" kern="100">
+              <a:rPr lang="en-US" sz="500" kern="100">
                 <a:solidFill>
                   <a:srgbClr val="C00000"/>
                 </a:solidFill>
@@ -3370,7 +3360,7 @@
               <a:buNone/>
             </a:pPr>
             <a:r>
-              <a:rPr lang="en-US" sz="853" kern="100">
+              <a:rPr lang="en-US" sz="500" kern="100">
                 <a:solidFill>
                   <a:srgbClr val="C00000"/>
                 </a:solidFill>
@@ -3405,7 +3395,7 @@
         </p:blipFill>
         <p:spPr>
           <a:xfrm>
-            <a:off x="9862126" y="8018081"/>
+            <a:off x="10368756" y="8280821"/>
             <a:ext cx="1037872" cy="236733"/>
           </a:xfrm>
           <a:prstGeom prst="rect">
@@ -3440,7 +3430,7 @@
         <p:spPr bwMode="auto">
           <a:xfrm>
             <a:off x="9107253" y="359941"/>
-            <a:ext cx="1261503" cy="1196534"/>
+            <a:ext cx="1261503" cy="1338752"/>
           </a:xfrm>
           <a:prstGeom prst="roundRect">
             <a:avLst>
@@ -3586,7 +3576,7 @@
                 <a:latin typeface="Segoe UI" panose="020B0502040204020203" pitchFamily="34" charset="0"/>
                 <a:cs typeface="Segoe UI" panose="020B0502040204020203" pitchFamily="34" charset="0"/>
               </a:rPr>
-              <a:t>Usr</a:t>
+              <a:t>UsrTags</a:t>
             </a:r>
             <a:r>
               <a:rPr lang="en-US" sz="853">
@@ -3596,8 +3586,35 @@
                 <a:latin typeface="Segoe UI" panose="020B0502040204020203" pitchFamily="34" charset="0"/>
                 <a:cs typeface="Segoe UI" panose="020B0502040204020203" pitchFamily="34" charset="0"/>
               </a:rPr>
-              <a:t>Tags  1: active</a:t>
-            </a:r>
+              <a:t> </a:t>
+            </a:r>
+          </a:p>
+          <a:p>
+            <a:pPr rtl="0">
+              <a:defRPr/>
+            </a:pPr>
+            <a:r>
+              <a:rPr lang="en-US" sz="500">
+                <a:solidFill>
+                  <a:srgbClr val="C00000"/>
+                </a:solidFill>
+                <a:latin typeface="Segoe UI" panose="020B0502040204020203" pitchFamily="34" charset="0"/>
+                <a:cs typeface="Segoe UI" panose="020B0502040204020203" pitchFamily="34" charset="0"/>
+              </a:rPr>
+              <a:t>1: active</a:t>
+            </a:r>
+          </a:p>
+          <a:p>
+            <a:pPr rtl="0">
+              <a:defRPr/>
+            </a:pPr>
+            <a:endParaRPr lang="en-US" sz="500">
+              <a:solidFill>
+                <a:srgbClr val="C00000"/>
+              </a:solidFill>
+              <a:latin typeface="Segoe UI" panose="020B0502040204020203" pitchFamily="34" charset="0"/>
+              <a:cs typeface="Segoe UI" panose="020B0502040204020203" pitchFamily="34" charset="0"/>
+            </a:endParaRPr>
           </a:p>
         </p:txBody>
       </p:sp>
@@ -3615,8 +3632,8 @@
         </p:nvSpPr>
         <p:spPr bwMode="auto">
           <a:xfrm>
-            <a:off x="4371117" y="645939"/>
-            <a:ext cx="1824374" cy="1308924"/>
+            <a:off x="4511934" y="894865"/>
+            <a:ext cx="1824374" cy="1059998"/>
           </a:xfrm>
           <a:prstGeom prst="roundRect">
             <a:avLst>
@@ -3942,39 +3959,43 @@
                 <a:latin typeface="Segoe UI" panose="020B0502040204020203" pitchFamily="34" charset="0"/>
                 <a:cs typeface="Segoe UI" panose="020B0502040204020203" pitchFamily="34" charset="0"/>
               </a:rPr>
-              <a:t>Test</a:t>
-            </a:r>
-            <a:r>
-              <a:rPr lang="en-US" sz="853">
+              <a:t>TestTags</a:t>
+            </a:r>
+          </a:p>
+          <a:p>
+            <a:pPr marL="189651" rtl="0"/>
+            <a:r>
+              <a:rPr lang="en-US" sz="500" kern="100">
                 <a:solidFill>
                   <a:srgbClr val="C00000"/>
-                </a:solidFill>
-                <a:latin typeface="Segoe UI" panose="020B0502040204020203" pitchFamily="34" charset="0"/>
-                <a:cs typeface="Segoe UI" panose="020B0502040204020203" pitchFamily="34" charset="0"/>
-              </a:rPr>
-              <a:t>Tags (</a:t>
-            </a:r>
-            <a:r>
-              <a:rPr lang="en-US" sz="853" kern="100">
-                <a:solidFill>
-                  <a:schemeClr val="tx1"/>
                 </a:solidFill>
                 <a:latin typeface="Consolas" panose="020B0609020204030204" pitchFamily="49" charset="0"/>
                 <a:ea typeface="Calibri" panose="020F0502020204030204" pitchFamily="34" charset="0"/>
                 <a:cs typeface="Calibri Light" panose="020F0302020204030204" pitchFamily="34" charset="0"/>
               </a:rPr>
-              <a:t>testRtl, optRtl</a:t>
-            </a:r>
-            <a:r>
-              <a:rPr lang="en-US" sz="853">
+              <a:t> testRtl</a:t>
+            </a:r>
+          </a:p>
+          <a:p>
+            <a:pPr marL="189651" rtl="0"/>
+            <a:r>
+              <a:rPr lang="en-US" sz="500" kern="100">
                 <a:solidFill>
                   <a:srgbClr val="C00000"/>
                 </a:solidFill>
-                <a:latin typeface="Segoe UI" panose="020B0502040204020203" pitchFamily="34" charset="0"/>
-                <a:cs typeface="Segoe UI" panose="020B0502040204020203" pitchFamily="34" charset="0"/>
-              </a:rPr>
-              <a:t>)</a:t>
-            </a:r>
+                <a:latin typeface="Consolas" panose="020B0609020204030204" pitchFamily="49" charset="0"/>
+                <a:ea typeface="Calibri" panose="020F0502020204030204" pitchFamily="34" charset="0"/>
+                <a:cs typeface="Calibri Light" panose="020F0302020204030204" pitchFamily="34" charset="0"/>
+              </a:rPr>
+              <a:t> optRtl</a:t>
+            </a:r>
+            <a:endParaRPr lang="en-US" sz="500">
+              <a:solidFill>
+                <a:srgbClr val="C00000"/>
+              </a:solidFill>
+              <a:latin typeface="Segoe UI" panose="020B0502040204020203" pitchFamily="34" charset="0"/>
+              <a:cs typeface="Segoe UI" panose="020B0502040204020203" pitchFamily="34" charset="0"/>
+            </a:endParaRPr>
           </a:p>
         </p:txBody>
       </p:sp>
@@ -4125,7 +4146,7 @@
                 <a:latin typeface="Segoe UI" panose="020B0502040204020203" pitchFamily="34" charset="0"/>
                 <a:cs typeface="Segoe UI" panose="020B0502040204020203" pitchFamily="34" charset="0"/>
               </a:rPr>
-              <a:t>TestOption</a:t>
+              <a:t>TestOptionTags</a:t>
             </a:r>
             <a:r>
               <a:rPr lang="en-US" sz="853">
@@ -4135,13 +4156,13 @@
                 <a:latin typeface="Segoe UI" panose="020B0502040204020203" pitchFamily="34" charset="0"/>
                 <a:cs typeface="Segoe UI" panose="020B0502040204020203" pitchFamily="34" charset="0"/>
               </a:rPr>
-              <a:t>Tags </a:t>
+              <a:t> </a:t>
             </a:r>
           </a:p>
           <a:p>
             <a:pPr rtl="0"/>
             <a:r>
-              <a:rPr lang="en-US" sz="853" kern="100">
+              <a:rPr lang="en-US" sz="500" kern="100">
                 <a:solidFill>
                   <a:srgbClr val="C00000"/>
                 </a:solidFill>
@@ -4149,13 +4170,13 @@
                 <a:ea typeface="Calibri" panose="020F0502020204030204" pitchFamily="34" charset="0"/>
                 <a:cs typeface="Calibri Light" panose="020F0302020204030204" pitchFamily="34" charset="0"/>
               </a:rPr>
-              <a:t>1:forceLast</a:t>
+              <a:t>1: forceLast</a:t>
             </a:r>
           </a:p>
           <a:p>
             <a:pPr rtl="0"/>
             <a:r>
-              <a:rPr lang="en-US" sz="853" kern="100">
+              <a:rPr lang="en-US" sz="500" kern="100">
                 <a:solidFill>
                   <a:srgbClr val="C00000"/>
                 </a:solidFill>
@@ -4163,7 +4184,7 @@
                 <a:ea typeface="Calibri" panose="020F0502020204030204" pitchFamily="34" charset="0"/>
                 <a:cs typeface="Calibri Light" panose="020F0302020204030204" pitchFamily="34" charset="0"/>
               </a:rPr>
-              <a:t>2:isAns</a:t>
+              <a:t>2: isAns</a:t>
             </a:r>
           </a:p>
         </p:txBody>
@@ -4182,7 +4203,7 @@
         </p:nvSpPr>
         <p:spPr bwMode="auto">
           <a:xfrm>
-            <a:off x="4561055" y="6369915"/>
+            <a:off x="4686211" y="6369915"/>
             <a:ext cx="1722105" cy="1226651"/>
           </a:xfrm>
           <a:prstGeom prst="roundRect">
@@ -4513,17 +4534,22 @@
                 <a:latin typeface="Segoe UI" panose="020B0502040204020203" pitchFamily="34" charset="0"/>
                 <a:cs typeface="Segoe UI" panose="020B0502040204020203" pitchFamily="34" charset="0"/>
               </a:rPr>
-              <a:t>Student</a:t>
-            </a:r>
-            <a:r>
-              <a:rPr lang="en-US" sz="853">
+              <a:t>StudentTags</a:t>
+            </a:r>
+          </a:p>
+          <a:p>
+            <a:pPr marL="176213" rtl="0">
+              <a:defRPr/>
+            </a:pPr>
+            <a:r>
+              <a:rPr lang="en-US" sz="500">
                 <a:solidFill>
                   <a:srgbClr val="C00000"/>
                 </a:solidFill>
                 <a:latin typeface="Segoe UI" panose="020B0502040204020203" pitchFamily="34" charset="0"/>
                 <a:cs typeface="Segoe UI" panose="020B0502040204020203" pitchFamily="34" charset="0"/>
               </a:rPr>
-              <a:t>Tags</a:t>
+              <a:t>1: IsActive</a:t>
             </a:r>
           </a:p>
           <a:p>
@@ -4531,14 +4557,14 @@
               <a:defRPr/>
             </a:pPr>
             <a:r>
-              <a:rPr lang="en-US" sz="700">
+              <a:rPr lang="en-US" sz="500">
                 <a:solidFill>
                   <a:srgbClr val="C00000"/>
                 </a:solidFill>
                 <a:latin typeface="Segoe UI" panose="020B0502040204020203" pitchFamily="34" charset="0"/>
                 <a:cs typeface="Segoe UI" panose="020B0502040204020203" pitchFamily="34" charset="0"/>
               </a:rPr>
-              <a:t>1:IsActive</a:t>
+              <a:t>2: ChangePass</a:t>
             </a:r>
           </a:p>
           <a:p>
@@ -4546,14 +4572,14 @@
               <a:defRPr/>
             </a:pPr>
             <a:r>
-              <a:rPr lang="en-US" sz="700">
+              <a:rPr lang="en-US" sz="500">
                 <a:solidFill>
                   <a:srgbClr val="C00000"/>
                 </a:solidFill>
                 <a:latin typeface="Segoe UI" panose="020B0502040204020203" pitchFamily="34" charset="0"/>
                 <a:cs typeface="Segoe UI" panose="020B0502040204020203" pitchFamily="34" charset="0"/>
               </a:rPr>
-              <a:t>2:ChangePass</a:t>
+              <a:t>4: ReviewEx</a:t>
             </a:r>
           </a:p>
           <a:p>
@@ -4561,14 +4587,14 @@
               <a:defRPr/>
             </a:pPr>
             <a:r>
-              <a:rPr lang="en-US" sz="700">
+              <a:rPr lang="en-US" sz="500">
                 <a:solidFill>
                   <a:srgbClr val="C00000"/>
                 </a:solidFill>
                 <a:latin typeface="Segoe UI" panose="020B0502040204020203" pitchFamily="34" charset="0"/>
                 <a:cs typeface="Segoe UI" panose="020B0502040204020203" pitchFamily="34" charset="0"/>
               </a:rPr>
-              <a:t>4:ReviewEx</a:t>
+              <a:t>8: GetStExTests</a:t>
             </a:r>
           </a:p>
           <a:p>
@@ -4576,14 +4602,14 @@
               <a:defRPr/>
             </a:pPr>
             <a:r>
-              <a:rPr lang="en-US" sz="700">
+              <a:rPr lang="en-US" sz="500">
                 <a:solidFill>
                   <a:srgbClr val="C00000"/>
                 </a:solidFill>
                 <a:latin typeface="Segoe UI" panose="020B0502040204020203" pitchFamily="34" charset="0"/>
                 <a:cs typeface="Segoe UI" panose="020B0502040204020203" pitchFamily="34" charset="0"/>
               </a:rPr>
-              <a:t>8:GetStExTests</a:t>
+              <a:t>16: CorrectStExTests</a:t>
             </a:r>
           </a:p>
           <a:p>
@@ -4591,14 +4617,14 @@
               <a:defRPr/>
             </a:pPr>
             <a:r>
-              <a:rPr lang="en-US" sz="700">
+              <a:rPr lang="en-US" sz="500">
                 <a:solidFill>
                   <a:srgbClr val="C00000"/>
                 </a:solidFill>
                 <a:latin typeface="Segoe UI" panose="020B0502040204020203" pitchFamily="34" charset="0"/>
                 <a:cs typeface="Segoe UI" panose="020B0502040204020203" pitchFamily="34" charset="0"/>
               </a:rPr>
-              <a:t>16:CorrectStExTests</a:t>
+              <a:t>32: RevStExTests</a:t>
             </a:r>
           </a:p>
           <a:p>
@@ -4606,14 +4632,14 @@
               <a:defRPr/>
             </a:pPr>
             <a:r>
-              <a:rPr lang="en-US" sz="700">
+              <a:rPr lang="en-US" sz="500">
                 <a:solidFill>
                   <a:srgbClr val="C00000"/>
                 </a:solidFill>
                 <a:latin typeface="Segoe UI" panose="020B0502040204020203" pitchFamily="34" charset="0"/>
                 <a:cs typeface="Segoe UI" panose="020B0502040204020203" pitchFamily="34" charset="0"/>
               </a:rPr>
-              <a:t>32:RevStExTests</a:t>
+              <a:t>64: IsSelected</a:t>
             </a:r>
           </a:p>
           <a:p>
@@ -4621,14 +4647,14 @@
               <a:defRPr/>
             </a:pPr>
             <a:r>
-              <a:rPr lang="en-US" sz="700">
+              <a:rPr lang="en-US" sz="500">
                 <a:solidFill>
                   <a:srgbClr val="C00000"/>
                 </a:solidFill>
                 <a:latin typeface="Segoe UI" panose="020B0502040204020203" pitchFamily="34" charset="0"/>
                 <a:cs typeface="Segoe UI" panose="020B0502040204020203" pitchFamily="34" charset="0"/>
               </a:rPr>
-              <a:t>64: IsSelected</a:t>
+              <a:t>128:</a:t>
             </a:r>
           </a:p>
           <a:p>
@@ -4636,22 +4662,7 @@
               <a:defRPr/>
             </a:pPr>
             <a:r>
-              <a:rPr lang="en-US" sz="700">
-                <a:solidFill>
-                  <a:srgbClr val="C00000"/>
-                </a:solidFill>
-                <a:latin typeface="Segoe UI" panose="020B0502040204020203" pitchFamily="34" charset="0"/>
-                <a:cs typeface="Segoe UI" panose="020B0502040204020203" pitchFamily="34" charset="0"/>
-              </a:rPr>
-              <a:t>128:</a:t>
-            </a:r>
-          </a:p>
-          <a:p>
-            <a:pPr marL="176213" rtl="0">
-              <a:defRPr/>
-            </a:pPr>
-            <a:r>
-              <a:rPr lang="en-US" sz="700">
+              <a:rPr lang="en-US" sz="500">
                 <a:solidFill>
                   <a:srgbClr val="C00000"/>
                 </a:solidFill>
@@ -4844,7 +4855,7 @@
         </p:nvSpPr>
         <p:spPr bwMode="auto">
           <a:xfrm>
-            <a:off x="5600126" y="645939"/>
+            <a:off x="5685945" y="670129"/>
             <a:ext cx="1366068" cy="1308924"/>
           </a:xfrm>
           <a:prstGeom prst="roundRect">
@@ -5162,14 +5173,14 @@
           <a:p>
             <a:pPr rtl="0"/>
             <a:r>
-              <a:rPr lang="en-US" sz="853">
+              <a:rPr lang="en-US" sz="500">
                 <a:solidFill>
                   <a:srgbClr val="C00000"/>
                 </a:solidFill>
                 <a:latin typeface="Segoe UI" panose="020B0502040204020203" pitchFamily="34" charset="0"/>
                 <a:cs typeface="Segoe UI" panose="020B0502040204020203" pitchFamily="34" charset="0"/>
               </a:rPr>
-              <a:t>1:act</a:t>
+              <a:t>1: act</a:t>
             </a:r>
           </a:p>
         </p:txBody>
@@ -5324,8 +5335,8 @@
         </p:nvSpPr>
         <p:spPr>
           <a:xfrm>
-            <a:off x="9757896" y="8201250"/>
-            <a:ext cx="1402948" cy="223587"/>
+            <a:off x="-12559" y="8399187"/>
+            <a:ext cx="1467068" cy="230832"/>
           </a:xfrm>
           <a:prstGeom prst="rect">
             <a:avLst/>
@@ -5340,17 +5351,21 @@
           <a:p>
             <a:pPr algn="l" rtl="0"/>
             <a:r>
-              <a:rPr lang="en-US" sz="853">
-                <a:solidFill>
-                  <a:schemeClr val="tx1"/>
+              <a:rPr lang="en-US" sz="900">
+                <a:solidFill>
+                  <a:schemeClr val="accent5">
+                    <a:lumMod val="75000"/>
+                  </a:schemeClr>
                 </a:solidFill>
                 <a:latin typeface="Consolas" panose="020B0609020204030204" pitchFamily="49" charset="0"/>
               </a:rPr>
               <a:t>Majid SharifiTehrani</a:t>
             </a:r>
-            <a:endParaRPr lang="fa-IR" sz="853">
+            <a:endParaRPr lang="fa-IR" sz="900">
               <a:solidFill>
-                <a:schemeClr val="tx1"/>
+                <a:schemeClr val="accent5">
+                  <a:lumMod val="75000"/>
+                </a:schemeClr>
               </a:solidFill>
               <a:latin typeface="Consolas" panose="020B0609020204030204" pitchFamily="49" charset="0"/>
             </a:endParaRPr>
@@ -5371,8 +5386,8 @@
         </p:nvSpPr>
         <p:spPr bwMode="auto">
           <a:xfrm>
-            <a:off x="5051947" y="4698088"/>
-            <a:ext cx="2010706" cy="1872068"/>
+            <a:off x="5192945" y="4910537"/>
+            <a:ext cx="1869708" cy="1570084"/>
           </a:xfrm>
           <a:prstGeom prst="roundRect">
             <a:avLst>
@@ -5548,7 +5563,7 @@
                 <a:latin typeface="Segoe UI" panose="020B0502040204020203" pitchFamily="34" charset="0"/>
                 <a:cs typeface="Segoe UI" panose="020B0502040204020203" pitchFamily="34" charset="0"/>
               </a:rPr>
-              <a:t>Exam</a:t>
+              <a:t>ExamTags</a:t>
             </a:r>
             <a:r>
               <a:rPr lang="en-US" sz="853">
@@ -5558,7 +5573,7 @@
                 <a:latin typeface="Segoe UI" panose="020B0502040204020203" pitchFamily="34" charset="0"/>
                 <a:cs typeface="Segoe UI" panose="020B0502040204020203" pitchFamily="34" charset="0"/>
               </a:rPr>
-              <a:t>Tags </a:t>
+              <a:t> </a:t>
             </a:r>
           </a:p>
           <a:p>
@@ -5566,7 +5581,7 @@
               <a:defRPr/>
             </a:pPr>
             <a:r>
-              <a:rPr lang="en-US" sz="853">
+              <a:rPr lang="en-US" sz="500">
                 <a:solidFill>
                   <a:srgbClr val="C00000"/>
                 </a:solidFill>
@@ -5729,8 +5744,8 @@
         </p:nvSpPr>
         <p:spPr bwMode="auto">
           <a:xfrm>
-            <a:off x="5049531" y="1921275"/>
-            <a:ext cx="2013127" cy="1645829"/>
+            <a:off x="5298327" y="1921275"/>
+            <a:ext cx="1764331" cy="1645829"/>
           </a:xfrm>
           <a:prstGeom prst="roundRect">
             <a:avLst>
@@ -5899,8 +5914,8 @@
         </p:nvSpPr>
         <p:spPr bwMode="auto">
           <a:xfrm>
-            <a:off x="6727074" y="6096823"/>
-            <a:ext cx="1552129" cy="1649493"/>
+            <a:off x="6641384" y="6096823"/>
+            <a:ext cx="1637820" cy="1649493"/>
           </a:xfrm>
           <a:prstGeom prst="roundRect">
             <a:avLst>
@@ -6093,17 +6108,7 @@
                 <a:latin typeface="Segoe UI" panose="020B0502040204020203" pitchFamily="34" charset="0"/>
                 <a:cs typeface="Segoe UI" panose="020B0502040204020203" pitchFamily="34" charset="0"/>
               </a:rPr>
-              <a:t>StudentExam</a:t>
-            </a:r>
-            <a:r>
-              <a:rPr lang="en-US" sz="853">
-                <a:solidFill>
-                  <a:srgbClr val="C00000"/>
-                </a:solidFill>
-                <a:latin typeface="Segoe UI" panose="020B0502040204020203" pitchFamily="34" charset="0"/>
-                <a:cs typeface="Segoe UI" panose="020B0502040204020203" pitchFamily="34" charset="0"/>
-              </a:rPr>
-              <a:t>Tags</a:t>
+              <a:t>StudentExamTags</a:t>
             </a:r>
           </a:p>
           <a:p>
@@ -6111,7 +6116,7 @@
               <a:defRPr/>
             </a:pPr>
             <a:r>
-              <a:rPr lang="en-US" sz="853">
+              <a:rPr lang="en-US" sz="500">
                 <a:solidFill>
                   <a:srgbClr val="C00000"/>
                 </a:solidFill>
@@ -6162,8 +6167,8 @@
         </p:nvSpPr>
         <p:spPr bwMode="auto">
           <a:xfrm>
-            <a:off x="6709586" y="1844456"/>
-            <a:ext cx="1545810" cy="1868075"/>
+            <a:off x="6709586" y="2038905"/>
+            <a:ext cx="1545810" cy="1705412"/>
           </a:xfrm>
           <a:prstGeom prst="roundRect">
             <a:avLst>
@@ -6337,17 +6342,7 @@
                 <a:latin typeface="Segoe UI" panose="020B0502040204020203" pitchFamily="34" charset="0"/>
                 <a:cs typeface="Segoe UI" panose="020B0502040204020203" pitchFamily="34" charset="0"/>
               </a:rPr>
-              <a:t>StudentCourse</a:t>
-            </a:r>
-            <a:r>
-              <a:rPr lang="en-US" sz="853">
-                <a:solidFill>
-                  <a:srgbClr val="C00000"/>
-                </a:solidFill>
-                <a:latin typeface="Segoe UI" panose="020B0502040204020203" pitchFamily="34" charset="0"/>
-                <a:cs typeface="Segoe UI" panose="020B0502040204020203" pitchFamily="34" charset="0"/>
-              </a:rPr>
-              <a:t>Tags</a:t>
+              <a:t>StudentCourseTags</a:t>
             </a:r>
           </a:p>
           <a:p>
@@ -6355,7 +6350,7 @@
               <a:buNone/>
             </a:pPr>
             <a:r>
-              <a:rPr lang="en-US" sz="853" kern="100">
+              <a:rPr lang="en-US" sz="500" kern="100">
                 <a:solidFill>
                   <a:srgbClr val="C00000"/>
                 </a:solidFill>
@@ -6363,7 +6358,39 @@
                 <a:ea typeface="Calibri" panose="020F0502020204030204" pitchFamily="34" charset="0"/>
                 <a:cs typeface="Segoe UI" panose="020B0502040204020203" pitchFamily="34" charset="0"/>
               </a:rPr>
-              <a:t>1:act 2:retry 4rev</a:t>
+              <a:t>1: act</a:t>
+            </a:r>
+          </a:p>
+          <a:p>
+            <a:pPr rtl="0">
+              <a:buNone/>
+            </a:pPr>
+            <a:r>
+              <a:rPr lang="en-US" sz="500" kern="100">
+                <a:solidFill>
+                  <a:srgbClr val="C00000"/>
+                </a:solidFill>
+                <a:latin typeface="Segoe UI" panose="020B0502040204020203" pitchFamily="34" charset="0"/>
+                <a:ea typeface="Calibri" panose="020F0502020204030204" pitchFamily="34" charset="0"/>
+                <a:cs typeface="Segoe UI" panose="020B0502040204020203" pitchFamily="34" charset="0"/>
+              </a:rPr>
+              <a:t>2: retry</a:t>
+            </a:r>
+          </a:p>
+          <a:p>
+            <a:pPr rtl="0">
+              <a:buNone/>
+            </a:pPr>
+            <a:r>
+              <a:rPr lang="en-US" sz="500" kern="100">
+                <a:solidFill>
+                  <a:srgbClr val="C00000"/>
+                </a:solidFill>
+                <a:latin typeface="Segoe UI" panose="020B0502040204020203" pitchFamily="34" charset="0"/>
+                <a:ea typeface="Calibri" panose="020F0502020204030204" pitchFamily="34" charset="0"/>
+                <a:cs typeface="Segoe UI" panose="020B0502040204020203" pitchFamily="34" charset="0"/>
+              </a:rPr>
+              <a:t>4: rev</a:t>
             </a:r>
           </a:p>
         </p:txBody>
@@ -6382,8 +6409,8 @@
         </p:nvSpPr>
         <p:spPr bwMode="auto">
           <a:xfrm>
-            <a:off x="6703272" y="4578752"/>
-            <a:ext cx="1552129" cy="1387474"/>
+            <a:off x="6641384" y="4578752"/>
+            <a:ext cx="1614017" cy="1387474"/>
           </a:xfrm>
           <a:prstGeom prst="roundRect">
             <a:avLst>
@@ -6568,8 +6595,8 @@
         </p:nvSpPr>
         <p:spPr bwMode="auto">
           <a:xfrm>
-            <a:off x="8114732" y="2007119"/>
-            <a:ext cx="1864591" cy="1402330"/>
+            <a:off x="8114731" y="2196769"/>
+            <a:ext cx="1864591" cy="1259516"/>
           </a:xfrm>
           <a:prstGeom prst="roundRect">
             <a:avLst>
@@ -6756,8 +6783,8 @@
         </p:nvSpPr>
         <p:spPr bwMode="auto">
           <a:xfrm>
-            <a:off x="8114731" y="5248801"/>
-            <a:ext cx="2299440" cy="2118334"/>
+            <a:off x="8136507" y="5248801"/>
+            <a:ext cx="2277663" cy="2599258"/>
           </a:xfrm>
           <a:prstGeom prst="roundRect">
             <a:avLst>
@@ -7014,78 +7041,15 @@
                 <a:latin typeface="Segoe UI" panose="020B0502040204020203" pitchFamily="34" charset="0"/>
                 <a:cs typeface="Segoe UI" panose="020B0502040204020203" pitchFamily="34" charset="0"/>
               </a:rPr>
-              <a:t>StudentExamTest</a:t>
-            </a:r>
-            <a:r>
-              <a:rPr lang="en-US" sz="853">
-                <a:solidFill>
-                  <a:srgbClr val="C00000"/>
-                </a:solidFill>
-                <a:latin typeface="Segoe UI" panose="020B0502040204020203" pitchFamily="34" charset="0"/>
-                <a:cs typeface="Segoe UI" panose="020B0502040204020203" pitchFamily="34" charset="0"/>
-              </a:rPr>
-              <a:t>Tags</a:t>
-            </a:r>
-          </a:p>
-        </p:txBody>
-      </p:sp>
-      <p:sp>
-        <p:nvSpPr>
-          <p:cNvPr id="30" name="Callout: Bent Line 29">
-            <a:extLst>
-              <a:ext uri="{FF2B5EF4-FFF2-40B4-BE49-F238E27FC236}">
-                <a16:creationId xmlns:a16="http://schemas.microsoft.com/office/drawing/2014/main" id="{37CBAADD-8162-F8CF-9142-1CCC32CAB857}"/>
-              </a:ext>
-            </a:extLst>
-          </p:cNvPr>
-          <p:cNvSpPr/>
-          <p:nvPr/>
-        </p:nvSpPr>
-        <p:spPr bwMode="auto">
-          <a:xfrm>
-            <a:off x="9376850" y="6290922"/>
-            <a:ext cx="969138" cy="981077"/>
-          </a:xfrm>
-          <a:prstGeom prst="borderCallout2">
-            <a:avLst>
-              <a:gd name="adj1" fmla="val -1024"/>
-              <a:gd name="adj2" fmla="val 85567"/>
-              <a:gd name="adj3" fmla="val 366"/>
-              <a:gd name="adj4" fmla="val 82159"/>
-              <a:gd name="adj5" fmla="val 180"/>
-              <a:gd name="adj6" fmla="val 85711"/>
-            </a:avLst>
-          </a:prstGeom>
-          <a:noFill/>
-          <a:ln>
-            <a:prstDash val="dash"/>
-          </a:ln>
-        </p:spPr>
-        <p:style>
-          <a:lnRef idx="2">
-            <a:schemeClr val="accent1">
-              <a:shade val="15000"/>
-            </a:schemeClr>
-          </a:lnRef>
-          <a:fillRef idx="1">
-            <a:schemeClr val="accent1"/>
-          </a:fillRef>
-          <a:effectRef idx="0">
-            <a:schemeClr val="accent1"/>
-          </a:effectRef>
-          <a:fontRef idx="minor">
-            <a:schemeClr val="lt1"/>
-          </a:fontRef>
-        </p:style>
-        <p:txBody>
-          <a:bodyPr rtlCol="1" anchor="ctr"/>
-          <a:lstStyle/>
+              <a:t>StudentExamTestTags</a:t>
+            </a:r>
+          </a:p>
           <a:p>
             <a:pPr rtl="0">
               <a:buNone/>
             </a:pPr>
             <a:r>
-              <a:rPr lang="en-US" sz="853" kern="100">
+              <a:rPr lang="en-US" sz="500" kern="100">
                 <a:solidFill>
                   <a:srgbClr val="C00000"/>
                 </a:solidFill>
@@ -7101,7 +7065,7 @@
               <a:buNone/>
             </a:pPr>
             <a:r>
-              <a:rPr lang="en-US" sz="853" kern="100">
+              <a:rPr lang="en-US" sz="500" kern="100">
                 <a:solidFill>
                   <a:srgbClr val="C00000"/>
                 </a:solidFill>
@@ -7117,7 +7081,7 @@
               <a:buNone/>
             </a:pPr>
             <a:r>
-              <a:rPr lang="en-US" sz="853" kern="100">
+              <a:rPr lang="en-US" sz="500" kern="100">
                 <a:solidFill>
                   <a:srgbClr val="C00000"/>
                 </a:solidFill>
@@ -7133,7 +7097,7 @@
               <a:buNone/>
             </a:pPr>
             <a:r>
-              <a:rPr lang="en-US" sz="853" kern="100">
+              <a:rPr lang="en-US" sz="500" kern="100">
                 <a:solidFill>
                   <a:srgbClr val="C00000"/>
                 </a:solidFill>
@@ -7149,7 +7113,7 @@
               <a:buNone/>
             </a:pPr>
             <a:r>
-              <a:rPr lang="en-US" sz="853" kern="100">
+              <a:rPr lang="en-US" sz="500" kern="100">
                 <a:solidFill>
                   <a:srgbClr val="C00000"/>
                 </a:solidFill>
@@ -7165,7 +7129,7 @@
               <a:buNone/>
             </a:pPr>
             <a:r>
-              <a:rPr lang="en-US" sz="853" kern="100">
+              <a:rPr lang="en-US" sz="500" kern="100">
                 <a:solidFill>
                   <a:srgbClr val="C00000"/>
                 </a:solidFill>
@@ -7179,7 +7143,7 @@
           <a:p>
             <a:pPr rtl="0"/>
             <a:r>
-              <a:rPr lang="en-US" sz="853" kern="100">
+              <a:rPr lang="en-US" sz="500" kern="100">
                 <a:solidFill>
                   <a:srgbClr val="C00000"/>
                 </a:solidFill>
@@ -7341,8 +7305,8 @@
         </p:nvSpPr>
         <p:spPr>
           <a:xfrm>
-            <a:off x="632108" y="6149940"/>
-            <a:ext cx="997025" cy="1003009"/>
+            <a:off x="632108" y="6149941"/>
+            <a:ext cx="997025" cy="1301732"/>
           </a:xfrm>
           <a:prstGeom prst="roundRect">
             <a:avLst>
@@ -7431,6 +7395,38 @@
               </a:rPr>
               <a:t>UserType</a:t>
             </a:r>
+          </a:p>
+          <a:p>
+            <a:pPr rtl="0">
+              <a:buNone/>
+            </a:pPr>
+            <a:r>
+              <a:rPr lang="en-US" sz="600" kern="100">
+                <a:solidFill>
+                  <a:schemeClr val="tx1"/>
+                </a:solidFill>
+                <a:latin typeface="Consolas" panose="020B0609020204030204" pitchFamily="49" charset="0"/>
+                <a:ea typeface="Calibri" panose="020F0502020204030204" pitchFamily="34" charset="0"/>
+                <a:cs typeface="Calibri Light" panose="020F0302020204030204" pitchFamily="34" charset="0"/>
+              </a:rPr>
+              <a:t> 1:Teacher</a:t>
+            </a:r>
+          </a:p>
+          <a:p>
+            <a:pPr rtl="0">
+              <a:buNone/>
+            </a:pPr>
+            <a:r>
+              <a:rPr lang="en-US" sz="600" kern="100">
+                <a:solidFill>
+                  <a:schemeClr val="tx1"/>
+                </a:solidFill>
+                <a:latin typeface="Consolas" panose="020B0609020204030204" pitchFamily="49" charset="0"/>
+                <a:ea typeface="Calibri" panose="020F0502020204030204" pitchFamily="34" charset="0"/>
+                <a:cs typeface="Calibri Light" panose="020F0302020204030204" pitchFamily="34" charset="0"/>
+              </a:rPr>
+              <a:t> 2:Student</a:t>
+            </a:r>
             <a:endParaRPr lang="en-US" sz="853" dirty="0"/>
           </a:p>
           <a:p>
@@ -7444,169 +7440,27 @@
           <a:p>
             <a:pPr rtl="0"/>
             <a:r>
-              <a:rPr lang="en-US" sz="853"/>
-              <a:t>Project</a:t>
-            </a:r>
-            <a:r>
               <a:rPr lang="en-US" sz="853">
                 <a:solidFill>
+                  <a:schemeClr val="tx1"/>
+                </a:solidFill>
+              </a:rPr>
+              <a:t>ProjectTags</a:t>
+            </a:r>
+          </a:p>
+          <a:p>
+            <a:pPr rtl="0"/>
+            <a:r>
+              <a:rPr lang="en-US" sz="500" kern="100">
+                <a:solidFill>
                   <a:srgbClr val="C00000"/>
                 </a:solidFill>
-              </a:rPr>
-              <a:t>Tags</a:t>
-            </a:r>
-            <a:endParaRPr lang="en-US" sz="853" dirty="0">
-              <a:solidFill>
-                <a:srgbClr val="C00000"/>
-              </a:solidFill>
-            </a:endParaRPr>
-          </a:p>
-        </p:txBody>
-      </p:sp>
-      <p:sp>
-        <p:nvSpPr>
-          <p:cNvPr id="2" name="Rectangle: Rounded Corners 1">
-            <a:extLst>
-              <a:ext uri="{FF2B5EF4-FFF2-40B4-BE49-F238E27FC236}">
-                <a16:creationId xmlns:a16="http://schemas.microsoft.com/office/drawing/2014/main" id="{6A0D2D6C-AD44-BFED-2D51-29757378D5BB}"/>
-              </a:ext>
-            </a:extLst>
-          </p:cNvPr>
-          <p:cNvSpPr/>
-          <p:nvPr/>
-        </p:nvSpPr>
-        <p:spPr>
-          <a:xfrm>
-            <a:off x="2735908" y="6631447"/>
-            <a:ext cx="895415" cy="1236232"/>
-          </a:xfrm>
-          <a:prstGeom prst="roundRect">
-            <a:avLst>
-              <a:gd name="adj" fmla="val 1266"/>
-            </a:avLst>
-          </a:prstGeom>
-          <a:solidFill>
-            <a:schemeClr val="bg1"/>
-          </a:solidFill>
-          <a:ln>
-            <a:solidFill>
-              <a:schemeClr val="tx1">
-                <a:lumMod val="65000"/>
-                <a:lumOff val="35000"/>
-              </a:schemeClr>
-            </a:solidFill>
-          </a:ln>
-        </p:spPr>
-        <p:style>
-          <a:lnRef idx="1">
-            <a:schemeClr val="accent4"/>
-          </a:lnRef>
-          <a:fillRef idx="2">
-            <a:schemeClr val="accent4"/>
-          </a:fillRef>
-          <a:effectRef idx="1">
-            <a:schemeClr val="accent4"/>
-          </a:effectRef>
-          <a:fontRef idx="minor">
-            <a:schemeClr val="dk1"/>
-          </a:fontRef>
-        </p:style>
-        <p:txBody>
-          <a:bodyPr rtlCol="1" anchor="t"/>
-          <a:lstStyle/>
-          <a:p>
-            <a:pPr rtl="0"/>
-            <a:r>
-              <a:rPr lang="en-US" sz="1707" b="1" dirty="0">
-                <a:solidFill>
-                  <a:schemeClr val="bg1"/>
-                </a:solidFill>
-                <a:highlight>
-                  <a:srgbClr val="000000"/>
-                </a:highlight>
-              </a:rPr>
-              <a:t>N</a:t>
-            </a:r>
-            <a:r>
-              <a:rPr lang="en-US" sz="1280" b="1" dirty="0"/>
-              <a:t>otes</a:t>
-            </a:r>
-          </a:p>
-          <a:p>
-            <a:pPr rtl="0"/>
-            <a:r>
-              <a:rPr lang="en-US" sz="853" i="1">
-                <a:solidFill>
-                  <a:schemeClr val="accent5"/>
-                </a:solidFill>
-                <a:latin typeface="Segoe UI" panose="020B0502040204020203" pitchFamily="34" charset="0"/>
-                <a:cs typeface="Segoe UI" panose="020B0502040204020203" pitchFamily="34" charset="0"/>
-              </a:rPr>
-              <a:t>NoteId</a:t>
-            </a:r>
-          </a:p>
-          <a:p>
-            <a:pPr rtl="0"/>
-            <a:r>
-              <a:rPr lang="en-US" sz="853"/>
-              <a:t>ParentId</a:t>
-            </a:r>
-          </a:p>
-          <a:p>
-            <a:pPr rtl="0"/>
-            <a:r>
-              <a:rPr lang="en-US" sz="853"/>
-              <a:t>ParentType</a:t>
-            </a:r>
-          </a:p>
-          <a:p>
-            <a:pPr rtl="0"/>
-            <a:r>
-              <a:rPr lang="en-US" sz="853"/>
-              <a:t>NoteDatum</a:t>
-            </a:r>
-            <a:endParaRPr lang="en-US" sz="853" dirty="0"/>
-          </a:p>
-          <a:p>
-            <a:pPr rtl="0"/>
-            <a:r>
-              <a:rPr lang="en-US" sz="853"/>
-              <a:t>NoteText</a:t>
-            </a:r>
-            <a:endParaRPr lang="en-US" sz="853" dirty="0"/>
-          </a:p>
-          <a:p>
-            <a:pPr rtl="0"/>
-            <a:r>
-              <a:rPr lang="en-US" sz="853">
-                <a:solidFill>
-                  <a:srgbClr val="C00000"/>
-                </a:solidFill>
-              </a:rPr>
-              <a:t>NoteTags</a:t>
-            </a:r>
-          </a:p>
-          <a:p>
-            <a:pPr rtl="0"/>
-            <a:r>
-              <a:rPr lang="en-US" sz="853">
-                <a:solidFill>
-                  <a:schemeClr val="tx1"/>
-                </a:solidFill>
-                <a:highlight>
-                  <a:srgbClr val="FFFF00"/>
-                </a:highlight>
-              </a:rPr>
-              <a:t>CreatorId</a:t>
-            </a:r>
-            <a:endParaRPr lang="fa-IR" sz="853" dirty="0">
-              <a:solidFill>
-                <a:schemeClr val="tx1"/>
-              </a:solidFill>
-              <a:highlight>
-                <a:srgbClr val="FFFF00"/>
-              </a:highlight>
-            </a:endParaRPr>
+                <a:latin typeface="Consolas" panose="020B0609020204030204" pitchFamily="49" charset="0"/>
+                <a:ea typeface="Calibri" panose="020F0502020204030204" pitchFamily="34" charset="0"/>
+                <a:cs typeface="Calibri Light" panose="020F0302020204030204" pitchFamily="34" charset="0"/>
+              </a:rPr>
+              <a:t> 1:active</a:t>
+            </a:r>
           </a:p>
         </p:txBody>
       </p:sp>
@@ -7624,7 +7478,7 @@
         </p:nvSpPr>
         <p:spPr>
           <a:xfrm>
-            <a:off x="3482164" y="6264597"/>
+            <a:off x="3440149" y="6209602"/>
             <a:ext cx="909928" cy="721108"/>
           </a:xfrm>
           <a:prstGeom prst="roundRect">
@@ -7731,8 +7585,8 @@
         </p:nvSpPr>
         <p:spPr bwMode="auto">
           <a:xfrm>
-            <a:off x="1007716" y="7332621"/>
-            <a:ext cx="1683369" cy="1236232"/>
+            <a:off x="1796568" y="7479661"/>
+            <a:ext cx="1105070" cy="787849"/>
           </a:xfrm>
           <a:prstGeom prst="borderCallout2">
             <a:avLst>
@@ -7773,7 +7627,7 @@
               <a:buNone/>
             </a:pPr>
             <a:r>
-              <a:rPr lang="en-US" sz="853" kern="100">
+              <a:rPr lang="en-US" sz="500" kern="100">
                 <a:solidFill>
                   <a:schemeClr val="tx1"/>
                 </a:solidFill>
@@ -7781,7 +7635,7 @@
                 <a:ea typeface="Calibri" panose="020F0502020204030204" pitchFamily="34" charset="0"/>
                 <a:cs typeface="Calibri Light" panose="020F0302020204030204" pitchFamily="34" charset="0"/>
               </a:rPr>
-              <a:t>parentTypes:</a:t>
+              <a:t>NoteTypes:</a:t>
             </a:r>
           </a:p>
           <a:p>
@@ -7789,7 +7643,7 @@
               <a:buNone/>
             </a:pPr>
             <a:r>
-              <a:rPr lang="en-US" sz="853" kern="100">
+              <a:rPr lang="en-US" sz="500" kern="100">
                 <a:solidFill>
                   <a:schemeClr val="tx1"/>
                 </a:solidFill>
@@ -7797,7 +7651,7 @@
                 <a:ea typeface="Calibri" panose="020F0502020204030204" pitchFamily="34" charset="0"/>
                 <a:cs typeface="Calibri Light" panose="020F0302020204030204" pitchFamily="34" charset="0"/>
               </a:rPr>
-              <a:t> 1: quickNote by T</a:t>
+              <a:t> 1: S: quickNote</a:t>
             </a:r>
           </a:p>
           <a:p>
@@ -7805,7 +7659,7 @@
               <a:buNone/>
             </a:pPr>
             <a:r>
-              <a:rPr lang="en-US" sz="853" kern="100">
+              <a:rPr lang="en-US" sz="500" kern="100">
                 <a:solidFill>
                   <a:schemeClr val="tx1"/>
                 </a:solidFill>
@@ -7813,7 +7667,7 @@
                 <a:ea typeface="Calibri" panose="020F0502020204030204" pitchFamily="34" charset="0"/>
                 <a:cs typeface="Calibri Light" panose="020F0302020204030204" pitchFamily="34" charset="0"/>
               </a:rPr>
-              <a:t> 2: section Note</a:t>
+              <a:t> 2: S: sectionNote</a:t>
             </a:r>
           </a:p>
           <a:p>
@@ -7821,7 +7675,7 @@
               <a:buNone/>
             </a:pPr>
             <a:r>
-              <a:rPr lang="en-US" sz="853" kern="100">
+              <a:rPr lang="en-US" sz="500" kern="100">
                 <a:solidFill>
                   <a:schemeClr val="tx1"/>
                 </a:solidFill>
@@ -7829,7 +7683,7 @@
                 <a:ea typeface="Calibri" panose="020F0502020204030204" pitchFamily="34" charset="0"/>
                 <a:cs typeface="Calibri Light" panose="020F0302020204030204" pitchFamily="34" charset="0"/>
               </a:rPr>
-              <a:t> 3: note on Student</a:t>
+              <a:t>11: T: quickNote</a:t>
             </a:r>
           </a:p>
           <a:p>
@@ -7837,7 +7691,7 @@
               <a:buNone/>
             </a:pPr>
             <a:r>
-              <a:rPr lang="en-US" sz="853" kern="100">
+              <a:rPr lang="en-US" sz="500" kern="100">
                 <a:solidFill>
                   <a:schemeClr val="tx1"/>
                 </a:solidFill>
@@ -7845,7 +7699,7 @@
                 <a:ea typeface="Calibri" panose="020F0502020204030204" pitchFamily="34" charset="0"/>
                 <a:cs typeface="Calibri Light" panose="020F0302020204030204" pitchFamily="34" charset="0"/>
               </a:rPr>
-              <a:t> 4: note on Group</a:t>
+              <a:t>12: T: sectionNote</a:t>
             </a:r>
           </a:p>
           <a:p>
@@ -7853,7 +7707,7 @@
               <a:buNone/>
             </a:pPr>
             <a:r>
-              <a:rPr lang="en-US" sz="853" kern="100">
+              <a:rPr lang="en-US" sz="500" kern="100">
                 <a:solidFill>
                   <a:schemeClr val="tx1"/>
                 </a:solidFill>
@@ -7861,7 +7715,7 @@
                 <a:ea typeface="Calibri" panose="020F0502020204030204" pitchFamily="34" charset="0"/>
                 <a:cs typeface="Calibri Light" panose="020F0302020204030204" pitchFamily="34" charset="0"/>
               </a:rPr>
-              <a:t> 5: note on Course</a:t>
+              <a:t>13: T: note on Student</a:t>
             </a:r>
           </a:p>
           <a:p>
@@ -7869,7 +7723,7 @@
               <a:buNone/>
             </a:pPr>
             <a:r>
-              <a:rPr lang="en-US" sz="853" kern="100">
+              <a:rPr lang="en-US" sz="500" kern="100">
                 <a:solidFill>
                   <a:schemeClr val="tx1"/>
                 </a:solidFill>
@@ -7877,7 +7731,7 @@
                 <a:ea typeface="Calibri" panose="020F0502020204030204" pitchFamily="34" charset="0"/>
                 <a:cs typeface="Calibri Light" panose="020F0302020204030204" pitchFamily="34" charset="0"/>
               </a:rPr>
-              <a:t> 6: note on Exam</a:t>
+              <a:t>14: T: note on Group</a:t>
             </a:r>
           </a:p>
           <a:p>
@@ -7885,7 +7739,7 @@
               <a:buNone/>
             </a:pPr>
             <a:r>
-              <a:rPr lang="en-US" sz="853" kern="100">
+              <a:rPr lang="en-US" sz="500" kern="100">
                 <a:solidFill>
                   <a:schemeClr val="tx1"/>
                 </a:solidFill>
@@ -7893,7 +7747,7 @@
                 <a:ea typeface="Calibri" panose="020F0502020204030204" pitchFamily="34" charset="0"/>
                 <a:cs typeface="Calibri Light" panose="020F0302020204030204" pitchFamily="34" charset="0"/>
               </a:rPr>
-              <a:t> 7: quickNote by S</a:t>
+              <a:t>15: T: note on Course</a:t>
             </a:r>
           </a:p>
           <a:p>
@@ -7901,7 +7755,7 @@
               <a:buNone/>
             </a:pPr>
             <a:r>
-              <a:rPr lang="en-US" sz="853" kern="100">
+              <a:rPr lang="en-US" sz="500" kern="100">
                 <a:solidFill>
                   <a:schemeClr val="tx1"/>
                 </a:solidFill>
@@ -7909,7 +7763,23 @@
                 <a:ea typeface="Calibri" panose="020F0502020204030204" pitchFamily="34" charset="0"/>
                 <a:cs typeface="Calibri Light" panose="020F0302020204030204" pitchFamily="34" charset="0"/>
               </a:rPr>
-              <a:t> 8: note on Examstudents</a:t>
+              <a:t>16: T: note on Exam</a:t>
+            </a:r>
+          </a:p>
+          <a:p>
+            <a:pPr rtl="0">
+              <a:buNone/>
+            </a:pPr>
+            <a:r>
+              <a:rPr lang="en-US" sz="500" kern="100">
+                <a:solidFill>
+                  <a:schemeClr val="tx1"/>
+                </a:solidFill>
+                <a:latin typeface="Consolas" panose="020B0609020204030204" pitchFamily="49" charset="0"/>
+                <a:ea typeface="Calibri" panose="020F0502020204030204" pitchFamily="34" charset="0"/>
+                <a:cs typeface="Calibri Light" panose="020F0302020204030204" pitchFamily="34" charset="0"/>
+              </a:rPr>
+              <a:t>17: T: note on StudentExam</a:t>
             </a:r>
           </a:p>
         </p:txBody>
@@ -7928,8 +7798,8 @@
         </p:nvSpPr>
         <p:spPr bwMode="auto">
           <a:xfrm>
-            <a:off x="2833510" y="597669"/>
-            <a:ext cx="1182039" cy="1402919"/>
+            <a:off x="2794325" y="588887"/>
+            <a:ext cx="1516599" cy="1411701"/>
           </a:xfrm>
           <a:prstGeom prst="roundRect">
             <a:avLst>
@@ -8094,65 +7964,12 @@
               <a:t>ChatTags</a:t>
             </a:r>
           </a:p>
-        </p:txBody>
-      </p:sp>
-      <p:sp>
-        <p:nvSpPr>
-          <p:cNvPr id="19" name="Callout: Bent Line 18">
-            <a:extLst>
-              <a:ext uri="{FF2B5EF4-FFF2-40B4-BE49-F238E27FC236}">
-                <a16:creationId xmlns:a16="http://schemas.microsoft.com/office/drawing/2014/main" id="{911BC3D9-3D49-A426-849E-1055E8FBCA28}"/>
-              </a:ext>
-            </a:extLst>
-          </p:cNvPr>
-          <p:cNvSpPr/>
-          <p:nvPr/>
-        </p:nvSpPr>
-        <p:spPr bwMode="auto">
-          <a:xfrm>
-            <a:off x="779315" y="1829793"/>
-            <a:ext cx="2013126" cy="259346"/>
-          </a:xfrm>
-          <a:prstGeom prst="borderCallout2">
-            <a:avLst>
-              <a:gd name="adj1" fmla="val -1024"/>
-              <a:gd name="adj2" fmla="val 85567"/>
-              <a:gd name="adj3" fmla="val 366"/>
-              <a:gd name="adj4" fmla="val 82159"/>
-              <a:gd name="adj5" fmla="val 180"/>
-              <a:gd name="adj6" fmla="val 85711"/>
-            </a:avLst>
-          </a:prstGeom>
-          <a:noFill/>
-          <a:ln>
-            <a:prstDash val="dash"/>
-          </a:ln>
-        </p:spPr>
-        <p:style>
-          <a:lnRef idx="2">
-            <a:schemeClr val="accent1">
-              <a:shade val="15000"/>
-            </a:schemeClr>
-          </a:lnRef>
-          <a:fillRef idx="1">
-            <a:schemeClr val="accent1"/>
-          </a:fillRef>
-          <a:effectRef idx="0">
-            <a:schemeClr val="accent1"/>
-          </a:effectRef>
-          <a:fontRef idx="minor">
-            <a:schemeClr val="lt1"/>
-          </a:fontRef>
-        </p:style>
-        <p:txBody>
-          <a:bodyPr rtlCol="1" anchor="ctr"/>
-          <a:lstStyle/>
           <a:p>
             <a:pPr rtl="0">
-              <a:buNone/>
-            </a:pPr>
-            <a:r>
-              <a:rPr lang="en-US" sz="853" kern="100">
+              <a:defRPr/>
+            </a:pPr>
+            <a:r>
+              <a:rPr lang="en-US" sz="600" kern="100">
                 <a:solidFill>
                   <a:schemeClr val="tx1"/>
                 </a:solidFill>
@@ -8160,308 +7977,7 @@
                 <a:ea typeface="Calibri" panose="020F0502020204030204" pitchFamily="34" charset="0"/>
                 <a:cs typeface="Calibri Light" panose="020F0302020204030204" pitchFamily="34" charset="0"/>
               </a:rPr>
-              <a:t>ChatTags</a:t>
-            </a:r>
-          </a:p>
-          <a:p>
-            <a:pPr rtl="0">
-              <a:buNone/>
-            </a:pPr>
-            <a:r>
-              <a:rPr lang="en-US" sz="853" kern="100">
-                <a:solidFill>
-                  <a:schemeClr val="tx1"/>
-                </a:solidFill>
-                <a:latin typeface="Consolas" panose="020B0609020204030204" pitchFamily="49" charset="0"/>
-                <a:ea typeface="Calibri" panose="020F0502020204030204" pitchFamily="34" charset="0"/>
-                <a:cs typeface="Calibri Light" panose="020F0302020204030204" pitchFamily="34" charset="0"/>
-              </a:rPr>
               <a:t>1:Read 2:Imp 3:Bookmark 4:Del</a:t>
-            </a:r>
-          </a:p>
-        </p:txBody>
-      </p:sp>
-      <p:sp>
-        <p:nvSpPr>
-          <p:cNvPr id="20" name="Callout: Bent Line 19">
-            <a:extLst>
-              <a:ext uri="{FF2B5EF4-FFF2-40B4-BE49-F238E27FC236}">
-                <a16:creationId xmlns:a16="http://schemas.microsoft.com/office/drawing/2014/main" id="{12E24851-D7C0-662B-DDE1-34D282E94032}"/>
-              </a:ext>
-            </a:extLst>
-          </p:cNvPr>
-          <p:cNvSpPr/>
-          <p:nvPr/>
-        </p:nvSpPr>
-        <p:spPr bwMode="auto">
-          <a:xfrm>
-            <a:off x="2735908" y="7920781"/>
-            <a:ext cx="1584176" cy="620356"/>
-          </a:xfrm>
-          <a:prstGeom prst="borderCallout2">
-            <a:avLst>
-              <a:gd name="adj1" fmla="val -1024"/>
-              <a:gd name="adj2" fmla="val 85567"/>
-              <a:gd name="adj3" fmla="val 366"/>
-              <a:gd name="adj4" fmla="val 82159"/>
-              <a:gd name="adj5" fmla="val 180"/>
-              <a:gd name="adj6" fmla="val 85711"/>
-            </a:avLst>
-          </a:prstGeom>
-          <a:noFill/>
-          <a:ln>
-            <a:prstDash val="dash"/>
-          </a:ln>
-        </p:spPr>
-        <p:style>
-          <a:lnRef idx="2">
-            <a:schemeClr val="accent1">
-              <a:shade val="15000"/>
-            </a:schemeClr>
-          </a:lnRef>
-          <a:fillRef idx="1">
-            <a:schemeClr val="accent1"/>
-          </a:fillRef>
-          <a:effectRef idx="0">
-            <a:schemeClr val="accent1"/>
-          </a:effectRef>
-          <a:fontRef idx="minor">
-            <a:schemeClr val="lt1"/>
-          </a:fontRef>
-        </p:style>
-        <p:txBody>
-          <a:bodyPr rtlCol="1" anchor="ctr"/>
-          <a:lstStyle/>
-          <a:p>
-            <a:pPr rtl="0">
-              <a:buNone/>
-            </a:pPr>
-            <a:r>
-              <a:rPr lang="en-US" sz="853" kern="100">
-                <a:solidFill>
-                  <a:schemeClr val="tx1"/>
-                </a:solidFill>
-                <a:latin typeface="Consolas" panose="020B0609020204030204" pitchFamily="49" charset="0"/>
-                <a:ea typeface="Calibri" panose="020F0502020204030204" pitchFamily="34" charset="0"/>
-                <a:cs typeface="Calibri Light" panose="020F0302020204030204" pitchFamily="34" charset="0"/>
-              </a:rPr>
-              <a:t>NoteTags</a:t>
-            </a:r>
-          </a:p>
-          <a:p>
-            <a:pPr rtl="0">
-              <a:buNone/>
-            </a:pPr>
-            <a:r>
-              <a:rPr lang="en-US" sz="853" kern="100">
-                <a:solidFill>
-                  <a:schemeClr val="tx1"/>
-                </a:solidFill>
-                <a:latin typeface="Consolas" panose="020B0609020204030204" pitchFamily="49" charset="0"/>
-                <a:ea typeface="Calibri" panose="020F0502020204030204" pitchFamily="34" charset="0"/>
-                <a:cs typeface="Calibri Light" panose="020F0302020204030204" pitchFamily="34" charset="0"/>
-              </a:rPr>
-              <a:t> 1:rtl      2:done</a:t>
-            </a:r>
-          </a:p>
-          <a:p>
-            <a:pPr rtl="0">
-              <a:buNone/>
-            </a:pPr>
-            <a:r>
-              <a:rPr lang="en-US" sz="853" kern="100">
-                <a:solidFill>
-                  <a:schemeClr val="tx1"/>
-                </a:solidFill>
-                <a:latin typeface="Consolas" panose="020B0609020204030204" pitchFamily="49" charset="0"/>
-                <a:ea typeface="Calibri" panose="020F0502020204030204" pitchFamily="34" charset="0"/>
-                <a:cs typeface="Calibri Light" panose="020F0302020204030204" pitchFamily="34" charset="0"/>
-              </a:rPr>
-              <a:t> 4:shared   8:</a:t>
-            </a:r>
-            <a:r>
-              <a:rPr lang="en-US" sz="853" kern="100">
-                <a:solidFill>
-                  <a:srgbClr val="FF0000"/>
-                </a:solidFill>
-                <a:latin typeface="Consolas" panose="020B0609020204030204" pitchFamily="49" charset="0"/>
-                <a:ea typeface="Calibri" panose="020F0502020204030204" pitchFamily="34" charset="0"/>
-                <a:cs typeface="Calibri Light" panose="020F0302020204030204" pitchFamily="34" charset="0"/>
-              </a:rPr>
-              <a:t>readonly</a:t>
-            </a:r>
-            <a:endParaRPr lang="en-US" sz="853" kern="100">
-              <a:solidFill>
-                <a:schemeClr val="tx1"/>
-              </a:solidFill>
-              <a:latin typeface="Consolas" panose="020B0609020204030204" pitchFamily="49" charset="0"/>
-              <a:ea typeface="Calibri" panose="020F0502020204030204" pitchFamily="34" charset="0"/>
-              <a:cs typeface="Calibri Light" panose="020F0302020204030204" pitchFamily="34" charset="0"/>
-            </a:endParaRPr>
-          </a:p>
-          <a:p>
-            <a:pPr rtl="0">
-              <a:buNone/>
-            </a:pPr>
-            <a:r>
-              <a:rPr lang="en-US" sz="853" kern="100">
-                <a:solidFill>
-                  <a:schemeClr val="tx1"/>
-                </a:solidFill>
-                <a:latin typeface="Consolas" panose="020B0609020204030204" pitchFamily="49" charset="0"/>
-                <a:ea typeface="Calibri" panose="020F0502020204030204" pitchFamily="34" charset="0"/>
-                <a:cs typeface="Calibri Light" panose="020F0302020204030204" pitchFamily="34" charset="0"/>
-              </a:rPr>
-              <a:t> 16:S-Note?</a:t>
-            </a:r>
-          </a:p>
-        </p:txBody>
-      </p:sp>
-      <p:sp>
-        <p:nvSpPr>
-          <p:cNvPr id="24" name="Callout: Bent Line 23">
-            <a:extLst>
-              <a:ext uri="{FF2B5EF4-FFF2-40B4-BE49-F238E27FC236}">
-                <a16:creationId xmlns:a16="http://schemas.microsoft.com/office/drawing/2014/main" id="{5C54F825-3D0E-64C0-E121-67B6A937D248}"/>
-              </a:ext>
-            </a:extLst>
-          </p:cNvPr>
-          <p:cNvSpPr/>
-          <p:nvPr/>
-        </p:nvSpPr>
-        <p:spPr bwMode="auto">
-          <a:xfrm>
-            <a:off x="77984" y="7242193"/>
-            <a:ext cx="861549" cy="822604"/>
-          </a:xfrm>
-          <a:prstGeom prst="borderCallout2">
-            <a:avLst>
-              <a:gd name="adj1" fmla="val -1024"/>
-              <a:gd name="adj2" fmla="val 85567"/>
-              <a:gd name="adj3" fmla="val 366"/>
-              <a:gd name="adj4" fmla="val 82159"/>
-              <a:gd name="adj5" fmla="val 180"/>
-              <a:gd name="adj6" fmla="val 85711"/>
-            </a:avLst>
-          </a:prstGeom>
-          <a:noFill/>
-          <a:ln>
-            <a:prstDash val="dash"/>
-          </a:ln>
-        </p:spPr>
-        <p:style>
-          <a:lnRef idx="2">
-            <a:schemeClr val="accent1">
-              <a:shade val="15000"/>
-            </a:schemeClr>
-          </a:lnRef>
-          <a:fillRef idx="1">
-            <a:schemeClr val="accent1"/>
-          </a:fillRef>
-          <a:effectRef idx="0">
-            <a:schemeClr val="accent1"/>
-          </a:effectRef>
-          <a:fontRef idx="minor">
-            <a:schemeClr val="lt1"/>
-          </a:fontRef>
-        </p:style>
-        <p:txBody>
-          <a:bodyPr rtlCol="1" anchor="ctr"/>
-          <a:lstStyle/>
-          <a:p>
-            <a:pPr rtl="0">
-              <a:buNone/>
-            </a:pPr>
-            <a:r>
-              <a:rPr lang="en-US" sz="853" kern="100">
-                <a:solidFill>
-                  <a:schemeClr val="tx1"/>
-                </a:solidFill>
-                <a:latin typeface="Consolas" panose="020B0609020204030204" pitchFamily="49" charset="0"/>
-                <a:ea typeface="Calibri" panose="020F0502020204030204" pitchFamily="34" charset="0"/>
-                <a:cs typeface="Calibri Light" panose="020F0302020204030204" pitchFamily="34" charset="0"/>
-              </a:rPr>
-              <a:t>UserType</a:t>
-            </a:r>
-          </a:p>
-          <a:p>
-            <a:pPr rtl="0">
-              <a:buNone/>
-            </a:pPr>
-            <a:r>
-              <a:rPr lang="en-US" sz="853" kern="100">
-                <a:solidFill>
-                  <a:schemeClr val="tx1"/>
-                </a:solidFill>
-                <a:latin typeface="Consolas" panose="020B0609020204030204" pitchFamily="49" charset="0"/>
-                <a:ea typeface="Calibri" panose="020F0502020204030204" pitchFamily="34" charset="0"/>
-                <a:cs typeface="Calibri Light" panose="020F0302020204030204" pitchFamily="34" charset="0"/>
-              </a:rPr>
-              <a:t> 1:Teacher</a:t>
-            </a:r>
-          </a:p>
-          <a:p>
-            <a:pPr rtl="0">
-              <a:buNone/>
-            </a:pPr>
-            <a:r>
-              <a:rPr lang="en-US" sz="853" kern="100">
-                <a:solidFill>
-                  <a:schemeClr val="tx1"/>
-                </a:solidFill>
-                <a:latin typeface="Consolas" panose="020B0609020204030204" pitchFamily="49" charset="0"/>
-                <a:ea typeface="Calibri" panose="020F0502020204030204" pitchFamily="34" charset="0"/>
-                <a:cs typeface="Calibri Light" panose="020F0302020204030204" pitchFamily="34" charset="0"/>
-              </a:rPr>
-              <a:t> 2:Student</a:t>
-            </a:r>
-          </a:p>
-          <a:p>
-            <a:pPr rtl="0">
-              <a:buNone/>
-            </a:pPr>
-            <a:r>
-              <a:rPr lang="en-US" sz="853" kern="100">
-                <a:solidFill>
-                  <a:schemeClr val="tx1"/>
-                </a:solidFill>
-                <a:latin typeface="Consolas" panose="020B0609020204030204" pitchFamily="49" charset="0"/>
-                <a:ea typeface="Calibri" panose="020F0502020204030204" pitchFamily="34" charset="0"/>
-                <a:cs typeface="Calibri Light" panose="020F0302020204030204" pitchFamily="34" charset="0"/>
-              </a:rPr>
-              <a:t> </a:t>
-            </a:r>
-          </a:p>
-          <a:p>
-            <a:pPr rtl="0">
-              <a:buNone/>
-            </a:pPr>
-            <a:r>
-              <a:rPr lang="en-US" sz="853" kern="100">
-                <a:solidFill>
-                  <a:schemeClr val="tx1"/>
-                </a:solidFill>
-                <a:latin typeface="Consolas" panose="020B0609020204030204" pitchFamily="49" charset="0"/>
-                <a:ea typeface="Calibri" panose="020F0502020204030204" pitchFamily="34" charset="0"/>
-                <a:cs typeface="Calibri Light" panose="020F0302020204030204" pitchFamily="34" charset="0"/>
-              </a:rPr>
-              <a:t>ProjectTags</a:t>
-            </a:r>
-          </a:p>
-          <a:p>
-            <a:pPr rtl="0">
-              <a:buNone/>
-            </a:pPr>
-            <a:r>
-              <a:rPr lang="en-US" sz="853" kern="100">
-                <a:solidFill>
-                  <a:schemeClr val="tx1"/>
-                </a:solidFill>
-                <a:latin typeface="Consolas" panose="020B0609020204030204" pitchFamily="49" charset="0"/>
-                <a:ea typeface="Calibri" panose="020F0502020204030204" pitchFamily="34" charset="0"/>
-                <a:cs typeface="Calibri Light" panose="020F0302020204030204" pitchFamily="34" charset="0"/>
-              </a:rPr>
-              <a:t> 1:active</a:t>
             </a:r>
           </a:p>
         </p:txBody>
@@ -8816,9 +8332,9 @@
               <a:defRPr/>
             </a:pPr>
             <a:r>
-              <a:rPr lang="en-US" sz="800">
-                <a:solidFill>
-                  <a:schemeClr val="tx1"/>
+              <a:rPr lang="en-US" sz="500">
+                <a:solidFill>
+                  <a:srgbClr val="C00000"/>
                 </a:solidFill>
                 <a:latin typeface="Segoe UI" panose="020B0502040204020203" pitchFamily="34" charset="0"/>
                 <a:cs typeface="Segoe UI" panose="020B0502040204020203" pitchFamily="34" charset="0"/>
@@ -8831,9 +8347,9 @@
               <a:defRPr/>
             </a:pPr>
             <a:r>
-              <a:rPr lang="en-US" sz="800">
-                <a:solidFill>
-                  <a:schemeClr val="tx1"/>
+              <a:rPr lang="en-US" sz="500">
+                <a:solidFill>
+                  <a:srgbClr val="C00000"/>
                 </a:solidFill>
                 <a:latin typeface="Segoe UI" panose="020B0502040204020203" pitchFamily="34" charset="0"/>
                 <a:cs typeface="Segoe UI" panose="020B0502040204020203" pitchFamily="34" charset="0"/>
@@ -8846,14 +8362,219 @@
               <a:defRPr/>
             </a:pPr>
             <a:r>
-              <a:rPr lang="en-US" sz="800">
-                <a:solidFill>
-                  <a:schemeClr val="tx1"/>
+              <a:rPr lang="en-US" sz="500">
+                <a:solidFill>
+                  <a:srgbClr val="C00000"/>
                 </a:solidFill>
                 <a:latin typeface="Segoe UI" panose="020B0502040204020203" pitchFamily="34" charset="0"/>
                 <a:cs typeface="Segoe UI" panose="020B0502040204020203" pitchFamily="34" charset="0"/>
               </a:rPr>
               <a:t>  4:IsDeleted</a:t>
+            </a:r>
+          </a:p>
+        </p:txBody>
+      </p:sp>
+      <p:sp>
+        <p:nvSpPr>
+          <p:cNvPr id="2" name="Rectangle: Rounded Corners 1">
+            <a:extLst>
+              <a:ext uri="{FF2B5EF4-FFF2-40B4-BE49-F238E27FC236}">
+                <a16:creationId xmlns:a16="http://schemas.microsoft.com/office/drawing/2014/main" id="{6A0D2D6C-AD44-BFED-2D51-29757378D5BB}"/>
+              </a:ext>
+            </a:extLst>
+          </p:cNvPr>
+          <p:cNvSpPr/>
+          <p:nvPr/>
+        </p:nvSpPr>
+        <p:spPr>
+          <a:xfrm>
+            <a:off x="2735908" y="6417263"/>
+            <a:ext cx="895415" cy="1634612"/>
+          </a:xfrm>
+          <a:prstGeom prst="roundRect">
+            <a:avLst>
+              <a:gd name="adj" fmla="val 1266"/>
+            </a:avLst>
+          </a:prstGeom>
+          <a:solidFill>
+            <a:schemeClr val="bg1"/>
+          </a:solidFill>
+          <a:ln>
+            <a:solidFill>
+              <a:schemeClr val="tx1">
+                <a:lumMod val="65000"/>
+                <a:lumOff val="35000"/>
+              </a:schemeClr>
+            </a:solidFill>
+          </a:ln>
+        </p:spPr>
+        <p:style>
+          <a:lnRef idx="1">
+            <a:schemeClr val="accent4"/>
+          </a:lnRef>
+          <a:fillRef idx="2">
+            <a:schemeClr val="accent4"/>
+          </a:fillRef>
+          <a:effectRef idx="1">
+            <a:schemeClr val="accent4"/>
+          </a:effectRef>
+          <a:fontRef idx="minor">
+            <a:schemeClr val="dk1"/>
+          </a:fontRef>
+        </p:style>
+        <p:txBody>
+          <a:bodyPr rtlCol="1" anchor="t"/>
+          <a:lstStyle/>
+          <a:p>
+            <a:pPr rtl="0"/>
+            <a:r>
+              <a:rPr lang="en-US" sz="1707" b="1" dirty="0">
+                <a:solidFill>
+                  <a:schemeClr val="bg1"/>
+                </a:solidFill>
+                <a:highlight>
+                  <a:srgbClr val="000000"/>
+                </a:highlight>
+              </a:rPr>
+              <a:t>N</a:t>
+            </a:r>
+            <a:r>
+              <a:rPr lang="en-US" sz="1280" b="1" dirty="0"/>
+              <a:t>otes</a:t>
+            </a:r>
+          </a:p>
+          <a:p>
+            <a:pPr rtl="0"/>
+            <a:r>
+              <a:rPr lang="en-US" sz="853" i="1">
+                <a:solidFill>
+                  <a:schemeClr val="accent5"/>
+                </a:solidFill>
+                <a:latin typeface="Segoe UI" panose="020B0502040204020203" pitchFamily="34" charset="0"/>
+                <a:cs typeface="Segoe UI" panose="020B0502040204020203" pitchFamily="34" charset="0"/>
+              </a:rPr>
+              <a:t>NoteId</a:t>
+            </a:r>
+          </a:p>
+          <a:p>
+            <a:pPr rtl="0"/>
+            <a:r>
+              <a:rPr lang="en-US" sz="853"/>
+              <a:t>NoteType</a:t>
+            </a:r>
+          </a:p>
+          <a:p>
+            <a:pPr rtl="0"/>
+            <a:r>
+              <a:rPr lang="en-US" sz="853"/>
+              <a:t>ReferenceId</a:t>
+            </a:r>
+          </a:p>
+          <a:p>
+            <a:pPr rtl="0"/>
+            <a:r>
+              <a:rPr lang="en-US" sz="853"/>
+              <a:t>NoteDateTime</a:t>
+            </a:r>
+            <a:endParaRPr lang="en-US" sz="853" dirty="0"/>
+          </a:p>
+          <a:p>
+            <a:pPr rtl="0"/>
+            <a:r>
+              <a:rPr lang="en-US" sz="853"/>
+              <a:t>NoteText</a:t>
+            </a:r>
+            <a:endParaRPr lang="en-US" sz="853" dirty="0"/>
+          </a:p>
+          <a:p>
+            <a:pPr rtl="0"/>
+            <a:r>
+              <a:rPr lang="en-US" sz="853">
+                <a:solidFill>
+                  <a:schemeClr val="tx1"/>
+                </a:solidFill>
+              </a:rPr>
+              <a:t>CreatorId</a:t>
+            </a:r>
+            <a:endParaRPr lang="fa-IR" sz="853">
+              <a:solidFill>
+                <a:schemeClr val="tx1"/>
+              </a:solidFill>
+            </a:endParaRPr>
+          </a:p>
+          <a:p>
+            <a:pPr rtl="0"/>
+            <a:r>
+              <a:rPr lang="en-US" sz="853">
+                <a:solidFill>
+                  <a:schemeClr val="tx1"/>
+                </a:solidFill>
+              </a:rPr>
+              <a:t>NoteTags</a:t>
+            </a:r>
+          </a:p>
+          <a:p>
+            <a:pPr rtl="0">
+              <a:buNone/>
+            </a:pPr>
+            <a:r>
+              <a:rPr lang="en-US" sz="500" kern="100">
+                <a:solidFill>
+                  <a:srgbClr val="C00000"/>
+                </a:solidFill>
+                <a:latin typeface="Consolas" panose="020B0609020204030204" pitchFamily="49" charset="0"/>
+                <a:ea typeface="Calibri" panose="020F0502020204030204" pitchFamily="34" charset="0"/>
+                <a:cs typeface="Calibri Light" panose="020F0302020204030204" pitchFamily="34" charset="0"/>
+              </a:rPr>
+              <a:t> 1:IsRtl</a:t>
+            </a:r>
+          </a:p>
+          <a:p>
+            <a:pPr rtl="0">
+              <a:buNone/>
+            </a:pPr>
+            <a:r>
+              <a:rPr lang="en-US" sz="500" kern="100">
+                <a:solidFill>
+                  <a:srgbClr val="C00000"/>
+                </a:solidFill>
+                <a:latin typeface="Consolas" panose="020B0609020204030204" pitchFamily="49" charset="0"/>
+                <a:ea typeface="Calibri" panose="020F0502020204030204" pitchFamily="34" charset="0"/>
+                <a:cs typeface="Calibri Light" panose="020F0302020204030204" pitchFamily="34" charset="0"/>
+              </a:rPr>
+              <a:t> 2:IsDone</a:t>
+            </a:r>
+          </a:p>
+          <a:p>
+            <a:pPr rtl="0">
+              <a:buNone/>
+            </a:pPr>
+            <a:r>
+              <a:rPr lang="en-US" sz="500" kern="100">
+                <a:solidFill>
+                  <a:srgbClr val="C00000"/>
+                </a:solidFill>
+                <a:latin typeface="Consolas" panose="020B0609020204030204" pitchFamily="49" charset="0"/>
+                <a:ea typeface="Calibri" panose="020F0502020204030204" pitchFamily="34" charset="0"/>
+                <a:cs typeface="Calibri Light" panose="020F0302020204030204" pitchFamily="34" charset="0"/>
+              </a:rPr>
+              <a:t> 4:IsShared</a:t>
+            </a:r>
+          </a:p>
+          <a:p>
+            <a:pPr rtl="0">
+              <a:buNone/>
+            </a:pPr>
+            <a:r>
+              <a:rPr lang="en-US" sz="500" kern="100">
+                <a:solidFill>
+                  <a:srgbClr val="C00000"/>
+                </a:solidFill>
+                <a:latin typeface="Consolas" panose="020B0609020204030204" pitchFamily="49" charset="0"/>
+                <a:ea typeface="Calibri" panose="020F0502020204030204" pitchFamily="34" charset="0"/>
+                <a:cs typeface="Calibri Light" panose="020F0302020204030204" pitchFamily="34" charset="0"/>
+              </a:rPr>
+              <a:t> 8:IsReadonly</a:t>
             </a:r>
           </a:p>
         </p:txBody>

</xml_diff>

<commit_message>
- Department table added - super user added - browser info added
</commit_message>
<xml_diff>
--- a/ExaminerB/.appCatalog/ExaminerB notes 1404.pptx
+++ b/ExaminerB/.appCatalog/ExaminerB notes 1404.pptx
@@ -280,7 +280,7 @@
             </a:pPr>
             <a:fld id="{BCC18F51-09EC-435C-A3BA-64A766E099C0}" type="datetimeFigureOut">
               <a:rPr lang="fa-IR"/>
-              <a:t>15/01/1448</a:t>
+              <a:t>18/01/1448</a:t>
             </a:fld>
             <a:endParaRPr/>
           </a:p>
@@ -459,7 +459,7 @@
             </a:pPr>
             <a:fld id="{BCC18F51-09EC-435C-A3BA-64A766E099C0}" type="datetimeFigureOut">
               <a:rPr lang="fa-IR"/>
-              <a:t>15/01/1448</a:t>
+              <a:t>18/01/1448</a:t>
             </a:fld>
             <a:endParaRPr/>
           </a:p>
@@ -648,7 +648,7 @@
             </a:pPr>
             <a:fld id="{BCC18F51-09EC-435C-A3BA-64A766E099C0}" type="datetimeFigureOut">
               <a:rPr lang="fa-IR"/>
-              <a:t>15/01/1448</a:t>
+              <a:t>18/01/1448</a:t>
             </a:fld>
             <a:endParaRPr/>
           </a:p>
@@ -827,7 +827,7 @@
             </a:pPr>
             <a:fld id="{BCC18F51-09EC-435C-A3BA-64A766E099C0}" type="datetimeFigureOut">
               <a:rPr lang="fa-IR"/>
-              <a:t>15/01/1448</a:t>
+              <a:t>18/01/1448</a:t>
             </a:fld>
             <a:endParaRPr/>
           </a:p>
@@ -1079,7 +1079,7 @@
             </a:pPr>
             <a:fld id="{BCC18F51-09EC-435C-A3BA-64A766E099C0}" type="datetimeFigureOut">
               <a:rPr lang="fa-IR"/>
-              <a:t>15/01/1448</a:t>
+              <a:t>18/01/1448</a:t>
             </a:fld>
             <a:endParaRPr/>
           </a:p>
@@ -1324,7 +1324,7 @@
             </a:pPr>
             <a:fld id="{BCC18F51-09EC-435C-A3BA-64A766E099C0}" type="datetimeFigureOut">
               <a:rPr lang="fa-IR"/>
-              <a:t>15/01/1448</a:t>
+              <a:t>18/01/1448</a:t>
             </a:fld>
             <a:endParaRPr/>
           </a:p>
@@ -1706,7 +1706,7 @@
             </a:pPr>
             <a:fld id="{BCC18F51-09EC-435C-A3BA-64A766E099C0}" type="datetimeFigureOut">
               <a:rPr lang="fa-IR"/>
-              <a:t>15/01/1448</a:t>
+              <a:t>18/01/1448</a:t>
             </a:fld>
             <a:endParaRPr/>
           </a:p>
@@ -1829,7 +1829,7 @@
             </a:pPr>
             <a:fld id="{BCC18F51-09EC-435C-A3BA-64A766E099C0}" type="datetimeFigureOut">
               <a:rPr lang="fa-IR"/>
-              <a:t>15/01/1448</a:t>
+              <a:t>18/01/1448</a:t>
             </a:fld>
             <a:endParaRPr/>
           </a:p>
@@ -1928,7 +1928,7 @@
             </a:pPr>
             <a:fld id="{BCC18F51-09EC-435C-A3BA-64A766E099C0}" type="datetimeFigureOut">
               <a:rPr lang="fa-IR"/>
-              <a:t>15/01/1448</a:t>
+              <a:t>18/01/1448</a:t>
             </a:fld>
             <a:endParaRPr/>
           </a:p>
@@ -2215,7 +2215,7 @@
             </a:pPr>
             <a:fld id="{BCC18F51-09EC-435C-A3BA-64A766E099C0}" type="datetimeFigureOut">
               <a:rPr lang="fa-IR"/>
-              <a:t>15/01/1448</a:t>
+              <a:t>18/01/1448</a:t>
             </a:fld>
             <a:endParaRPr/>
           </a:p>
@@ -2479,7 +2479,7 @@
             </a:pPr>
             <a:fld id="{BCC18F51-09EC-435C-A3BA-64A766E099C0}" type="datetimeFigureOut">
               <a:rPr lang="fa-IR"/>
-              <a:t>15/01/1448</a:t>
+              <a:t>18/01/1448</a:t>
             </a:fld>
             <a:endParaRPr/>
           </a:p>
@@ -2701,7 +2701,7 @@
             </a:pPr>
             <a:fld id="{BCC18F51-09EC-435C-A3BA-64A766E099C0}" type="datetimeFigureOut">
               <a:rPr lang="fa-IR"/>
-              <a:t>15/01/1448</a:t>
+              <a:t>18/01/1448</a:t>
             </a:fld>
             <a:endParaRPr/>
           </a:p>
@@ -3127,8 +3127,8 @@
         </p:nvSpPr>
         <p:spPr bwMode="auto">
           <a:xfrm>
-            <a:off x="1359989" y="3712532"/>
-            <a:ext cx="1757728" cy="1831986"/>
+            <a:off x="1359989" y="3928228"/>
+            <a:ext cx="1757728" cy="1759977"/>
           </a:xfrm>
           <a:prstGeom prst="roundRect">
             <a:avLst>
@@ -3395,7 +3395,7 @@
         </p:blipFill>
         <p:spPr>
           <a:xfrm>
-            <a:off x="10368756" y="8280821"/>
+            <a:off x="99748" y="8109307"/>
             <a:ext cx="1037872" cy="236733"/>
           </a:xfrm>
           <a:prstGeom prst="rect">
@@ -3417,329 +3417,6 @@
       </p:pic>
       <p:sp>
         <p:nvSpPr>
-          <p:cNvPr id="23" name="Rectangle: Rounded Corners 44">
-            <a:extLst>
-              <a:ext uri="{FF2B5EF4-FFF2-40B4-BE49-F238E27FC236}">
-                <a16:creationId xmlns:a16="http://schemas.microsoft.com/office/drawing/2014/main" id="{60EEA583-4825-92D1-3BD6-2EFF827734DE}"/>
-              </a:ext>
-            </a:extLst>
-          </p:cNvPr>
-          <p:cNvSpPr/>
-          <p:nvPr/>
-        </p:nvSpPr>
-        <p:spPr bwMode="auto">
-          <a:xfrm>
-            <a:off x="9107253" y="359941"/>
-            <a:ext cx="1261503" cy="1756036"/>
-          </a:xfrm>
-          <a:prstGeom prst="roundRect">
-            <a:avLst>
-              <a:gd name="adj" fmla="val 9941"/>
-            </a:avLst>
-          </a:prstGeom>
-          <a:solidFill>
-            <a:schemeClr val="bg1"/>
-          </a:solidFill>
-          <a:ln>
-            <a:solidFill>
-              <a:schemeClr val="tx1"/>
-            </a:solidFill>
-          </a:ln>
-          <a:effectLst/>
-        </p:spPr>
-        <p:style>
-          <a:lnRef idx="0">
-            <a:schemeClr val="accent4"/>
-          </a:lnRef>
-          <a:fillRef idx="3">
-            <a:schemeClr val="accent4"/>
-          </a:fillRef>
-          <a:effectRef idx="3">
-            <a:schemeClr val="accent4"/>
-          </a:effectRef>
-          <a:fontRef idx="minor">
-            <a:schemeClr val="lt1"/>
-          </a:fontRef>
-        </p:style>
-        <p:txBody>
-          <a:bodyPr rtlCol="1" anchor="ctr"/>
-          <a:lstStyle/>
-          <a:p>
-            <a:pPr rtl="0">
-              <a:defRPr/>
-            </a:pPr>
-            <a:r>
-              <a:rPr lang="en-US" sz="1707" b="1">
-                <a:solidFill>
-                  <a:schemeClr val="bg1"/>
-                </a:solidFill>
-                <a:highlight>
-                  <a:srgbClr val="008080"/>
-                </a:highlight>
-                <a:latin typeface="Segoe UI" panose="020B0502040204020203" pitchFamily="34" charset="0"/>
-                <a:cs typeface="Segoe UI" panose="020B0502040204020203" pitchFamily="34" charset="0"/>
-              </a:rPr>
-              <a:t>U</a:t>
-            </a:r>
-          </a:p>
-          <a:p>
-            <a:pPr rtl="0">
-              <a:defRPr/>
-            </a:pPr>
-            <a:r>
-              <a:rPr lang="en-US" sz="1280" b="1">
-                <a:solidFill>
-                  <a:schemeClr val="tx1"/>
-                </a:solidFill>
-                <a:latin typeface="Segoe UI" panose="020B0502040204020203" pitchFamily="34" charset="0"/>
-                <a:cs typeface="Segoe UI" panose="020B0502040204020203" pitchFamily="34" charset="0"/>
-              </a:rPr>
-              <a:t>usrs</a:t>
-            </a:r>
-            <a:endParaRPr sz="1280">
-              <a:solidFill>
-                <a:schemeClr val="tx1"/>
-              </a:solidFill>
-              <a:latin typeface="Segoe UI" panose="020B0502040204020203" pitchFamily="34" charset="0"/>
-              <a:cs typeface="Segoe UI" panose="020B0502040204020203" pitchFamily="34" charset="0"/>
-            </a:endParaRPr>
-          </a:p>
-          <a:p>
-            <a:pPr rtl="0">
-              <a:defRPr/>
-            </a:pPr>
-            <a:r>
-              <a:rPr lang="en-US" sz="853" i="1">
-                <a:solidFill>
-                  <a:schemeClr val="accent5"/>
-                </a:solidFill>
-                <a:latin typeface="Segoe UI" panose="020B0502040204020203" pitchFamily="34" charset="0"/>
-                <a:cs typeface="Segoe UI" panose="020B0502040204020203" pitchFamily="34" charset="0"/>
-              </a:rPr>
-              <a:t>UsrId</a:t>
-            </a:r>
-          </a:p>
-          <a:p>
-            <a:pPr rtl="0">
-              <a:defRPr/>
-            </a:pPr>
-            <a:r>
-              <a:rPr lang="en-US" sz="853">
-                <a:solidFill>
-                  <a:schemeClr val="tx1"/>
-                </a:solidFill>
-                <a:latin typeface="Segoe UI" panose="020B0502040204020203" pitchFamily="34" charset="0"/>
-                <a:cs typeface="Segoe UI" panose="020B0502040204020203" pitchFamily="34" charset="0"/>
-              </a:rPr>
-              <a:t>UsrName</a:t>
-            </a:r>
-          </a:p>
-          <a:p>
-            <a:pPr rtl="0">
-              <a:defRPr/>
-            </a:pPr>
-            <a:r>
-              <a:rPr lang="en-US" sz="853">
-                <a:solidFill>
-                  <a:schemeClr val="tx1"/>
-                </a:solidFill>
-                <a:latin typeface="Segoe UI" panose="020B0502040204020203" pitchFamily="34" charset="0"/>
-                <a:cs typeface="Segoe UI" panose="020B0502040204020203" pitchFamily="34" charset="0"/>
-              </a:rPr>
-              <a:t>UsrPass</a:t>
-            </a:r>
-          </a:p>
-          <a:p>
-            <a:pPr rtl="0">
-              <a:defRPr/>
-            </a:pPr>
-            <a:r>
-              <a:rPr lang="en-US" sz="853">
-                <a:solidFill>
-                  <a:schemeClr val="tx1"/>
-                </a:solidFill>
-                <a:latin typeface="Segoe UI" panose="020B0502040204020203" pitchFamily="34" charset="0"/>
-                <a:cs typeface="Segoe UI" panose="020B0502040204020203" pitchFamily="34" charset="0"/>
-              </a:rPr>
-              <a:t>UsrNickname</a:t>
-            </a:r>
-          </a:p>
-          <a:p>
-            <a:pPr rtl="0">
-              <a:defRPr/>
-            </a:pPr>
-            <a:r>
-              <a:rPr lang="en-US" sz="853">
-                <a:solidFill>
-                  <a:schemeClr val="tx1"/>
-                </a:solidFill>
-                <a:latin typeface="Segoe UI" panose="020B0502040204020203" pitchFamily="34" charset="0"/>
-                <a:cs typeface="Segoe UI" panose="020B0502040204020203" pitchFamily="34" charset="0"/>
-              </a:rPr>
-              <a:t>UsrTags</a:t>
-            </a:r>
-            <a:r>
-              <a:rPr lang="en-US" sz="853">
-                <a:solidFill>
-                  <a:srgbClr val="C00000"/>
-                </a:solidFill>
-                <a:latin typeface="Segoe UI" panose="020B0502040204020203" pitchFamily="34" charset="0"/>
-                <a:cs typeface="Segoe UI" panose="020B0502040204020203" pitchFamily="34" charset="0"/>
-              </a:rPr>
-              <a:t> </a:t>
-            </a:r>
-          </a:p>
-          <a:p>
-            <a:pPr marL="90488" rtl="0">
-              <a:defRPr/>
-            </a:pPr>
-            <a:r>
-              <a:rPr lang="en-US" sz="500">
-                <a:solidFill>
-                  <a:srgbClr val="C00000"/>
-                </a:solidFill>
-                <a:latin typeface="Segoe UI" panose="020B0502040204020203" pitchFamily="34" charset="0"/>
-                <a:cs typeface="Segoe UI" panose="020B0502040204020203" pitchFamily="34" charset="0"/>
-              </a:rPr>
-              <a:t>1: IsActive</a:t>
-            </a:r>
-          </a:p>
-          <a:p>
-            <a:pPr marL="90488" rtl="0">
-              <a:defRPr/>
-            </a:pPr>
-            <a:r>
-              <a:rPr lang="en-US" sz="500">
-                <a:solidFill>
-                  <a:srgbClr val="C00000"/>
-                </a:solidFill>
-                <a:latin typeface="Segoe UI" panose="020B0502040204020203" pitchFamily="34" charset="0"/>
-                <a:cs typeface="Segoe UI" panose="020B0502040204020203" pitchFamily="34" charset="0"/>
-              </a:rPr>
-              <a:t>2: ChangePass</a:t>
-            </a:r>
-          </a:p>
-          <a:p>
-            <a:pPr marL="90488" rtl="0">
-              <a:defRPr/>
-            </a:pPr>
-            <a:r>
-              <a:rPr lang="en-US" sz="500">
-                <a:solidFill>
-                  <a:srgbClr val="C00000"/>
-                </a:solidFill>
-                <a:latin typeface="Segoe UI" panose="020B0502040204020203" pitchFamily="34" charset="0"/>
-                <a:cs typeface="Segoe UI" panose="020B0502040204020203" pitchFamily="34" charset="0"/>
-              </a:rPr>
-              <a:t>4: -</a:t>
-            </a:r>
-          </a:p>
-          <a:p>
-            <a:pPr marL="90488" rtl="0">
-              <a:defRPr/>
-            </a:pPr>
-            <a:r>
-              <a:rPr lang="en-US" sz="500">
-                <a:solidFill>
-                  <a:srgbClr val="C00000"/>
-                </a:solidFill>
-                <a:latin typeface="Segoe UI" panose="020B0502040204020203" pitchFamily="34" charset="0"/>
-                <a:cs typeface="Segoe UI" panose="020B0502040204020203" pitchFamily="34" charset="0"/>
-              </a:rPr>
-              <a:t>8: -</a:t>
-            </a:r>
-          </a:p>
-          <a:p>
-            <a:pPr marL="90488" rtl="0">
-              <a:defRPr/>
-            </a:pPr>
-            <a:r>
-              <a:rPr lang="en-US" sz="500">
-                <a:solidFill>
-                  <a:srgbClr val="C00000"/>
-                </a:solidFill>
-                <a:latin typeface="Segoe UI" panose="020B0502040204020203" pitchFamily="34" charset="0"/>
-                <a:cs typeface="Segoe UI" panose="020B0502040204020203" pitchFamily="34" charset="0"/>
-              </a:rPr>
-              <a:t>16: -</a:t>
-            </a:r>
-          </a:p>
-          <a:p>
-            <a:pPr marL="90488" rtl="0">
-              <a:defRPr/>
-            </a:pPr>
-            <a:r>
-              <a:rPr lang="en-US" sz="500">
-                <a:solidFill>
-                  <a:srgbClr val="C00000"/>
-                </a:solidFill>
-                <a:latin typeface="Segoe UI" panose="020B0502040204020203" pitchFamily="34" charset="0"/>
-                <a:cs typeface="Segoe UI" panose="020B0502040204020203" pitchFamily="34" charset="0"/>
-              </a:rPr>
-              <a:t>32: -</a:t>
-            </a:r>
-          </a:p>
-          <a:p>
-            <a:pPr marL="90488" rtl="0">
-              <a:defRPr/>
-            </a:pPr>
-            <a:r>
-              <a:rPr lang="en-US" sz="500">
-                <a:solidFill>
-                  <a:srgbClr val="C00000"/>
-                </a:solidFill>
-                <a:latin typeface="Segoe UI" panose="020B0502040204020203" pitchFamily="34" charset="0"/>
-                <a:cs typeface="Segoe UI" panose="020B0502040204020203" pitchFamily="34" charset="0"/>
-              </a:rPr>
-              <a:t>64: -</a:t>
-            </a:r>
-          </a:p>
-          <a:p>
-            <a:pPr marL="90488" rtl="0">
-              <a:defRPr/>
-            </a:pPr>
-            <a:r>
-              <a:rPr lang="en-US" sz="500">
-                <a:solidFill>
-                  <a:srgbClr val="C00000"/>
-                </a:solidFill>
-                <a:latin typeface="Segoe UI" panose="020B0502040204020203" pitchFamily="34" charset="0"/>
-                <a:cs typeface="Segoe UI" panose="020B0502040204020203" pitchFamily="34" charset="0"/>
-              </a:rPr>
-              <a:t>128: -</a:t>
-            </a:r>
-          </a:p>
-          <a:p>
-            <a:pPr marL="90488" rtl="0">
-              <a:defRPr/>
-            </a:pPr>
-            <a:r>
-              <a:rPr lang="en-US" sz="500">
-                <a:solidFill>
-                  <a:srgbClr val="C00000"/>
-                </a:solidFill>
-                <a:latin typeface="Segoe UI" panose="020B0502040204020203" pitchFamily="34" charset="0"/>
-                <a:cs typeface="Segoe UI" panose="020B0502040204020203" pitchFamily="34" charset="0"/>
-              </a:rPr>
-              <a:t>256: CalendarFa</a:t>
-            </a:r>
-          </a:p>
-          <a:p>
-            <a:pPr rtl="0">
-              <a:defRPr/>
-            </a:pPr>
-            <a:endParaRPr lang="en-US" sz="500">
-              <a:solidFill>
-                <a:srgbClr val="C00000"/>
-              </a:solidFill>
-              <a:latin typeface="Segoe UI" panose="020B0502040204020203" pitchFamily="34" charset="0"/>
-              <a:cs typeface="Segoe UI" panose="020B0502040204020203" pitchFamily="34" charset="0"/>
-            </a:endParaRPr>
-          </a:p>
-        </p:txBody>
-      </p:sp>
-      <p:sp>
-        <p:nvSpPr>
           <p:cNvPr id="8" name="Rectangle: Rounded Corners 18">
             <a:extLst>
               <a:ext uri="{FF2B5EF4-FFF2-40B4-BE49-F238E27FC236}">
@@ -3752,8 +3429,8 @@
         </p:nvSpPr>
         <p:spPr bwMode="auto">
           <a:xfrm>
-            <a:off x="4511934" y="894865"/>
-            <a:ext cx="1824374" cy="1059998"/>
+            <a:off x="4398629" y="1152028"/>
+            <a:ext cx="1937679" cy="1179645"/>
           </a:xfrm>
           <a:prstGeom prst="roundRect">
             <a:avLst>
@@ -3873,6 +3550,30 @@
               <a:t>CourseTopicTitle</a:t>
             </a:r>
           </a:p>
+          <a:p>
+            <a:pPr rtl="0">
+              <a:defRPr/>
+            </a:pPr>
+            <a:endParaRPr lang="en-US" sz="853">
+              <a:solidFill>
+                <a:schemeClr val="tx1"/>
+              </a:solidFill>
+              <a:latin typeface="Segoe UI" panose="020B0502040204020203" pitchFamily="34" charset="0"/>
+              <a:cs typeface="Segoe UI" panose="020B0502040204020203" pitchFamily="34" charset="0"/>
+            </a:endParaRPr>
+          </a:p>
+          <a:p>
+            <a:pPr rtl="0">
+              <a:defRPr/>
+            </a:pPr>
+            <a:endParaRPr lang="en-US" sz="853">
+              <a:solidFill>
+                <a:schemeClr val="tx1"/>
+              </a:solidFill>
+              <a:latin typeface="Segoe UI" panose="020B0502040204020203" pitchFamily="34" charset="0"/>
+              <a:cs typeface="Segoe UI" panose="020B0502040204020203" pitchFamily="34" charset="0"/>
+            </a:endParaRPr>
+          </a:p>
         </p:txBody>
       </p:sp>
       <p:sp>
@@ -3889,7 +3590,7 @@
         </p:nvSpPr>
         <p:spPr bwMode="auto">
           <a:xfrm>
-            <a:off x="8050056" y="2944397"/>
+            <a:off x="8050056" y="3160093"/>
             <a:ext cx="2065492" cy="2435984"/>
           </a:xfrm>
           <a:prstGeom prst="roundRect">
@@ -4133,8 +3834,8 @@
         </p:nvSpPr>
         <p:spPr bwMode="auto">
           <a:xfrm>
-            <a:off x="9979322" y="3652993"/>
-            <a:ext cx="1261502" cy="1387474"/>
+            <a:off x="9792692" y="3888333"/>
+            <a:ext cx="1261502" cy="1243452"/>
           </a:xfrm>
           <a:prstGeom prst="roundRect">
             <a:avLst>
@@ -4323,8 +4024,8 @@
         </p:nvSpPr>
         <p:spPr bwMode="auto">
           <a:xfrm>
-            <a:off x="4686211" y="6369915"/>
-            <a:ext cx="1722105" cy="1226651"/>
+            <a:off x="4686211" y="6480621"/>
+            <a:ext cx="1722105" cy="1190826"/>
           </a:xfrm>
           <a:prstGeom prst="roundRect">
             <a:avLst>
@@ -4500,8 +4201,8 @@
         </p:nvSpPr>
         <p:spPr bwMode="auto">
           <a:xfrm>
-            <a:off x="3860208" y="2944397"/>
-            <a:ext cx="1855656" cy="2144040"/>
+            <a:off x="3860208" y="3160092"/>
+            <a:ext cx="1855656" cy="2078683"/>
           </a:xfrm>
           <a:prstGeom prst="roundRect">
             <a:avLst>
@@ -4589,208 +4290,228 @@
               </a:rPr>
               <a:t>StudentId</a:t>
             </a:r>
-            <a:endParaRPr lang="en-US" sz="853">
+          </a:p>
+          <a:p>
+            <a:pPr marL="189651" rtl="0">
+              <a:defRPr/>
+            </a:pPr>
+            <a:r>
+              <a:rPr lang="en-US" sz="853">
+                <a:solidFill>
+                  <a:schemeClr val="tx1"/>
+                </a:solidFill>
+                <a:latin typeface="Segoe UI" panose="020B0502040204020203" pitchFamily="34" charset="0"/>
+                <a:cs typeface="Segoe UI" panose="020B0502040204020203" pitchFamily="34" charset="0"/>
+              </a:rPr>
+              <a:t>DepartmentId</a:t>
+            </a:r>
+          </a:p>
+          <a:p>
+            <a:pPr marL="189651" rtl="0">
+              <a:defRPr/>
+            </a:pPr>
+            <a:r>
+              <a:rPr lang="en-US" sz="853">
+                <a:solidFill>
+                  <a:schemeClr val="tx1"/>
+                </a:solidFill>
+                <a:latin typeface="Segoe UI" panose="020B0502040204020203" pitchFamily="34" charset="0"/>
+                <a:cs typeface="Segoe UI" panose="020B0502040204020203" pitchFamily="34" charset="0"/>
+              </a:rPr>
+              <a:t>StudentName</a:t>
+            </a:r>
+          </a:p>
+          <a:p>
+            <a:pPr marL="189651" rtl="0">
+              <a:defRPr/>
+            </a:pPr>
+            <a:r>
+              <a:rPr lang="en-US" sz="853">
+                <a:solidFill>
+                  <a:schemeClr val="tx1"/>
+                </a:solidFill>
+                <a:latin typeface="Segoe UI" panose="020B0502040204020203" pitchFamily="34" charset="0"/>
+                <a:cs typeface="Segoe UI" panose="020B0502040204020203" pitchFamily="34" charset="0"/>
+              </a:rPr>
+              <a:t>StudentPass</a:t>
+            </a:r>
+          </a:p>
+          <a:p>
+            <a:pPr marL="189651" rtl="0">
+              <a:defRPr/>
+            </a:pPr>
+            <a:r>
+              <a:rPr lang="en-US" sz="853">
+                <a:solidFill>
+                  <a:schemeClr val="tx1"/>
+                </a:solidFill>
+                <a:latin typeface="Segoe UI" panose="020B0502040204020203" pitchFamily="34" charset="0"/>
+                <a:cs typeface="Segoe UI" panose="020B0502040204020203" pitchFamily="34" charset="0"/>
+              </a:rPr>
+              <a:t>StudentNickname</a:t>
+            </a:r>
+          </a:p>
+          <a:p>
+            <a:pPr marL="189651" rtl="0">
+              <a:defRPr/>
+            </a:pPr>
+            <a:r>
+              <a:rPr lang="en-US" sz="853">
+                <a:solidFill>
+                  <a:schemeClr val="tx1"/>
+                </a:solidFill>
+                <a:latin typeface="Segoe UI" panose="020B0502040204020203" pitchFamily="34" charset="0"/>
+                <a:cs typeface="Segoe UI" panose="020B0502040204020203" pitchFamily="34" charset="0"/>
+              </a:rPr>
+              <a:t>StudentTags</a:t>
+            </a:r>
+          </a:p>
+          <a:p>
+            <a:pPr marL="176213" rtl="0">
+              <a:defRPr/>
+            </a:pPr>
+            <a:r>
+              <a:rPr lang="en-US" sz="500">
+                <a:solidFill>
+                  <a:srgbClr val="C00000"/>
+                </a:solidFill>
+                <a:latin typeface="Segoe UI" panose="020B0502040204020203" pitchFamily="34" charset="0"/>
+                <a:cs typeface="Segoe UI" panose="020B0502040204020203" pitchFamily="34" charset="0"/>
+              </a:rPr>
+              <a:t>1: IsActive</a:t>
+            </a:r>
+          </a:p>
+          <a:p>
+            <a:pPr marL="176213" rtl="0">
+              <a:defRPr/>
+            </a:pPr>
+            <a:r>
+              <a:rPr lang="en-US" sz="500">
+                <a:solidFill>
+                  <a:srgbClr val="C00000"/>
+                </a:solidFill>
+                <a:latin typeface="Segoe UI" panose="020B0502040204020203" pitchFamily="34" charset="0"/>
+                <a:cs typeface="Segoe UI" panose="020B0502040204020203" pitchFamily="34" charset="0"/>
+              </a:rPr>
+              <a:t>2: ChangePass</a:t>
+            </a:r>
+          </a:p>
+          <a:p>
+            <a:pPr marL="176213" rtl="0">
+              <a:defRPr/>
+            </a:pPr>
+            <a:r>
+              <a:rPr lang="en-US" sz="500">
+                <a:solidFill>
+                  <a:srgbClr val="C00000"/>
+                </a:solidFill>
+                <a:latin typeface="Segoe UI" panose="020B0502040204020203" pitchFamily="34" charset="0"/>
+                <a:cs typeface="Segoe UI" panose="020B0502040204020203" pitchFamily="34" charset="0"/>
+              </a:rPr>
+              <a:t>4: ReviewEx</a:t>
+            </a:r>
+          </a:p>
+          <a:p>
+            <a:pPr marL="176213" rtl="0">
+              <a:defRPr/>
+            </a:pPr>
+            <a:r>
+              <a:rPr lang="en-US" sz="500">
+                <a:solidFill>
+                  <a:srgbClr val="C00000"/>
+                </a:solidFill>
+                <a:latin typeface="Segoe UI" panose="020B0502040204020203" pitchFamily="34" charset="0"/>
+                <a:cs typeface="Segoe UI" panose="020B0502040204020203" pitchFamily="34" charset="0"/>
+              </a:rPr>
+              <a:t>8: GetStExTests</a:t>
+            </a:r>
+          </a:p>
+          <a:p>
+            <a:pPr marL="176213" rtl="0">
+              <a:defRPr/>
+            </a:pPr>
+            <a:r>
+              <a:rPr lang="en-US" sz="500">
+                <a:solidFill>
+                  <a:srgbClr val="C00000"/>
+                </a:solidFill>
+                <a:latin typeface="Segoe UI" panose="020B0502040204020203" pitchFamily="34" charset="0"/>
+                <a:cs typeface="Segoe UI" panose="020B0502040204020203" pitchFamily="34" charset="0"/>
+              </a:rPr>
+              <a:t>16: CorrectStExTests</a:t>
+            </a:r>
+          </a:p>
+          <a:p>
+            <a:pPr marL="176213" rtl="0">
+              <a:defRPr/>
+            </a:pPr>
+            <a:r>
+              <a:rPr lang="en-US" sz="500">
+                <a:solidFill>
+                  <a:srgbClr val="C00000"/>
+                </a:solidFill>
+                <a:latin typeface="Segoe UI" panose="020B0502040204020203" pitchFamily="34" charset="0"/>
+                <a:cs typeface="Segoe UI" panose="020B0502040204020203" pitchFamily="34" charset="0"/>
+              </a:rPr>
+              <a:t>32: RevStExTests</a:t>
+            </a:r>
+          </a:p>
+          <a:p>
+            <a:pPr marL="176213" rtl="0">
+              <a:defRPr/>
+            </a:pPr>
+            <a:r>
+              <a:rPr lang="en-US" sz="500">
+                <a:solidFill>
+                  <a:srgbClr val="C00000"/>
+                </a:solidFill>
+                <a:latin typeface="Segoe UI" panose="020B0502040204020203" pitchFamily="34" charset="0"/>
+                <a:cs typeface="Segoe UI" panose="020B0502040204020203" pitchFamily="34" charset="0"/>
+              </a:rPr>
+              <a:t>64: IsSelected</a:t>
+            </a:r>
+          </a:p>
+          <a:p>
+            <a:pPr marL="176213" rtl="0">
+              <a:defRPr/>
+            </a:pPr>
+            <a:r>
+              <a:rPr lang="en-US" sz="500">
+                <a:solidFill>
+                  <a:srgbClr val="C00000"/>
+                </a:solidFill>
+                <a:latin typeface="Segoe UI" panose="020B0502040204020203" pitchFamily="34" charset="0"/>
+                <a:cs typeface="Segoe UI" panose="020B0502040204020203" pitchFamily="34" charset="0"/>
+              </a:rPr>
+              <a:t>128:</a:t>
+            </a:r>
+          </a:p>
+          <a:p>
+            <a:pPr marL="176213" rtl="0">
+              <a:defRPr/>
+            </a:pPr>
+            <a:r>
+              <a:rPr lang="en-US" sz="500">
+                <a:solidFill>
+                  <a:srgbClr val="C00000"/>
+                </a:solidFill>
+                <a:latin typeface="Segoe UI" panose="020B0502040204020203" pitchFamily="34" charset="0"/>
+                <a:cs typeface="Segoe UI" panose="020B0502040204020203" pitchFamily="34" charset="0"/>
+              </a:rPr>
+              <a:t>256: CalendarFa</a:t>
+            </a:r>
+          </a:p>
+          <a:p>
+            <a:pPr marL="176213" rtl="0">
+              <a:defRPr/>
+            </a:pPr>
+            <a:endParaRPr lang="en-US" sz="500">
               <a:solidFill>
-                <a:schemeClr val="tx1"/>
+                <a:srgbClr val="C00000"/>
               </a:solidFill>
               <a:latin typeface="Segoe UI" panose="020B0502040204020203" pitchFamily="34" charset="0"/>
               <a:cs typeface="Segoe UI" panose="020B0502040204020203" pitchFamily="34" charset="0"/>
             </a:endParaRPr>
-          </a:p>
-          <a:p>
-            <a:pPr marL="189651" rtl="0">
-              <a:defRPr/>
-            </a:pPr>
-            <a:r>
-              <a:rPr lang="en-US" sz="853">
-                <a:solidFill>
-                  <a:schemeClr val="tx1"/>
-                </a:solidFill>
-                <a:latin typeface="Segoe UI" panose="020B0502040204020203" pitchFamily="34" charset="0"/>
-                <a:cs typeface="Segoe UI" panose="020B0502040204020203" pitchFamily="34" charset="0"/>
-              </a:rPr>
-              <a:t>StudentName</a:t>
-            </a:r>
-          </a:p>
-          <a:p>
-            <a:pPr marL="189651" rtl="0">
-              <a:defRPr/>
-            </a:pPr>
-            <a:r>
-              <a:rPr lang="en-US" sz="853">
-                <a:solidFill>
-                  <a:schemeClr val="tx1"/>
-                </a:solidFill>
-                <a:latin typeface="Segoe UI" panose="020B0502040204020203" pitchFamily="34" charset="0"/>
-                <a:cs typeface="Segoe UI" panose="020B0502040204020203" pitchFamily="34" charset="0"/>
-              </a:rPr>
-              <a:t>StudentPass</a:t>
-            </a:r>
-          </a:p>
-          <a:p>
-            <a:pPr marL="189651" rtl="0">
-              <a:defRPr/>
-            </a:pPr>
-            <a:r>
-              <a:rPr lang="en-US" sz="853">
-                <a:solidFill>
-                  <a:schemeClr val="tx1"/>
-                </a:solidFill>
-                <a:latin typeface="Segoe UI" panose="020B0502040204020203" pitchFamily="34" charset="0"/>
-                <a:cs typeface="Segoe UI" panose="020B0502040204020203" pitchFamily="34" charset="0"/>
-              </a:rPr>
-              <a:t>StudentNickname</a:t>
-            </a:r>
-          </a:p>
-          <a:p>
-            <a:pPr marL="189651" rtl="0">
-              <a:defRPr/>
-            </a:pPr>
-            <a:r>
-              <a:rPr lang="en-US" sz="853">
-                <a:solidFill>
-                  <a:schemeClr val="tx1"/>
-                </a:solidFill>
-                <a:latin typeface="Segoe UI" panose="020B0502040204020203" pitchFamily="34" charset="0"/>
-                <a:cs typeface="Segoe UI" panose="020B0502040204020203" pitchFamily="34" charset="0"/>
-              </a:rPr>
-              <a:t>StudentTags</a:t>
-            </a:r>
-          </a:p>
-          <a:p>
-            <a:pPr marL="176213" rtl="0">
-              <a:defRPr/>
-            </a:pPr>
-            <a:r>
-              <a:rPr lang="en-US" sz="500">
-                <a:solidFill>
-                  <a:srgbClr val="C00000"/>
-                </a:solidFill>
-                <a:latin typeface="Segoe UI" panose="020B0502040204020203" pitchFamily="34" charset="0"/>
-                <a:cs typeface="Segoe UI" panose="020B0502040204020203" pitchFamily="34" charset="0"/>
-              </a:rPr>
-              <a:t>1: IsActive</a:t>
-            </a:r>
-          </a:p>
-          <a:p>
-            <a:pPr marL="176213" rtl="0">
-              <a:defRPr/>
-            </a:pPr>
-            <a:r>
-              <a:rPr lang="en-US" sz="500">
-                <a:solidFill>
-                  <a:srgbClr val="C00000"/>
-                </a:solidFill>
-                <a:latin typeface="Segoe UI" panose="020B0502040204020203" pitchFamily="34" charset="0"/>
-                <a:cs typeface="Segoe UI" panose="020B0502040204020203" pitchFamily="34" charset="0"/>
-              </a:rPr>
-              <a:t>2: ChangePass</a:t>
-            </a:r>
-          </a:p>
-          <a:p>
-            <a:pPr marL="176213" rtl="0">
-              <a:defRPr/>
-            </a:pPr>
-            <a:r>
-              <a:rPr lang="en-US" sz="500">
-                <a:solidFill>
-                  <a:srgbClr val="C00000"/>
-                </a:solidFill>
-                <a:latin typeface="Segoe UI" panose="020B0502040204020203" pitchFamily="34" charset="0"/>
-                <a:cs typeface="Segoe UI" panose="020B0502040204020203" pitchFamily="34" charset="0"/>
-              </a:rPr>
-              <a:t>4: ReviewEx</a:t>
-            </a:r>
-          </a:p>
-          <a:p>
-            <a:pPr marL="176213" rtl="0">
-              <a:defRPr/>
-            </a:pPr>
-            <a:r>
-              <a:rPr lang="en-US" sz="500">
-                <a:solidFill>
-                  <a:srgbClr val="C00000"/>
-                </a:solidFill>
-                <a:latin typeface="Segoe UI" panose="020B0502040204020203" pitchFamily="34" charset="0"/>
-                <a:cs typeface="Segoe UI" panose="020B0502040204020203" pitchFamily="34" charset="0"/>
-              </a:rPr>
-              <a:t>8: GetStExTests</a:t>
-            </a:r>
-          </a:p>
-          <a:p>
-            <a:pPr marL="176213" rtl="0">
-              <a:defRPr/>
-            </a:pPr>
-            <a:r>
-              <a:rPr lang="en-US" sz="500">
-                <a:solidFill>
-                  <a:srgbClr val="C00000"/>
-                </a:solidFill>
-                <a:latin typeface="Segoe UI" panose="020B0502040204020203" pitchFamily="34" charset="0"/>
-                <a:cs typeface="Segoe UI" panose="020B0502040204020203" pitchFamily="34" charset="0"/>
-              </a:rPr>
-              <a:t>16: CorrectStExTests</a:t>
-            </a:r>
-          </a:p>
-          <a:p>
-            <a:pPr marL="176213" rtl="0">
-              <a:defRPr/>
-            </a:pPr>
-            <a:r>
-              <a:rPr lang="en-US" sz="500">
-                <a:solidFill>
-                  <a:srgbClr val="C00000"/>
-                </a:solidFill>
-                <a:latin typeface="Segoe UI" panose="020B0502040204020203" pitchFamily="34" charset="0"/>
-                <a:cs typeface="Segoe UI" panose="020B0502040204020203" pitchFamily="34" charset="0"/>
-              </a:rPr>
-              <a:t>32: RevStExTests</a:t>
-            </a:r>
-          </a:p>
-          <a:p>
-            <a:pPr marL="176213" rtl="0">
-              <a:defRPr/>
-            </a:pPr>
-            <a:r>
-              <a:rPr lang="en-US" sz="500">
-                <a:solidFill>
-                  <a:srgbClr val="C00000"/>
-                </a:solidFill>
-                <a:latin typeface="Segoe UI" panose="020B0502040204020203" pitchFamily="34" charset="0"/>
-                <a:cs typeface="Segoe UI" panose="020B0502040204020203" pitchFamily="34" charset="0"/>
-              </a:rPr>
-              <a:t>64: IsSelected</a:t>
-            </a:r>
-          </a:p>
-          <a:p>
-            <a:pPr marL="176213" rtl="0">
-              <a:defRPr/>
-            </a:pPr>
-            <a:r>
-              <a:rPr lang="en-US" sz="500">
-                <a:solidFill>
-                  <a:srgbClr val="C00000"/>
-                </a:solidFill>
-                <a:latin typeface="Segoe UI" panose="020B0502040204020203" pitchFamily="34" charset="0"/>
-                <a:cs typeface="Segoe UI" panose="020B0502040204020203" pitchFamily="34" charset="0"/>
-              </a:rPr>
-              <a:t>128:</a:t>
-            </a:r>
-          </a:p>
-          <a:p>
-            <a:pPr marL="176213" rtl="0">
-              <a:defRPr/>
-            </a:pPr>
-            <a:r>
-              <a:rPr lang="en-US" sz="500">
-                <a:solidFill>
-                  <a:srgbClr val="C00000"/>
-                </a:solidFill>
-                <a:latin typeface="Segoe UI" panose="020B0502040204020203" pitchFamily="34" charset="0"/>
-                <a:cs typeface="Segoe UI" panose="020B0502040204020203" pitchFamily="34" charset="0"/>
-              </a:rPr>
-              <a:t>256: CalendarFa</a:t>
-            </a:r>
           </a:p>
         </p:txBody>
       </p:sp>
@@ -4808,7 +4529,7 @@
         </p:nvSpPr>
         <p:spPr bwMode="auto">
           <a:xfrm>
-            <a:off x="2794325" y="4552520"/>
+            <a:off x="2794325" y="4768216"/>
             <a:ext cx="1182039" cy="1199659"/>
           </a:xfrm>
           <a:prstGeom prst="roundRect">
@@ -4975,7 +4696,7 @@
         </p:nvSpPr>
         <p:spPr bwMode="auto">
           <a:xfrm>
-            <a:off x="5685945" y="670129"/>
+            <a:off x="5685945" y="885825"/>
             <a:ext cx="1366068" cy="1308924"/>
           </a:xfrm>
           <a:prstGeom prst="roundRect">
@@ -5143,8 +4864,8 @@
         </p:nvSpPr>
         <p:spPr bwMode="auto">
           <a:xfrm>
-            <a:off x="1359989" y="2115977"/>
-            <a:ext cx="1757728" cy="1442933"/>
+            <a:off x="1359989" y="2331674"/>
+            <a:ext cx="1757728" cy="1268300"/>
           </a:xfrm>
           <a:prstGeom prst="roundRect">
             <a:avLst>
@@ -5307,142 +5028,6 @@
       </p:sp>
       <p:sp>
         <p:nvSpPr>
-          <p:cNvPr id="22" name="Rectangle: Rounded Corners 44">
-            <a:extLst>
-              <a:ext uri="{FF2B5EF4-FFF2-40B4-BE49-F238E27FC236}">
-                <a16:creationId xmlns:a16="http://schemas.microsoft.com/office/drawing/2014/main" id="{1829AC77-A972-B3B8-4EF9-16E84E6DAF15}"/>
-              </a:ext>
-            </a:extLst>
-          </p:cNvPr>
-          <p:cNvSpPr/>
-          <p:nvPr/>
-        </p:nvSpPr>
-        <p:spPr bwMode="auto">
-          <a:xfrm>
-            <a:off x="10195069" y="524241"/>
-            <a:ext cx="1045755" cy="915820"/>
-          </a:xfrm>
-          <a:prstGeom prst="roundRect">
-            <a:avLst>
-              <a:gd name="adj" fmla="val 9941"/>
-            </a:avLst>
-          </a:prstGeom>
-          <a:solidFill>
-            <a:schemeClr val="bg1"/>
-          </a:solidFill>
-          <a:ln>
-            <a:solidFill>
-              <a:schemeClr val="tx1"/>
-            </a:solidFill>
-          </a:ln>
-          <a:effectLst/>
-        </p:spPr>
-        <p:style>
-          <a:lnRef idx="0">
-            <a:schemeClr val="accent4"/>
-          </a:lnRef>
-          <a:fillRef idx="3">
-            <a:schemeClr val="accent4"/>
-          </a:fillRef>
-          <a:effectRef idx="3">
-            <a:schemeClr val="accent4"/>
-          </a:effectRef>
-          <a:fontRef idx="minor">
-            <a:schemeClr val="lt1"/>
-          </a:fontRef>
-        </p:style>
-        <p:txBody>
-          <a:bodyPr rtlCol="1" anchor="ctr"/>
-          <a:lstStyle/>
-          <a:p>
-            <a:pPr rtl="0">
-              <a:defRPr/>
-            </a:pPr>
-            <a:r>
-              <a:rPr lang="en-US" sz="1707" b="1">
-                <a:solidFill>
-                  <a:schemeClr val="bg1"/>
-                </a:solidFill>
-                <a:highlight>
-                  <a:srgbClr val="008080"/>
-                </a:highlight>
-                <a:latin typeface="Segoe UI" panose="020B0502040204020203" pitchFamily="34" charset="0"/>
-                <a:cs typeface="Segoe UI" panose="020B0502040204020203" pitchFamily="34" charset="0"/>
-              </a:rPr>
-              <a:t>UL</a:t>
-            </a:r>
-          </a:p>
-          <a:p>
-            <a:pPr rtl="0">
-              <a:defRPr/>
-            </a:pPr>
-            <a:r>
-              <a:rPr lang="en-US" sz="1280" b="1">
-                <a:solidFill>
-                  <a:schemeClr val="tx1"/>
-                </a:solidFill>
-                <a:latin typeface="Segoe UI" panose="020B0502040204020203" pitchFamily="34" charset="0"/>
-                <a:cs typeface="Segoe UI" panose="020B0502040204020203" pitchFamily="34" charset="0"/>
-              </a:rPr>
-              <a:t>usrsLogs</a:t>
-            </a:r>
-            <a:endParaRPr sz="1280">
-              <a:solidFill>
-                <a:schemeClr val="tx1"/>
-              </a:solidFill>
-              <a:latin typeface="Segoe UI" panose="020B0502040204020203" pitchFamily="34" charset="0"/>
-              <a:cs typeface="Segoe UI" panose="020B0502040204020203" pitchFamily="34" charset="0"/>
-            </a:endParaRPr>
-          </a:p>
-          <a:p>
-            <a:pPr rtl="0">
-              <a:defRPr/>
-            </a:pPr>
-            <a:r>
-              <a:rPr lang="en-US" sz="853">
-                <a:solidFill>
-                  <a:schemeClr val="tx1"/>
-                </a:solidFill>
-                <a:latin typeface="Segoe UI" panose="020B0502040204020203" pitchFamily="34" charset="0"/>
-                <a:cs typeface="Segoe UI" panose="020B0502040204020203" pitchFamily="34" charset="0"/>
-              </a:rPr>
-              <a:t>UserId</a:t>
-            </a:r>
-          </a:p>
-          <a:p>
-            <a:pPr rtl="0">
-              <a:defRPr/>
-            </a:pPr>
-            <a:r>
-              <a:rPr lang="en-US" sz="853">
-                <a:solidFill>
-                  <a:schemeClr val="tx1"/>
-                </a:solidFill>
-                <a:latin typeface="Segoe UI" panose="020B0502040204020203" pitchFamily="34" charset="0"/>
-                <a:cs typeface="Segoe UI" panose="020B0502040204020203" pitchFamily="34" charset="0"/>
-              </a:rPr>
-              <a:t>UserLogText</a:t>
-            </a:r>
-          </a:p>
-          <a:p>
-            <a:pPr rtl="0">
-              <a:defRPr/>
-            </a:pPr>
-            <a:r>
-              <a:rPr lang="en-US" sz="853">
-                <a:solidFill>
-                  <a:schemeClr val="tx1"/>
-                </a:solidFill>
-                <a:latin typeface="Segoe UI" panose="020B0502040204020203" pitchFamily="34" charset="0"/>
-                <a:cs typeface="Segoe UI" panose="020B0502040204020203" pitchFamily="34" charset="0"/>
-              </a:rPr>
-              <a:t>DateTime</a:t>
-            </a:r>
-          </a:p>
-        </p:txBody>
-      </p:sp>
-      <p:sp>
-        <p:nvSpPr>
           <p:cNvPr id="80" name="TextBox 79">
             <a:extLst>
               <a:ext uri="{FF2B5EF4-FFF2-40B4-BE49-F238E27FC236}">
@@ -5455,7 +5040,7 @@
         </p:nvSpPr>
         <p:spPr>
           <a:xfrm>
-            <a:off x="-12559" y="8399187"/>
+            <a:off x="-8773" y="8384051"/>
             <a:ext cx="1467068" cy="230832"/>
           </a:xfrm>
           <a:prstGeom prst="rect">
@@ -5506,8 +5091,8 @@
         </p:nvSpPr>
         <p:spPr bwMode="auto">
           <a:xfrm>
-            <a:off x="5192945" y="4910537"/>
-            <a:ext cx="1869708" cy="1570084"/>
+            <a:off x="5192945" y="5126233"/>
+            <a:ext cx="1869708" cy="1498076"/>
           </a:xfrm>
           <a:prstGeom prst="roundRect">
             <a:avLst>
@@ -5727,8 +5312,8 @@
         </p:nvSpPr>
         <p:spPr bwMode="auto">
           <a:xfrm>
-            <a:off x="2833517" y="2242327"/>
-            <a:ext cx="1182038" cy="1075389"/>
+            <a:off x="2833517" y="2614045"/>
+            <a:ext cx="1182038" cy="1098548"/>
           </a:xfrm>
           <a:prstGeom prst="roundRect">
             <a:avLst>
@@ -5864,8 +5449,8 @@
         </p:nvSpPr>
         <p:spPr bwMode="auto">
           <a:xfrm>
-            <a:off x="5298327" y="1921275"/>
-            <a:ext cx="1764331" cy="1645829"/>
+            <a:off x="5298327" y="2136972"/>
+            <a:ext cx="1764331" cy="1174970"/>
           </a:xfrm>
           <a:prstGeom prst="roundRect">
             <a:avLst>
@@ -6034,8 +5619,8 @@
         </p:nvSpPr>
         <p:spPr bwMode="auto">
           <a:xfrm>
-            <a:off x="6641384" y="6096823"/>
-            <a:ext cx="1637820" cy="1649493"/>
+            <a:off x="6641384" y="6422704"/>
+            <a:ext cx="1637820" cy="1498077"/>
           </a:xfrm>
           <a:prstGeom prst="roundRect">
             <a:avLst>
@@ -6287,8 +5872,8 @@
         </p:nvSpPr>
         <p:spPr bwMode="auto">
           <a:xfrm>
-            <a:off x="6709586" y="2038905"/>
-            <a:ext cx="1545810" cy="1705412"/>
+            <a:off x="6709586" y="2254601"/>
+            <a:ext cx="1545810" cy="1528199"/>
           </a:xfrm>
           <a:prstGeom prst="roundRect">
             <a:avLst>
@@ -6529,8 +6114,8 @@
         </p:nvSpPr>
         <p:spPr bwMode="auto">
           <a:xfrm>
-            <a:off x="6641384" y="4578752"/>
-            <a:ext cx="1614017" cy="1387474"/>
+            <a:off x="6641384" y="4824437"/>
+            <a:ext cx="1614017" cy="1300022"/>
           </a:xfrm>
           <a:prstGeom prst="roundRect">
             <a:avLst>
@@ -6715,8 +6300,8 @@
         </p:nvSpPr>
         <p:spPr bwMode="auto">
           <a:xfrm>
-            <a:off x="8114731" y="2196769"/>
-            <a:ext cx="1864591" cy="1259516"/>
+            <a:off x="8114731" y="2412465"/>
+            <a:ext cx="1864591" cy="1152285"/>
           </a:xfrm>
           <a:prstGeom prst="roundRect">
             <a:avLst>
@@ -6903,8 +6488,8 @@
         </p:nvSpPr>
         <p:spPr bwMode="auto">
           <a:xfrm>
-            <a:off x="8136507" y="5248801"/>
-            <a:ext cx="2277663" cy="2599258"/>
+            <a:off x="8136507" y="5400501"/>
+            <a:ext cx="2247973" cy="2812402"/>
           </a:xfrm>
           <a:prstGeom prst="roundRect">
             <a:avLst>
@@ -6940,7 +6525,7 @@
           <a:bodyPr rtlCol="1" anchor="ctr"/>
           <a:lstStyle/>
           <a:p>
-            <a:pPr rtl="0">
+            <a:pPr marL="90488" rtl="0">
               <a:defRPr/>
             </a:pPr>
             <a:r>
@@ -6968,7 +6553,7 @@
             </a:endParaRPr>
           </a:p>
           <a:p>
-            <a:pPr rtl="0">
+            <a:pPr marL="90488" rtl="0">
               <a:defRPr/>
             </a:pPr>
             <a:r>
@@ -6990,7 +6575,7 @@
             </a:endParaRPr>
           </a:p>
           <a:p>
-            <a:pPr rtl="0">
+            <a:pPr marL="90488" rtl="0">
               <a:defRPr/>
             </a:pPr>
             <a:r>
@@ -7015,7 +6600,7 @@
             </a:r>
           </a:p>
           <a:p>
-            <a:pPr rtl="0">
+            <a:pPr marL="90488" rtl="0">
               <a:defRPr/>
             </a:pPr>
             <a:r>
@@ -7030,7 +6615,7 @@
             </a:r>
           </a:p>
           <a:p>
-            <a:pPr rtl="0">
+            <a:pPr marL="90488" rtl="0">
               <a:defRPr/>
             </a:pPr>
             <a:r>
@@ -7045,7 +6630,7 @@
             </a:r>
           </a:p>
           <a:p>
-            <a:pPr rtl="0">
+            <a:pPr marL="90488" rtl="0">
               <a:defRPr/>
             </a:pPr>
             <a:r>
@@ -7060,7 +6645,7 @@
             </a:r>
           </a:p>
           <a:p>
-            <a:pPr rtl="0">
+            <a:pPr marL="90488" rtl="0">
               <a:defRPr/>
             </a:pPr>
             <a:r>
@@ -7075,7 +6660,7 @@
             </a:r>
           </a:p>
           <a:p>
-            <a:pPr rtl="0">
+            <a:pPr marL="90488" rtl="0">
               <a:defRPr/>
             </a:pPr>
             <a:r>
@@ -7090,7 +6675,7 @@
             </a:r>
           </a:p>
           <a:p>
-            <a:pPr rtl="0">
+            <a:pPr marL="90488" rtl="0">
               <a:defRPr/>
             </a:pPr>
             <a:r>
@@ -7105,7 +6690,7 @@
             </a:r>
           </a:p>
           <a:p>
-            <a:pPr rtl="0">
+            <a:pPr marL="90488" rtl="0">
               <a:defRPr/>
             </a:pPr>
             <a:r>
@@ -7120,7 +6705,7 @@
             </a:r>
           </a:p>
           <a:p>
-            <a:pPr rtl="0">
+            <a:pPr marL="90488" rtl="0">
               <a:defRPr/>
             </a:pPr>
             <a:r>
@@ -7135,7 +6720,7 @@
             </a:r>
           </a:p>
           <a:p>
-            <a:pPr rtl="0">
+            <a:pPr marL="90488" rtl="0">
               <a:defRPr/>
             </a:pPr>
             <a:r>
@@ -7150,7 +6735,7 @@
             </a:r>
           </a:p>
           <a:p>
-            <a:pPr rtl="0">
+            <a:pPr marL="90488" rtl="0">
               <a:defRPr/>
             </a:pPr>
             <a:r>
@@ -7165,7 +6750,7 @@
             </a:r>
           </a:p>
           <a:p>
-            <a:pPr rtl="0">
+            <a:pPr marL="90488" rtl="0">
               <a:buNone/>
             </a:pPr>
             <a:r>
@@ -7181,7 +6766,7 @@
             </a:r>
           </a:p>
           <a:p>
-            <a:pPr rtl="0">
+            <a:pPr marL="90488" rtl="0">
               <a:buNone/>
             </a:pPr>
             <a:r>
@@ -7197,7 +6782,7 @@
             </a:r>
           </a:p>
           <a:p>
-            <a:pPr rtl="0">
+            <a:pPr marL="90488" rtl="0">
               <a:buNone/>
             </a:pPr>
             <a:r>
@@ -7213,7 +6798,7 @@
             </a:r>
           </a:p>
           <a:p>
-            <a:pPr rtl="0">
+            <a:pPr marL="90488" rtl="0">
               <a:buNone/>
             </a:pPr>
             <a:r>
@@ -7229,7 +6814,7 @@
             </a:r>
           </a:p>
           <a:p>
-            <a:pPr rtl="0">
+            <a:pPr marL="90488" rtl="0">
               <a:buNone/>
             </a:pPr>
             <a:r>
@@ -7245,7 +6830,7 @@
             </a:r>
           </a:p>
           <a:p>
-            <a:pPr rtl="0">
+            <a:pPr marL="90488" rtl="0">
               <a:buNone/>
             </a:pPr>
             <a:r>
@@ -7261,7 +6846,7 @@
             </a:r>
           </a:p>
           <a:p>
-            <a:pPr rtl="0"/>
+            <a:pPr marL="90488" rtl="0"/>
             <a:r>
               <a:rPr lang="en-US" sz="500" kern="100">
                 <a:solidFill>
@@ -7272,6 +6857,1810 @@
                 <a:cs typeface="Calibri Light" panose="020F0302020204030204" pitchFamily="34" charset="0"/>
               </a:rPr>
               <a:t>64 IsSelected</a:t>
+            </a:r>
+          </a:p>
+          <a:p>
+            <a:pPr rtl="0"/>
+            <a:endParaRPr lang="en-US" sz="500" kern="100">
+              <a:solidFill>
+                <a:srgbClr val="C00000"/>
+              </a:solidFill>
+              <a:latin typeface="Consolas" panose="020B0609020204030204" pitchFamily="49" charset="0"/>
+              <a:ea typeface="Calibri" panose="020F0502020204030204" pitchFamily="34" charset="0"/>
+              <a:cs typeface="Calibri Light" panose="020F0302020204030204" pitchFamily="34" charset="0"/>
+            </a:endParaRPr>
+          </a:p>
+          <a:p>
+            <a:pPr rtl="0"/>
+            <a:endParaRPr lang="en-US" sz="500" kern="100">
+              <a:solidFill>
+                <a:srgbClr val="C00000"/>
+              </a:solidFill>
+              <a:latin typeface="Consolas" panose="020B0609020204030204" pitchFamily="49" charset="0"/>
+              <a:ea typeface="Calibri" panose="020F0502020204030204" pitchFamily="34" charset="0"/>
+              <a:cs typeface="Calibri Light" panose="020F0302020204030204" pitchFamily="34" charset="0"/>
+            </a:endParaRPr>
+          </a:p>
+          <a:p>
+            <a:pPr rtl="0"/>
+            <a:endParaRPr lang="en-US" sz="500" kern="100">
+              <a:solidFill>
+                <a:srgbClr val="C00000"/>
+              </a:solidFill>
+              <a:latin typeface="Consolas" panose="020B0609020204030204" pitchFamily="49" charset="0"/>
+              <a:ea typeface="Calibri" panose="020F0502020204030204" pitchFamily="34" charset="0"/>
+              <a:cs typeface="Calibri Light" panose="020F0302020204030204" pitchFamily="34" charset="0"/>
+            </a:endParaRPr>
+          </a:p>
+          <a:p>
+            <a:pPr rtl="0"/>
+            <a:endParaRPr lang="en-US" sz="500" kern="100">
+              <a:solidFill>
+                <a:srgbClr val="C00000"/>
+              </a:solidFill>
+              <a:latin typeface="Consolas" panose="020B0609020204030204" pitchFamily="49" charset="0"/>
+              <a:ea typeface="Calibri" panose="020F0502020204030204" pitchFamily="34" charset="0"/>
+              <a:cs typeface="Calibri Light" panose="020F0302020204030204" pitchFamily="34" charset="0"/>
+            </a:endParaRPr>
+          </a:p>
+        </p:txBody>
+      </p:sp>
+      <p:sp>
+        <p:nvSpPr>
+          <p:cNvPr id="16" name="Rectangle: Rounded Corners 15">
+            <a:extLst>
+              <a:ext uri="{FF2B5EF4-FFF2-40B4-BE49-F238E27FC236}">
+                <a16:creationId xmlns:a16="http://schemas.microsoft.com/office/drawing/2014/main" id="{8EB7AD94-FB73-258B-E14F-D29425205938}"/>
+              </a:ext>
+            </a:extLst>
+          </p:cNvPr>
+          <p:cNvSpPr/>
+          <p:nvPr/>
+        </p:nvSpPr>
+        <p:spPr>
+          <a:xfrm>
+            <a:off x="215628" y="5832549"/>
+            <a:ext cx="1316312" cy="1301732"/>
+          </a:xfrm>
+          <a:prstGeom prst="roundRect">
+            <a:avLst>
+              <a:gd name="adj" fmla="val 8313"/>
+            </a:avLst>
+          </a:prstGeom>
+          <a:solidFill>
+            <a:schemeClr val="bg1"/>
+          </a:solidFill>
+          <a:ln>
+            <a:solidFill>
+              <a:schemeClr val="tx1">
+                <a:lumMod val="65000"/>
+                <a:lumOff val="35000"/>
+              </a:schemeClr>
+            </a:solidFill>
+          </a:ln>
+        </p:spPr>
+        <p:style>
+          <a:lnRef idx="1">
+            <a:schemeClr val="accent4"/>
+          </a:lnRef>
+          <a:fillRef idx="2">
+            <a:schemeClr val="accent4"/>
+          </a:fillRef>
+          <a:effectRef idx="1">
+            <a:schemeClr val="accent4"/>
+          </a:effectRef>
+          <a:fontRef idx="minor">
+            <a:schemeClr val="dk1"/>
+          </a:fontRef>
+        </p:style>
+        <p:txBody>
+          <a:bodyPr rtlCol="1" anchor="t"/>
+          <a:lstStyle/>
+          <a:p>
+            <a:pPr rtl="0"/>
+            <a:r>
+              <a:rPr lang="en-US" sz="1707" b="1" dirty="0">
+                <a:solidFill>
+                  <a:schemeClr val="bg1"/>
+                </a:solidFill>
+                <a:highlight>
+                  <a:srgbClr val="000000"/>
+                </a:highlight>
+              </a:rPr>
+              <a:t>P</a:t>
+            </a:r>
+            <a:r>
+              <a:rPr lang="en-US" sz="1280" b="1" dirty="0"/>
+              <a:t>rojects</a:t>
+            </a:r>
+            <a:endParaRPr lang="en-US" sz="853" b="1" dirty="0"/>
+          </a:p>
+          <a:p>
+            <a:pPr rtl="0"/>
+            <a:r>
+              <a:rPr lang="en-US" sz="853" i="1">
+                <a:solidFill>
+                  <a:schemeClr val="accent5"/>
+                </a:solidFill>
+                <a:latin typeface="Segoe UI" panose="020B0502040204020203" pitchFamily="34" charset="0"/>
+                <a:cs typeface="Segoe UI" panose="020B0502040204020203" pitchFamily="34" charset="0"/>
+              </a:rPr>
+              <a:t>ProjectId</a:t>
+            </a:r>
+          </a:p>
+          <a:p>
+            <a:pPr rtl="0"/>
+            <a:r>
+              <a:rPr lang="en-US" sz="853">
+                <a:solidFill>
+                  <a:schemeClr val="tx1"/>
+                </a:solidFill>
+              </a:rPr>
+              <a:t>UserId</a:t>
+            </a:r>
+          </a:p>
+          <a:p>
+            <a:pPr rtl="0"/>
+            <a:r>
+              <a:rPr lang="en-US" sz="853">
+                <a:solidFill>
+                  <a:schemeClr val="tx1"/>
+                </a:solidFill>
+              </a:rPr>
+              <a:t>UserType</a:t>
+            </a:r>
+          </a:p>
+          <a:p>
+            <a:pPr rtl="0">
+              <a:buNone/>
+            </a:pPr>
+            <a:r>
+              <a:rPr lang="en-US" sz="600" kern="100">
+                <a:solidFill>
+                  <a:schemeClr val="tx1"/>
+                </a:solidFill>
+                <a:latin typeface="Consolas" panose="020B0609020204030204" pitchFamily="49" charset="0"/>
+                <a:ea typeface="Calibri" panose="020F0502020204030204" pitchFamily="34" charset="0"/>
+                <a:cs typeface="Calibri Light" panose="020F0302020204030204" pitchFamily="34" charset="0"/>
+              </a:rPr>
+              <a:t> 1:Teacher</a:t>
+            </a:r>
+          </a:p>
+          <a:p>
+            <a:pPr rtl="0">
+              <a:buNone/>
+            </a:pPr>
+            <a:r>
+              <a:rPr lang="en-US" sz="600" kern="100">
+                <a:solidFill>
+                  <a:schemeClr val="tx1"/>
+                </a:solidFill>
+                <a:latin typeface="Consolas" panose="020B0609020204030204" pitchFamily="49" charset="0"/>
+                <a:ea typeface="Calibri" panose="020F0502020204030204" pitchFamily="34" charset="0"/>
+                <a:cs typeface="Calibri Light" panose="020F0302020204030204" pitchFamily="34" charset="0"/>
+              </a:rPr>
+              <a:t> 2:Student</a:t>
+            </a:r>
+            <a:endParaRPr lang="en-US" sz="853" dirty="0"/>
+          </a:p>
+          <a:p>
+            <a:pPr rtl="0"/>
+            <a:r>
+              <a:rPr lang="en-US" sz="853" dirty="0" err="1"/>
+              <a:t>ProjectName</a:t>
+            </a:r>
+            <a:endParaRPr lang="en-US" sz="853" dirty="0"/>
+          </a:p>
+          <a:p>
+            <a:pPr rtl="0"/>
+            <a:r>
+              <a:rPr lang="en-US" sz="853">
+                <a:solidFill>
+                  <a:schemeClr val="tx1"/>
+                </a:solidFill>
+              </a:rPr>
+              <a:t>ProjectTags</a:t>
+            </a:r>
+          </a:p>
+          <a:p>
+            <a:pPr rtl="0"/>
+            <a:r>
+              <a:rPr lang="en-US" sz="500" kern="100">
+                <a:solidFill>
+                  <a:srgbClr val="C00000"/>
+                </a:solidFill>
+                <a:latin typeface="Consolas" panose="020B0609020204030204" pitchFamily="49" charset="0"/>
+                <a:ea typeface="Calibri" panose="020F0502020204030204" pitchFamily="34" charset="0"/>
+                <a:cs typeface="Calibri Light" panose="020F0302020204030204" pitchFamily="34" charset="0"/>
+              </a:rPr>
+              <a:t> 1:active</a:t>
+            </a:r>
+          </a:p>
+        </p:txBody>
+      </p:sp>
+      <p:sp>
+        <p:nvSpPr>
+          <p:cNvPr id="17" name="Callout: Bent Line 16">
+            <a:extLst>
+              <a:ext uri="{FF2B5EF4-FFF2-40B4-BE49-F238E27FC236}">
+                <a16:creationId xmlns:a16="http://schemas.microsoft.com/office/drawing/2014/main" id="{D7A96907-C393-6D27-7271-FEC08798F246}"/>
+              </a:ext>
+            </a:extLst>
+          </p:cNvPr>
+          <p:cNvSpPr/>
+          <p:nvPr/>
+        </p:nvSpPr>
+        <p:spPr bwMode="auto">
+          <a:xfrm>
+            <a:off x="1799804" y="7640689"/>
+            <a:ext cx="1105070" cy="787849"/>
+          </a:xfrm>
+          <a:prstGeom prst="borderCallout2">
+            <a:avLst>
+              <a:gd name="adj1" fmla="val -1024"/>
+              <a:gd name="adj2" fmla="val 85567"/>
+              <a:gd name="adj3" fmla="val 366"/>
+              <a:gd name="adj4" fmla="val 82159"/>
+              <a:gd name="adj5" fmla="val 180"/>
+              <a:gd name="adj6" fmla="val 85711"/>
+            </a:avLst>
+          </a:prstGeom>
+          <a:noFill/>
+          <a:ln>
+            <a:prstDash val="dash"/>
+          </a:ln>
+        </p:spPr>
+        <p:style>
+          <a:lnRef idx="2">
+            <a:schemeClr val="accent1">
+              <a:shade val="15000"/>
+            </a:schemeClr>
+          </a:lnRef>
+          <a:fillRef idx="1">
+            <a:schemeClr val="accent1"/>
+          </a:fillRef>
+          <a:effectRef idx="0">
+            <a:schemeClr val="accent1"/>
+          </a:effectRef>
+          <a:fontRef idx="minor">
+            <a:schemeClr val="lt1"/>
+          </a:fontRef>
+        </p:style>
+        <p:txBody>
+          <a:bodyPr rtlCol="1" anchor="ctr"/>
+          <a:lstStyle/>
+          <a:p>
+            <a:pPr rtl="0">
+              <a:buNone/>
+            </a:pPr>
+            <a:r>
+              <a:rPr lang="en-US" sz="500" kern="100">
+                <a:solidFill>
+                  <a:schemeClr val="tx1"/>
+                </a:solidFill>
+                <a:latin typeface="Consolas" panose="020B0609020204030204" pitchFamily="49" charset="0"/>
+                <a:ea typeface="Calibri" panose="020F0502020204030204" pitchFamily="34" charset="0"/>
+                <a:cs typeface="Calibri Light" panose="020F0302020204030204" pitchFamily="34" charset="0"/>
+              </a:rPr>
+              <a:t>NoteTypes:</a:t>
+            </a:r>
+          </a:p>
+          <a:p>
+            <a:pPr rtl="0">
+              <a:buNone/>
+            </a:pPr>
+            <a:r>
+              <a:rPr lang="en-US" sz="500" kern="100">
+                <a:solidFill>
+                  <a:schemeClr val="tx1"/>
+                </a:solidFill>
+                <a:latin typeface="Consolas" panose="020B0609020204030204" pitchFamily="49" charset="0"/>
+                <a:ea typeface="Calibri" panose="020F0502020204030204" pitchFamily="34" charset="0"/>
+                <a:cs typeface="Calibri Light" panose="020F0302020204030204" pitchFamily="34" charset="0"/>
+              </a:rPr>
+              <a:t> 1: S: quickNote</a:t>
+            </a:r>
+          </a:p>
+          <a:p>
+            <a:pPr rtl="0">
+              <a:buNone/>
+            </a:pPr>
+            <a:r>
+              <a:rPr lang="en-US" sz="500" kern="100">
+                <a:solidFill>
+                  <a:schemeClr val="tx1"/>
+                </a:solidFill>
+                <a:latin typeface="Consolas" panose="020B0609020204030204" pitchFamily="49" charset="0"/>
+                <a:ea typeface="Calibri" panose="020F0502020204030204" pitchFamily="34" charset="0"/>
+                <a:cs typeface="Calibri Light" panose="020F0302020204030204" pitchFamily="34" charset="0"/>
+              </a:rPr>
+              <a:t> 2: S: sectionNote</a:t>
+            </a:r>
+          </a:p>
+          <a:p>
+            <a:pPr rtl="0">
+              <a:buNone/>
+            </a:pPr>
+            <a:r>
+              <a:rPr lang="en-US" sz="500" kern="100">
+                <a:solidFill>
+                  <a:schemeClr val="tx1"/>
+                </a:solidFill>
+                <a:latin typeface="Consolas" panose="020B0609020204030204" pitchFamily="49" charset="0"/>
+                <a:ea typeface="Calibri" panose="020F0502020204030204" pitchFamily="34" charset="0"/>
+                <a:cs typeface="Calibri Light" panose="020F0302020204030204" pitchFamily="34" charset="0"/>
+              </a:rPr>
+              <a:t>11: T: quickNote</a:t>
+            </a:r>
+          </a:p>
+          <a:p>
+            <a:pPr rtl="0">
+              <a:buNone/>
+            </a:pPr>
+            <a:r>
+              <a:rPr lang="en-US" sz="500" kern="100">
+                <a:solidFill>
+                  <a:schemeClr val="tx1"/>
+                </a:solidFill>
+                <a:latin typeface="Consolas" panose="020B0609020204030204" pitchFamily="49" charset="0"/>
+                <a:ea typeface="Calibri" panose="020F0502020204030204" pitchFamily="34" charset="0"/>
+                <a:cs typeface="Calibri Light" panose="020F0302020204030204" pitchFamily="34" charset="0"/>
+              </a:rPr>
+              <a:t>12: T: sectionNote</a:t>
+            </a:r>
+          </a:p>
+          <a:p>
+            <a:pPr rtl="0">
+              <a:buNone/>
+            </a:pPr>
+            <a:r>
+              <a:rPr lang="en-US" sz="500" kern="100">
+                <a:solidFill>
+                  <a:schemeClr val="tx1"/>
+                </a:solidFill>
+                <a:latin typeface="Consolas" panose="020B0609020204030204" pitchFamily="49" charset="0"/>
+                <a:ea typeface="Calibri" panose="020F0502020204030204" pitchFamily="34" charset="0"/>
+                <a:cs typeface="Calibri Light" panose="020F0302020204030204" pitchFamily="34" charset="0"/>
+              </a:rPr>
+              <a:t>13: T: note on Student</a:t>
+            </a:r>
+          </a:p>
+          <a:p>
+            <a:pPr rtl="0">
+              <a:buNone/>
+            </a:pPr>
+            <a:r>
+              <a:rPr lang="en-US" sz="500" kern="100">
+                <a:solidFill>
+                  <a:schemeClr val="tx1"/>
+                </a:solidFill>
+                <a:latin typeface="Consolas" panose="020B0609020204030204" pitchFamily="49" charset="0"/>
+                <a:ea typeface="Calibri" panose="020F0502020204030204" pitchFamily="34" charset="0"/>
+                <a:cs typeface="Calibri Light" panose="020F0302020204030204" pitchFamily="34" charset="0"/>
+              </a:rPr>
+              <a:t>14: T: note on Group</a:t>
+            </a:r>
+          </a:p>
+          <a:p>
+            <a:pPr rtl="0">
+              <a:buNone/>
+            </a:pPr>
+            <a:r>
+              <a:rPr lang="en-US" sz="500" kern="100">
+                <a:solidFill>
+                  <a:schemeClr val="tx1"/>
+                </a:solidFill>
+                <a:latin typeface="Consolas" panose="020B0609020204030204" pitchFamily="49" charset="0"/>
+                <a:ea typeface="Calibri" panose="020F0502020204030204" pitchFamily="34" charset="0"/>
+                <a:cs typeface="Calibri Light" panose="020F0302020204030204" pitchFamily="34" charset="0"/>
+              </a:rPr>
+              <a:t>15: T: note on Course</a:t>
+            </a:r>
+          </a:p>
+          <a:p>
+            <a:pPr rtl="0">
+              <a:buNone/>
+            </a:pPr>
+            <a:r>
+              <a:rPr lang="en-US" sz="500" kern="100">
+                <a:solidFill>
+                  <a:schemeClr val="tx1"/>
+                </a:solidFill>
+                <a:latin typeface="Consolas" panose="020B0609020204030204" pitchFamily="49" charset="0"/>
+                <a:ea typeface="Calibri" panose="020F0502020204030204" pitchFamily="34" charset="0"/>
+                <a:cs typeface="Calibri Light" panose="020F0302020204030204" pitchFamily="34" charset="0"/>
+              </a:rPr>
+              <a:t>16: T: note on Exam</a:t>
+            </a:r>
+          </a:p>
+          <a:p>
+            <a:pPr rtl="0">
+              <a:buNone/>
+            </a:pPr>
+            <a:r>
+              <a:rPr lang="en-US" sz="500" kern="100">
+                <a:solidFill>
+                  <a:schemeClr val="tx1"/>
+                </a:solidFill>
+                <a:latin typeface="Consolas" panose="020B0609020204030204" pitchFamily="49" charset="0"/>
+                <a:ea typeface="Calibri" panose="020F0502020204030204" pitchFamily="34" charset="0"/>
+                <a:cs typeface="Calibri Light" panose="020F0302020204030204" pitchFamily="34" charset="0"/>
+              </a:rPr>
+              <a:t>17: T: note on StudentExam</a:t>
+            </a:r>
+          </a:p>
+        </p:txBody>
+      </p:sp>
+      <p:sp>
+        <p:nvSpPr>
+          <p:cNvPr id="18" name="Rectangle: Rounded Corners 45">
+            <a:extLst>
+              <a:ext uri="{FF2B5EF4-FFF2-40B4-BE49-F238E27FC236}">
+                <a16:creationId xmlns:a16="http://schemas.microsoft.com/office/drawing/2014/main" id="{84CF63F6-9EC1-FF7B-5327-5C2174F26690}"/>
+              </a:ext>
+            </a:extLst>
+          </p:cNvPr>
+          <p:cNvSpPr/>
+          <p:nvPr/>
+        </p:nvSpPr>
+        <p:spPr bwMode="auto">
+          <a:xfrm>
+            <a:off x="2936700" y="501554"/>
+            <a:ext cx="1182037" cy="1712656"/>
+          </a:xfrm>
+          <a:prstGeom prst="roundRect">
+            <a:avLst>
+              <a:gd name="adj" fmla="val 8076"/>
+            </a:avLst>
+          </a:prstGeom>
+          <a:solidFill>
+            <a:schemeClr val="bg1"/>
+          </a:solidFill>
+          <a:ln w="28575">
+            <a:solidFill>
+              <a:schemeClr val="tx1"/>
+            </a:solidFill>
+            <a:prstDash val="solid"/>
+          </a:ln>
+          <a:effectLst/>
+        </p:spPr>
+        <p:style>
+          <a:lnRef idx="0">
+            <a:schemeClr val="accent4"/>
+          </a:lnRef>
+          <a:fillRef idx="3">
+            <a:schemeClr val="accent4"/>
+          </a:fillRef>
+          <a:effectRef idx="3">
+            <a:schemeClr val="accent4"/>
+          </a:effectRef>
+          <a:fontRef idx="minor">
+            <a:schemeClr val="lt1"/>
+          </a:fontRef>
+        </p:style>
+        <p:txBody>
+          <a:bodyPr rtlCol="1" anchor="ctr"/>
+          <a:lstStyle/>
+          <a:p>
+            <a:pPr algn="l" rtl="0">
+              <a:defRPr/>
+            </a:pPr>
+            <a:r>
+              <a:rPr lang="en-US" sz="1707" b="1">
+                <a:solidFill>
+                  <a:schemeClr val="bg1"/>
+                </a:solidFill>
+                <a:highlight>
+                  <a:srgbClr val="800080"/>
+                </a:highlight>
+                <a:latin typeface="Segoe UI" panose="020B0502040204020203" pitchFamily="34" charset="0"/>
+                <a:cs typeface="Segoe UI" panose="020B0502040204020203" pitchFamily="34" charset="0"/>
+              </a:rPr>
+              <a:t>CH</a:t>
+            </a:r>
+          </a:p>
+          <a:p>
+            <a:pPr rtl="0">
+              <a:defRPr/>
+            </a:pPr>
+            <a:r>
+              <a:rPr lang="en-US" sz="1280" b="1">
+                <a:solidFill>
+                  <a:schemeClr val="tx1"/>
+                </a:solidFill>
+                <a:latin typeface="Segoe UI" panose="020B0502040204020203" pitchFamily="34" charset="0"/>
+                <a:cs typeface="Segoe UI" panose="020B0502040204020203" pitchFamily="34" charset="0"/>
+              </a:rPr>
+              <a:t>Chats</a:t>
+            </a:r>
+            <a:endParaRPr sz="1280">
+              <a:solidFill>
+                <a:schemeClr val="tx1"/>
+              </a:solidFill>
+              <a:latin typeface="Segoe UI" panose="020B0502040204020203" pitchFamily="34" charset="0"/>
+              <a:cs typeface="Segoe UI" panose="020B0502040204020203" pitchFamily="34" charset="0"/>
+            </a:endParaRPr>
+          </a:p>
+          <a:p>
+            <a:pPr rtl="0">
+              <a:defRPr/>
+            </a:pPr>
+            <a:r>
+              <a:rPr lang="en-US" sz="853" i="1">
+                <a:solidFill>
+                  <a:schemeClr val="accent5"/>
+                </a:solidFill>
+                <a:latin typeface="Segoe UI" panose="020B0502040204020203" pitchFamily="34" charset="0"/>
+                <a:cs typeface="Segoe UI" panose="020B0502040204020203" pitchFamily="34" charset="0"/>
+              </a:rPr>
+              <a:t>ChatId</a:t>
+            </a:r>
+          </a:p>
+          <a:p>
+            <a:pPr rtl="0">
+              <a:defRPr/>
+            </a:pPr>
+            <a:r>
+              <a:rPr lang="en-US" sz="853">
+                <a:solidFill>
+                  <a:schemeClr val="tx1"/>
+                </a:solidFill>
+                <a:latin typeface="Segoe UI" panose="020B0502040204020203" pitchFamily="34" charset="0"/>
+                <a:cs typeface="Segoe UI" panose="020B0502040204020203" pitchFamily="34" charset="0"/>
+              </a:rPr>
+              <a:t>FromId</a:t>
+            </a:r>
+          </a:p>
+          <a:p>
+            <a:pPr rtl="0">
+              <a:defRPr/>
+            </a:pPr>
+            <a:r>
+              <a:rPr lang="en-US" sz="853">
+                <a:solidFill>
+                  <a:schemeClr val="tx1"/>
+                </a:solidFill>
+                <a:latin typeface="Segoe UI" panose="020B0502040204020203" pitchFamily="34" charset="0"/>
+                <a:cs typeface="Segoe UI" panose="020B0502040204020203" pitchFamily="34" charset="0"/>
+              </a:rPr>
+              <a:t>ToId</a:t>
+            </a:r>
+          </a:p>
+          <a:p>
+            <a:pPr rtl="0">
+              <a:defRPr/>
+            </a:pPr>
+            <a:r>
+              <a:rPr lang="en-US" sz="853">
+                <a:solidFill>
+                  <a:schemeClr val="tx1"/>
+                </a:solidFill>
+                <a:latin typeface="Segoe UI" panose="020B0502040204020203" pitchFamily="34" charset="0"/>
+                <a:cs typeface="Segoe UI" panose="020B0502040204020203" pitchFamily="34" charset="0"/>
+              </a:rPr>
+              <a:t>DateTimeSent</a:t>
+            </a:r>
+          </a:p>
+          <a:p>
+            <a:pPr rtl="0">
+              <a:defRPr/>
+            </a:pPr>
+            <a:r>
+              <a:rPr lang="en-US" sz="853">
+                <a:solidFill>
+                  <a:schemeClr val="tx1"/>
+                </a:solidFill>
+                <a:latin typeface="Segoe UI" panose="020B0502040204020203" pitchFamily="34" charset="0"/>
+                <a:cs typeface="Segoe UI" panose="020B0502040204020203" pitchFamily="34" charset="0"/>
+              </a:rPr>
+              <a:t>ChatText</a:t>
+            </a:r>
+          </a:p>
+          <a:p>
+            <a:pPr rtl="0">
+              <a:defRPr/>
+            </a:pPr>
+            <a:r>
+              <a:rPr lang="en-US" sz="853">
+                <a:solidFill>
+                  <a:schemeClr val="tx1"/>
+                </a:solidFill>
+                <a:latin typeface="Segoe UI" panose="020B0502040204020203" pitchFamily="34" charset="0"/>
+                <a:cs typeface="Segoe UI" panose="020B0502040204020203" pitchFamily="34" charset="0"/>
+              </a:rPr>
+              <a:t>ChatTags</a:t>
+            </a:r>
+          </a:p>
+          <a:p>
+            <a:pPr rtl="0">
+              <a:defRPr/>
+            </a:pPr>
+            <a:r>
+              <a:rPr lang="en-US" sz="600" kern="100">
+                <a:solidFill>
+                  <a:schemeClr val="tx1"/>
+                </a:solidFill>
+                <a:latin typeface="Consolas" panose="020B0609020204030204" pitchFamily="49" charset="0"/>
+                <a:ea typeface="Calibri" panose="020F0502020204030204" pitchFamily="34" charset="0"/>
+                <a:cs typeface="Calibri Light" panose="020F0302020204030204" pitchFamily="34" charset="0"/>
+              </a:rPr>
+              <a:t>1:Read </a:t>
+            </a:r>
+          </a:p>
+          <a:p>
+            <a:pPr rtl="0">
+              <a:defRPr/>
+            </a:pPr>
+            <a:r>
+              <a:rPr lang="en-US" sz="600" kern="100">
+                <a:solidFill>
+                  <a:schemeClr val="tx1"/>
+                </a:solidFill>
+                <a:latin typeface="Consolas" panose="020B0609020204030204" pitchFamily="49" charset="0"/>
+                <a:ea typeface="Calibri" panose="020F0502020204030204" pitchFamily="34" charset="0"/>
+                <a:cs typeface="Calibri Light" panose="020F0302020204030204" pitchFamily="34" charset="0"/>
+              </a:rPr>
+              <a:t>2:Imp </a:t>
+            </a:r>
+          </a:p>
+          <a:p>
+            <a:pPr rtl="0">
+              <a:defRPr/>
+            </a:pPr>
+            <a:r>
+              <a:rPr lang="en-US" sz="600" kern="100">
+                <a:solidFill>
+                  <a:schemeClr val="tx1"/>
+                </a:solidFill>
+                <a:latin typeface="Consolas" panose="020B0609020204030204" pitchFamily="49" charset="0"/>
+                <a:ea typeface="Calibri" panose="020F0502020204030204" pitchFamily="34" charset="0"/>
+                <a:cs typeface="Calibri Light" panose="020F0302020204030204" pitchFamily="34" charset="0"/>
+              </a:rPr>
+              <a:t>3:Bookmark </a:t>
+            </a:r>
+          </a:p>
+          <a:p>
+            <a:pPr rtl="0">
+              <a:defRPr/>
+            </a:pPr>
+            <a:r>
+              <a:rPr lang="en-US" sz="600" kern="100">
+                <a:solidFill>
+                  <a:schemeClr val="tx1"/>
+                </a:solidFill>
+                <a:latin typeface="Consolas" panose="020B0609020204030204" pitchFamily="49" charset="0"/>
+                <a:ea typeface="Calibri" panose="020F0502020204030204" pitchFamily="34" charset="0"/>
+                <a:cs typeface="Calibri Light" panose="020F0302020204030204" pitchFamily="34" charset="0"/>
+              </a:rPr>
+              <a:t>4:Del</a:t>
+            </a:r>
+          </a:p>
+        </p:txBody>
+      </p:sp>
+      <p:sp>
+        <p:nvSpPr>
+          <p:cNvPr id="28" name="Rectangle: Rounded Corners 44">
+            <a:extLst>
+              <a:ext uri="{FF2B5EF4-FFF2-40B4-BE49-F238E27FC236}">
+                <a16:creationId xmlns:a16="http://schemas.microsoft.com/office/drawing/2014/main" id="{96D765ED-D9C6-3463-0136-8A90C3A57F14}"/>
+              </a:ext>
+            </a:extLst>
+          </p:cNvPr>
+          <p:cNvSpPr/>
+          <p:nvPr/>
+        </p:nvSpPr>
+        <p:spPr bwMode="auto">
+          <a:xfrm>
+            <a:off x="188719" y="373335"/>
+            <a:ext cx="1467069" cy="1642462"/>
+          </a:xfrm>
+          <a:prstGeom prst="roundRect">
+            <a:avLst>
+              <a:gd name="adj" fmla="val 6742"/>
+            </a:avLst>
+          </a:prstGeom>
+          <a:solidFill>
+            <a:schemeClr val="bg1"/>
+          </a:solidFill>
+          <a:ln>
+            <a:solidFill>
+              <a:schemeClr val="tx1"/>
+            </a:solidFill>
+          </a:ln>
+          <a:effectLst/>
+        </p:spPr>
+        <p:style>
+          <a:lnRef idx="0">
+            <a:schemeClr val="accent4"/>
+          </a:lnRef>
+          <a:fillRef idx="3">
+            <a:schemeClr val="accent4"/>
+          </a:fillRef>
+          <a:effectRef idx="3">
+            <a:schemeClr val="accent4"/>
+          </a:effectRef>
+          <a:fontRef idx="minor">
+            <a:schemeClr val="lt1"/>
+          </a:fontRef>
+        </p:style>
+        <p:txBody>
+          <a:bodyPr rtlCol="1" anchor="ctr"/>
+          <a:lstStyle/>
+          <a:p>
+            <a:pPr rtl="0">
+              <a:defRPr/>
+            </a:pPr>
+            <a:r>
+              <a:rPr lang="en-US" sz="1707" b="1">
+                <a:solidFill>
+                  <a:schemeClr val="bg1"/>
+                </a:solidFill>
+                <a:highlight>
+                  <a:srgbClr val="808000"/>
+                </a:highlight>
+                <a:latin typeface="Segoe UI" panose="020B0502040204020203" pitchFamily="34" charset="0"/>
+                <a:cs typeface="Segoe UI" panose="020B0502040204020203" pitchFamily="34" charset="0"/>
+              </a:rPr>
+              <a:t>CHRP</a:t>
+            </a:r>
+          </a:p>
+          <a:p>
+            <a:pPr rtl="0">
+              <a:defRPr/>
+            </a:pPr>
+            <a:r>
+              <a:rPr lang="en-US" sz="1280" b="1">
+                <a:solidFill>
+                  <a:schemeClr val="tx1"/>
+                </a:solidFill>
+                <a:latin typeface="Segoe UI" panose="020B0502040204020203" pitchFamily="34" charset="0"/>
+                <a:cs typeface="Segoe UI" panose="020B0502040204020203" pitchFamily="34" charset="0"/>
+              </a:rPr>
+              <a:t>ChatroomPosts</a:t>
+            </a:r>
+            <a:endParaRPr sz="1280">
+              <a:solidFill>
+                <a:schemeClr val="tx1"/>
+              </a:solidFill>
+              <a:latin typeface="Segoe UI" panose="020B0502040204020203" pitchFamily="34" charset="0"/>
+              <a:cs typeface="Segoe UI" panose="020B0502040204020203" pitchFamily="34" charset="0"/>
+            </a:endParaRPr>
+          </a:p>
+          <a:p>
+            <a:pPr rtl="0">
+              <a:defRPr/>
+            </a:pPr>
+            <a:r>
+              <a:rPr lang="en-US" sz="853" i="1">
+                <a:solidFill>
+                  <a:schemeClr val="accent5"/>
+                </a:solidFill>
+                <a:latin typeface="Segoe UI" panose="020B0502040204020203" pitchFamily="34" charset="0"/>
+                <a:cs typeface="Segoe UI" panose="020B0502040204020203" pitchFamily="34" charset="0"/>
+              </a:rPr>
+              <a:t>ChatroomPostId</a:t>
+            </a:r>
+          </a:p>
+          <a:p>
+            <a:pPr rtl="0">
+              <a:defRPr/>
+            </a:pPr>
+            <a:r>
+              <a:rPr lang="en-US" sz="853">
+                <a:solidFill>
+                  <a:schemeClr val="tx1"/>
+                </a:solidFill>
+                <a:latin typeface="Segoe UI" panose="020B0502040204020203" pitchFamily="34" charset="0"/>
+                <a:cs typeface="Segoe UI" panose="020B0502040204020203" pitchFamily="34" charset="0"/>
+              </a:rPr>
+              <a:t>ChatroomId</a:t>
+            </a:r>
+          </a:p>
+          <a:p>
+            <a:pPr rtl="0">
+              <a:defRPr/>
+            </a:pPr>
+            <a:r>
+              <a:rPr lang="en-US" sz="853">
+                <a:solidFill>
+                  <a:schemeClr val="tx1"/>
+                </a:solidFill>
+                <a:latin typeface="Segoe UI" panose="020B0502040204020203" pitchFamily="34" charset="0"/>
+                <a:cs typeface="Segoe UI" panose="020B0502040204020203" pitchFamily="34" charset="0"/>
+              </a:rPr>
+              <a:t>SenderId</a:t>
+            </a:r>
+          </a:p>
+          <a:p>
+            <a:pPr rtl="0">
+              <a:defRPr/>
+            </a:pPr>
+            <a:r>
+              <a:rPr lang="en-US" sz="853">
+                <a:solidFill>
+                  <a:schemeClr val="tx1"/>
+                </a:solidFill>
+                <a:latin typeface="Segoe UI" panose="020B0502040204020203" pitchFamily="34" charset="0"/>
+                <a:cs typeface="Segoe UI" panose="020B0502040204020203" pitchFamily="34" charset="0"/>
+              </a:rPr>
+              <a:t>PostDateTime</a:t>
+            </a:r>
+          </a:p>
+          <a:p>
+            <a:pPr rtl="0">
+              <a:defRPr/>
+            </a:pPr>
+            <a:r>
+              <a:rPr lang="en-US" sz="853">
+                <a:solidFill>
+                  <a:schemeClr val="tx1"/>
+                </a:solidFill>
+                <a:latin typeface="Segoe UI" panose="020B0502040204020203" pitchFamily="34" charset="0"/>
+                <a:cs typeface="Segoe UI" panose="020B0502040204020203" pitchFamily="34" charset="0"/>
+              </a:rPr>
+              <a:t>PostText</a:t>
+            </a:r>
+          </a:p>
+          <a:p>
+            <a:pPr rtl="0">
+              <a:defRPr/>
+            </a:pPr>
+            <a:r>
+              <a:rPr lang="en-US" sz="853">
+                <a:solidFill>
+                  <a:schemeClr val="tx1"/>
+                </a:solidFill>
+                <a:latin typeface="Segoe UI" panose="020B0502040204020203" pitchFamily="34" charset="0"/>
+                <a:cs typeface="Segoe UI" panose="020B0502040204020203" pitchFamily="34" charset="0"/>
+              </a:rPr>
+              <a:t>PostTags</a:t>
+            </a:r>
+          </a:p>
+          <a:p>
+            <a:pPr rtl="0">
+              <a:defRPr/>
+            </a:pPr>
+            <a:r>
+              <a:rPr lang="en-US" sz="500">
+                <a:solidFill>
+                  <a:srgbClr val="C00000"/>
+                </a:solidFill>
+                <a:latin typeface="Segoe UI" panose="020B0502040204020203" pitchFamily="34" charset="0"/>
+                <a:cs typeface="Segoe UI" panose="020B0502040204020203" pitchFamily="34" charset="0"/>
+              </a:rPr>
+              <a:t>  1:NeedReply</a:t>
+            </a:r>
+          </a:p>
+          <a:p>
+            <a:pPr rtl="0">
+              <a:defRPr/>
+            </a:pPr>
+            <a:r>
+              <a:rPr lang="en-US" sz="500">
+                <a:solidFill>
+                  <a:srgbClr val="C00000"/>
+                </a:solidFill>
+                <a:latin typeface="Segoe UI" panose="020B0502040204020203" pitchFamily="34" charset="0"/>
+                <a:cs typeface="Segoe UI" panose="020B0502040204020203" pitchFamily="34" charset="0"/>
+              </a:rPr>
+              <a:t>  2:IsEdited</a:t>
+            </a:r>
+          </a:p>
+          <a:p>
+            <a:pPr rtl="0">
+              <a:defRPr/>
+            </a:pPr>
+            <a:r>
+              <a:rPr lang="en-US" sz="500">
+                <a:solidFill>
+                  <a:srgbClr val="C00000"/>
+                </a:solidFill>
+                <a:latin typeface="Segoe UI" panose="020B0502040204020203" pitchFamily="34" charset="0"/>
+                <a:cs typeface="Segoe UI" panose="020B0502040204020203" pitchFamily="34" charset="0"/>
+              </a:rPr>
+              <a:t>  4:IsDeleted</a:t>
+            </a:r>
+          </a:p>
+        </p:txBody>
+      </p:sp>
+      <p:sp>
+        <p:nvSpPr>
+          <p:cNvPr id="2" name="Rectangle: Rounded Corners 1">
+            <a:extLst>
+              <a:ext uri="{FF2B5EF4-FFF2-40B4-BE49-F238E27FC236}">
+                <a16:creationId xmlns:a16="http://schemas.microsoft.com/office/drawing/2014/main" id="{6A0D2D6C-AD44-BFED-2D51-29757378D5BB}"/>
+              </a:ext>
+            </a:extLst>
+          </p:cNvPr>
+          <p:cNvSpPr/>
+          <p:nvPr/>
+        </p:nvSpPr>
+        <p:spPr>
+          <a:xfrm>
+            <a:off x="2818874" y="6578291"/>
+            <a:ext cx="976113" cy="1634612"/>
+          </a:xfrm>
+          <a:prstGeom prst="roundRect">
+            <a:avLst>
+              <a:gd name="adj" fmla="val 1266"/>
+            </a:avLst>
+          </a:prstGeom>
+          <a:solidFill>
+            <a:schemeClr val="bg1"/>
+          </a:solidFill>
+          <a:ln>
+            <a:solidFill>
+              <a:schemeClr val="tx1">
+                <a:lumMod val="65000"/>
+                <a:lumOff val="35000"/>
+              </a:schemeClr>
+            </a:solidFill>
+          </a:ln>
+        </p:spPr>
+        <p:style>
+          <a:lnRef idx="1">
+            <a:schemeClr val="accent4"/>
+          </a:lnRef>
+          <a:fillRef idx="2">
+            <a:schemeClr val="accent4"/>
+          </a:fillRef>
+          <a:effectRef idx="1">
+            <a:schemeClr val="accent4"/>
+          </a:effectRef>
+          <a:fontRef idx="minor">
+            <a:schemeClr val="dk1"/>
+          </a:fontRef>
+        </p:style>
+        <p:txBody>
+          <a:bodyPr rtlCol="1" anchor="t"/>
+          <a:lstStyle/>
+          <a:p>
+            <a:pPr rtl="0"/>
+            <a:r>
+              <a:rPr lang="en-US" sz="1707" b="1" dirty="0">
+                <a:solidFill>
+                  <a:schemeClr val="bg1"/>
+                </a:solidFill>
+                <a:highlight>
+                  <a:srgbClr val="000000"/>
+                </a:highlight>
+              </a:rPr>
+              <a:t>N</a:t>
+            </a:r>
+            <a:r>
+              <a:rPr lang="en-US" sz="1280" b="1" dirty="0"/>
+              <a:t>otes</a:t>
+            </a:r>
+          </a:p>
+          <a:p>
+            <a:pPr rtl="0"/>
+            <a:r>
+              <a:rPr lang="en-US" sz="853" i="1">
+                <a:solidFill>
+                  <a:schemeClr val="accent5"/>
+                </a:solidFill>
+                <a:latin typeface="Segoe UI" panose="020B0502040204020203" pitchFamily="34" charset="0"/>
+                <a:cs typeface="Segoe UI" panose="020B0502040204020203" pitchFamily="34" charset="0"/>
+              </a:rPr>
+              <a:t>NoteId</a:t>
+            </a:r>
+          </a:p>
+          <a:p>
+            <a:pPr rtl="0"/>
+            <a:r>
+              <a:rPr lang="en-US" sz="853"/>
+              <a:t>NoteType</a:t>
+            </a:r>
+          </a:p>
+          <a:p>
+            <a:pPr rtl="0"/>
+            <a:r>
+              <a:rPr lang="en-US" sz="853"/>
+              <a:t>ReferenceId</a:t>
+            </a:r>
+          </a:p>
+          <a:p>
+            <a:pPr rtl="0"/>
+            <a:r>
+              <a:rPr lang="en-US" sz="853"/>
+              <a:t>NoteDateTime</a:t>
+            </a:r>
+            <a:endParaRPr lang="en-US" sz="853" dirty="0"/>
+          </a:p>
+          <a:p>
+            <a:pPr rtl="0"/>
+            <a:r>
+              <a:rPr lang="en-US" sz="853"/>
+              <a:t>NoteText</a:t>
+            </a:r>
+            <a:endParaRPr lang="en-US" sz="853" dirty="0"/>
+          </a:p>
+          <a:p>
+            <a:pPr rtl="0"/>
+            <a:r>
+              <a:rPr lang="en-US" sz="853">
+                <a:solidFill>
+                  <a:schemeClr val="tx1"/>
+                </a:solidFill>
+              </a:rPr>
+              <a:t>CreatorId</a:t>
+            </a:r>
+            <a:endParaRPr lang="fa-IR" sz="853">
+              <a:solidFill>
+                <a:schemeClr val="tx1"/>
+              </a:solidFill>
+            </a:endParaRPr>
+          </a:p>
+          <a:p>
+            <a:pPr rtl="0"/>
+            <a:r>
+              <a:rPr lang="en-US" sz="853">
+                <a:solidFill>
+                  <a:schemeClr val="tx1"/>
+                </a:solidFill>
+              </a:rPr>
+              <a:t>NoteTags</a:t>
+            </a:r>
+          </a:p>
+          <a:p>
+            <a:pPr rtl="0">
+              <a:buNone/>
+            </a:pPr>
+            <a:r>
+              <a:rPr lang="en-US" sz="500" kern="100">
+                <a:solidFill>
+                  <a:srgbClr val="C00000"/>
+                </a:solidFill>
+                <a:latin typeface="Consolas" panose="020B0609020204030204" pitchFamily="49" charset="0"/>
+                <a:ea typeface="Calibri" panose="020F0502020204030204" pitchFamily="34" charset="0"/>
+                <a:cs typeface="Calibri Light" panose="020F0302020204030204" pitchFamily="34" charset="0"/>
+              </a:rPr>
+              <a:t> 1:IsRtl</a:t>
+            </a:r>
+          </a:p>
+          <a:p>
+            <a:pPr rtl="0">
+              <a:buNone/>
+            </a:pPr>
+            <a:r>
+              <a:rPr lang="en-US" sz="500" kern="100">
+                <a:solidFill>
+                  <a:srgbClr val="C00000"/>
+                </a:solidFill>
+                <a:latin typeface="Consolas" panose="020B0609020204030204" pitchFamily="49" charset="0"/>
+                <a:ea typeface="Calibri" panose="020F0502020204030204" pitchFamily="34" charset="0"/>
+                <a:cs typeface="Calibri Light" panose="020F0302020204030204" pitchFamily="34" charset="0"/>
+              </a:rPr>
+              <a:t> 2:IsDone</a:t>
+            </a:r>
+          </a:p>
+          <a:p>
+            <a:pPr rtl="0">
+              <a:buNone/>
+            </a:pPr>
+            <a:r>
+              <a:rPr lang="en-US" sz="500" kern="100">
+                <a:solidFill>
+                  <a:srgbClr val="C00000"/>
+                </a:solidFill>
+                <a:latin typeface="Consolas" panose="020B0609020204030204" pitchFamily="49" charset="0"/>
+                <a:ea typeface="Calibri" panose="020F0502020204030204" pitchFamily="34" charset="0"/>
+                <a:cs typeface="Calibri Light" panose="020F0302020204030204" pitchFamily="34" charset="0"/>
+              </a:rPr>
+              <a:t> 4:IsShared</a:t>
+            </a:r>
+          </a:p>
+          <a:p>
+            <a:pPr rtl="0">
+              <a:buNone/>
+            </a:pPr>
+            <a:r>
+              <a:rPr lang="en-US" sz="500" kern="100">
+                <a:solidFill>
+                  <a:srgbClr val="C00000"/>
+                </a:solidFill>
+                <a:latin typeface="Consolas" panose="020B0609020204030204" pitchFamily="49" charset="0"/>
+                <a:ea typeface="Calibri" panose="020F0502020204030204" pitchFamily="34" charset="0"/>
+                <a:cs typeface="Calibri Light" panose="020F0302020204030204" pitchFamily="34" charset="0"/>
+              </a:rPr>
+              <a:t> 8:IsReadonly</a:t>
+            </a:r>
+          </a:p>
+        </p:txBody>
+      </p:sp>
+      <p:sp>
+        <p:nvSpPr>
+          <p:cNvPr id="3" name="Rectangle: Rounded Corners 2">
+            <a:extLst>
+              <a:ext uri="{FF2B5EF4-FFF2-40B4-BE49-F238E27FC236}">
+                <a16:creationId xmlns:a16="http://schemas.microsoft.com/office/drawing/2014/main" id="{4E95C3AB-3ADD-0B38-7306-5F78CAD1B483}"/>
+              </a:ext>
+            </a:extLst>
+          </p:cNvPr>
+          <p:cNvSpPr/>
+          <p:nvPr/>
+        </p:nvSpPr>
+        <p:spPr>
+          <a:xfrm>
+            <a:off x="3581379" y="7721770"/>
+            <a:ext cx="954729" cy="775075"/>
+          </a:xfrm>
+          <a:prstGeom prst="roundRect">
+            <a:avLst>
+              <a:gd name="adj" fmla="val 4805"/>
+            </a:avLst>
+          </a:prstGeom>
+          <a:solidFill>
+            <a:schemeClr val="bg1"/>
+          </a:solidFill>
+          <a:ln>
+            <a:solidFill>
+              <a:schemeClr val="tx1">
+                <a:lumMod val="65000"/>
+                <a:lumOff val="35000"/>
+              </a:schemeClr>
+            </a:solidFill>
+          </a:ln>
+        </p:spPr>
+        <p:style>
+          <a:lnRef idx="1">
+            <a:schemeClr val="accent4"/>
+          </a:lnRef>
+          <a:fillRef idx="2">
+            <a:schemeClr val="accent4"/>
+          </a:fillRef>
+          <a:effectRef idx="1">
+            <a:schemeClr val="accent4"/>
+          </a:effectRef>
+          <a:fontRef idx="minor">
+            <a:schemeClr val="dk1"/>
+          </a:fontRef>
+        </p:style>
+        <p:txBody>
+          <a:bodyPr rtlCol="1" anchor="t"/>
+          <a:lstStyle/>
+          <a:p>
+            <a:pPr rtl="0"/>
+            <a:r>
+              <a:rPr lang="en-US" sz="1707" b="1" dirty="0" err="1">
+                <a:solidFill>
+                  <a:schemeClr val="bg1"/>
+                </a:solidFill>
+                <a:highlight>
+                  <a:srgbClr val="000000"/>
+                </a:highlight>
+              </a:rPr>
+              <a:t>N</a:t>
+            </a:r>
+            <a:r>
+              <a:rPr lang="en-US" sz="1280" b="1" dirty="0" err="1"/>
+              <a:t>oteNet</a:t>
+            </a:r>
+            <a:endParaRPr lang="en-US" sz="1280" b="1" dirty="0"/>
+          </a:p>
+          <a:p>
+            <a:pPr rtl="0"/>
+            <a:r>
+              <a:rPr lang="en-US" sz="853" i="1">
+                <a:solidFill>
+                  <a:schemeClr val="accent5"/>
+                </a:solidFill>
+                <a:latin typeface="Segoe UI" panose="020B0502040204020203" pitchFamily="34" charset="0"/>
+                <a:cs typeface="Segoe UI" panose="020B0502040204020203" pitchFamily="34" charset="0"/>
+              </a:rPr>
+              <a:t>NoteNetId</a:t>
+            </a:r>
+            <a:endParaRPr lang="en-US" sz="853" i="1" dirty="0">
+              <a:solidFill>
+                <a:schemeClr val="accent5"/>
+              </a:solidFill>
+              <a:latin typeface="Segoe UI" panose="020B0502040204020203" pitchFamily="34" charset="0"/>
+              <a:cs typeface="Segoe UI" panose="020B0502040204020203" pitchFamily="34" charset="0"/>
+            </a:endParaRPr>
+          </a:p>
+          <a:p>
+            <a:pPr rtl="0"/>
+            <a:r>
+              <a:rPr lang="en-US" sz="853"/>
+              <a:t>NoteAId</a:t>
+            </a:r>
+          </a:p>
+          <a:p>
+            <a:pPr rtl="0"/>
+            <a:r>
+              <a:rPr lang="en-US" sz="853"/>
+              <a:t>NoteBId</a:t>
+            </a:r>
+            <a:endParaRPr lang="en-US" sz="853" dirty="0"/>
+          </a:p>
+        </p:txBody>
+      </p:sp>
+      <p:sp>
+        <p:nvSpPr>
+          <p:cNvPr id="25" name="Rectangle: Rounded Corners 44">
+            <a:extLst>
+              <a:ext uri="{FF2B5EF4-FFF2-40B4-BE49-F238E27FC236}">
+                <a16:creationId xmlns:a16="http://schemas.microsoft.com/office/drawing/2014/main" id="{A460627C-6A84-BFD9-020B-04D76A321D4A}"/>
+              </a:ext>
+            </a:extLst>
+          </p:cNvPr>
+          <p:cNvSpPr/>
+          <p:nvPr/>
+        </p:nvSpPr>
+        <p:spPr bwMode="auto">
+          <a:xfrm>
+            <a:off x="1531940" y="694119"/>
+            <a:ext cx="1210830" cy="1196534"/>
+          </a:xfrm>
+          <a:prstGeom prst="roundRect">
+            <a:avLst>
+              <a:gd name="adj" fmla="val 9941"/>
+            </a:avLst>
+          </a:prstGeom>
+          <a:solidFill>
+            <a:schemeClr val="bg1"/>
+          </a:solidFill>
+          <a:ln>
+            <a:solidFill>
+              <a:schemeClr val="tx1"/>
+            </a:solidFill>
+          </a:ln>
+          <a:effectLst/>
+        </p:spPr>
+        <p:style>
+          <a:lnRef idx="0">
+            <a:schemeClr val="accent4"/>
+          </a:lnRef>
+          <a:fillRef idx="3">
+            <a:schemeClr val="accent4"/>
+          </a:fillRef>
+          <a:effectRef idx="3">
+            <a:schemeClr val="accent4"/>
+          </a:effectRef>
+          <a:fontRef idx="minor">
+            <a:schemeClr val="lt1"/>
+          </a:fontRef>
+        </p:style>
+        <p:txBody>
+          <a:bodyPr rtlCol="1" anchor="ctr"/>
+          <a:lstStyle/>
+          <a:p>
+            <a:pPr rtl="0">
+              <a:defRPr/>
+            </a:pPr>
+            <a:r>
+              <a:rPr lang="en-US" sz="1707" b="1">
+                <a:solidFill>
+                  <a:schemeClr val="bg1"/>
+                </a:solidFill>
+                <a:highlight>
+                  <a:srgbClr val="808000"/>
+                </a:highlight>
+                <a:latin typeface="Segoe UI" panose="020B0502040204020203" pitchFamily="34" charset="0"/>
+                <a:cs typeface="Segoe UI" panose="020B0502040204020203" pitchFamily="34" charset="0"/>
+              </a:rPr>
+              <a:t>CHR</a:t>
+            </a:r>
+          </a:p>
+          <a:p>
+            <a:pPr rtl="0">
+              <a:defRPr/>
+            </a:pPr>
+            <a:r>
+              <a:rPr lang="en-US" sz="1280" b="1">
+                <a:solidFill>
+                  <a:schemeClr val="tx1"/>
+                </a:solidFill>
+                <a:latin typeface="Segoe UI" panose="020B0502040204020203" pitchFamily="34" charset="0"/>
+                <a:cs typeface="Segoe UI" panose="020B0502040204020203" pitchFamily="34" charset="0"/>
+              </a:rPr>
+              <a:t>Chatrooms</a:t>
+            </a:r>
+            <a:endParaRPr sz="1280">
+              <a:solidFill>
+                <a:schemeClr val="tx1"/>
+              </a:solidFill>
+              <a:latin typeface="Segoe UI" panose="020B0502040204020203" pitchFamily="34" charset="0"/>
+              <a:cs typeface="Segoe UI" panose="020B0502040204020203" pitchFamily="34" charset="0"/>
+            </a:endParaRPr>
+          </a:p>
+          <a:p>
+            <a:pPr rtl="0">
+              <a:defRPr/>
+            </a:pPr>
+            <a:r>
+              <a:rPr lang="en-US" sz="853" i="1">
+                <a:solidFill>
+                  <a:schemeClr val="accent5"/>
+                </a:solidFill>
+                <a:latin typeface="Segoe UI" panose="020B0502040204020203" pitchFamily="34" charset="0"/>
+                <a:cs typeface="Segoe UI" panose="020B0502040204020203" pitchFamily="34" charset="0"/>
+              </a:rPr>
+              <a:t>ChatroomId</a:t>
+            </a:r>
+          </a:p>
+          <a:p>
+            <a:pPr rtl="0">
+              <a:defRPr/>
+            </a:pPr>
+            <a:r>
+              <a:rPr lang="en-US" sz="853">
+                <a:solidFill>
+                  <a:schemeClr val="tx1"/>
+                </a:solidFill>
+                <a:latin typeface="Segoe UI" panose="020B0502040204020203" pitchFamily="34" charset="0"/>
+                <a:cs typeface="Segoe UI" panose="020B0502040204020203" pitchFamily="34" charset="0"/>
+              </a:rPr>
+              <a:t>ChatroomUserId</a:t>
+            </a:r>
+          </a:p>
+          <a:p>
+            <a:pPr rtl="0">
+              <a:defRPr/>
+            </a:pPr>
+            <a:r>
+              <a:rPr lang="en-US" sz="853">
+                <a:solidFill>
+                  <a:schemeClr val="tx1"/>
+                </a:solidFill>
+                <a:latin typeface="Segoe UI" panose="020B0502040204020203" pitchFamily="34" charset="0"/>
+                <a:cs typeface="Segoe UI" panose="020B0502040204020203" pitchFamily="34" charset="0"/>
+              </a:rPr>
+              <a:t>ChatroomAdminId</a:t>
+            </a:r>
+          </a:p>
+          <a:p>
+            <a:pPr rtl="0">
+              <a:defRPr/>
+            </a:pPr>
+            <a:r>
+              <a:rPr lang="en-US" sz="853">
+                <a:solidFill>
+                  <a:schemeClr val="tx1"/>
+                </a:solidFill>
+                <a:latin typeface="Segoe UI" panose="020B0502040204020203" pitchFamily="34" charset="0"/>
+                <a:cs typeface="Segoe UI" panose="020B0502040204020203" pitchFamily="34" charset="0"/>
+              </a:rPr>
+              <a:t>ChatroomName</a:t>
+            </a:r>
+          </a:p>
+          <a:p>
+            <a:pPr rtl="0">
+              <a:defRPr/>
+            </a:pPr>
+            <a:r>
+              <a:rPr lang="en-US" sz="853">
+                <a:solidFill>
+                  <a:schemeClr val="tx1"/>
+                </a:solidFill>
+                <a:latin typeface="Segoe UI" panose="020B0502040204020203" pitchFamily="34" charset="0"/>
+                <a:cs typeface="Segoe UI" panose="020B0502040204020203" pitchFamily="34" charset="0"/>
+              </a:rPr>
+              <a:t>ChatroomTerms</a:t>
+            </a:r>
+          </a:p>
+        </p:txBody>
+      </p:sp>
+      <p:sp>
+        <p:nvSpPr>
+          <p:cNvPr id="23" name="Rectangle: Rounded Corners 44">
+            <a:extLst>
+              <a:ext uri="{FF2B5EF4-FFF2-40B4-BE49-F238E27FC236}">
+                <a16:creationId xmlns:a16="http://schemas.microsoft.com/office/drawing/2014/main" id="{60EEA583-4825-92D1-3BD6-2EFF827734DE}"/>
+              </a:ext>
+            </a:extLst>
+          </p:cNvPr>
+          <p:cNvSpPr/>
+          <p:nvPr/>
+        </p:nvSpPr>
+        <p:spPr bwMode="auto">
+          <a:xfrm>
+            <a:off x="8933155" y="133499"/>
+            <a:ext cx="1366068" cy="1748618"/>
+          </a:xfrm>
+          <a:prstGeom prst="roundRect">
+            <a:avLst>
+              <a:gd name="adj" fmla="val 9941"/>
+            </a:avLst>
+          </a:prstGeom>
+          <a:solidFill>
+            <a:schemeClr val="bg1"/>
+          </a:solidFill>
+          <a:ln>
+            <a:solidFill>
+              <a:schemeClr val="tx1"/>
+            </a:solidFill>
+          </a:ln>
+          <a:effectLst/>
+        </p:spPr>
+        <p:style>
+          <a:lnRef idx="0">
+            <a:schemeClr val="accent4"/>
+          </a:lnRef>
+          <a:fillRef idx="3">
+            <a:schemeClr val="accent4"/>
+          </a:fillRef>
+          <a:effectRef idx="3">
+            <a:schemeClr val="accent4"/>
+          </a:effectRef>
+          <a:fontRef idx="minor">
+            <a:schemeClr val="lt1"/>
+          </a:fontRef>
+        </p:style>
+        <p:txBody>
+          <a:bodyPr rtlCol="1" anchor="ctr"/>
+          <a:lstStyle/>
+          <a:p>
+            <a:pPr rtl="0">
+              <a:defRPr/>
+            </a:pPr>
+            <a:r>
+              <a:rPr lang="en-US" sz="1707" b="1">
+                <a:solidFill>
+                  <a:schemeClr val="bg1"/>
+                </a:solidFill>
+                <a:highlight>
+                  <a:srgbClr val="008080"/>
+                </a:highlight>
+                <a:latin typeface="Segoe UI" panose="020B0502040204020203" pitchFamily="34" charset="0"/>
+                <a:cs typeface="Segoe UI" panose="020B0502040204020203" pitchFamily="34" charset="0"/>
+              </a:rPr>
+              <a:t>U</a:t>
+            </a:r>
+          </a:p>
+          <a:p>
+            <a:pPr rtl="0">
+              <a:defRPr/>
+            </a:pPr>
+            <a:r>
+              <a:rPr lang="en-US" sz="1280" b="1">
+                <a:solidFill>
+                  <a:schemeClr val="tx1"/>
+                </a:solidFill>
+                <a:latin typeface="Segoe UI" panose="020B0502040204020203" pitchFamily="34" charset="0"/>
+                <a:cs typeface="Segoe UI" panose="020B0502040204020203" pitchFamily="34" charset="0"/>
+              </a:rPr>
+              <a:t>usrs</a:t>
+            </a:r>
+            <a:endParaRPr sz="1280">
+              <a:solidFill>
+                <a:schemeClr val="tx1"/>
+              </a:solidFill>
+              <a:latin typeface="Segoe UI" panose="020B0502040204020203" pitchFamily="34" charset="0"/>
+              <a:cs typeface="Segoe UI" panose="020B0502040204020203" pitchFamily="34" charset="0"/>
+            </a:endParaRPr>
+          </a:p>
+          <a:p>
+            <a:pPr rtl="0">
+              <a:defRPr/>
+            </a:pPr>
+            <a:r>
+              <a:rPr lang="en-US" sz="853" i="1">
+                <a:solidFill>
+                  <a:schemeClr val="accent5"/>
+                </a:solidFill>
+                <a:latin typeface="Segoe UI" panose="020B0502040204020203" pitchFamily="34" charset="0"/>
+                <a:cs typeface="Segoe UI" panose="020B0502040204020203" pitchFamily="34" charset="0"/>
+              </a:rPr>
+              <a:t>UsrId</a:t>
+            </a:r>
+          </a:p>
+          <a:p>
+            <a:pPr rtl="0">
+              <a:defRPr/>
+            </a:pPr>
+            <a:r>
+              <a:rPr lang="en-US" sz="853">
+                <a:solidFill>
+                  <a:schemeClr val="tx1"/>
+                </a:solidFill>
+                <a:latin typeface="Segoe UI" panose="020B0502040204020203" pitchFamily="34" charset="0"/>
+                <a:cs typeface="Segoe UI" panose="020B0502040204020203" pitchFamily="34" charset="0"/>
+              </a:rPr>
+              <a:t>DepartmentId</a:t>
+            </a:r>
+            <a:endParaRPr lang="en-US" sz="853" i="1">
+              <a:solidFill>
+                <a:schemeClr val="accent5"/>
+              </a:solidFill>
+              <a:latin typeface="Segoe UI" panose="020B0502040204020203" pitchFamily="34" charset="0"/>
+              <a:cs typeface="Segoe UI" panose="020B0502040204020203" pitchFamily="34" charset="0"/>
+            </a:endParaRPr>
+          </a:p>
+          <a:p>
+            <a:pPr rtl="0">
+              <a:defRPr/>
+            </a:pPr>
+            <a:r>
+              <a:rPr lang="en-US" sz="853">
+                <a:solidFill>
+                  <a:schemeClr val="tx1"/>
+                </a:solidFill>
+                <a:latin typeface="Segoe UI" panose="020B0502040204020203" pitchFamily="34" charset="0"/>
+                <a:cs typeface="Segoe UI" panose="020B0502040204020203" pitchFamily="34" charset="0"/>
+              </a:rPr>
+              <a:t>UsrName</a:t>
+            </a:r>
+          </a:p>
+          <a:p>
+            <a:pPr rtl="0">
+              <a:defRPr/>
+            </a:pPr>
+            <a:r>
+              <a:rPr lang="en-US" sz="853">
+                <a:solidFill>
+                  <a:schemeClr val="tx1"/>
+                </a:solidFill>
+                <a:latin typeface="Segoe UI" panose="020B0502040204020203" pitchFamily="34" charset="0"/>
+                <a:cs typeface="Segoe UI" panose="020B0502040204020203" pitchFamily="34" charset="0"/>
+              </a:rPr>
+              <a:t>UsrPass</a:t>
+            </a:r>
+          </a:p>
+          <a:p>
+            <a:pPr rtl="0">
+              <a:defRPr/>
+            </a:pPr>
+            <a:r>
+              <a:rPr lang="en-US" sz="853">
+                <a:solidFill>
+                  <a:schemeClr val="tx1"/>
+                </a:solidFill>
+                <a:latin typeface="Segoe UI" panose="020B0502040204020203" pitchFamily="34" charset="0"/>
+                <a:cs typeface="Segoe UI" panose="020B0502040204020203" pitchFamily="34" charset="0"/>
+              </a:rPr>
+              <a:t>UsrNickname</a:t>
+            </a:r>
+          </a:p>
+          <a:p>
+            <a:pPr rtl="0">
+              <a:defRPr/>
+            </a:pPr>
+            <a:r>
+              <a:rPr lang="en-US" sz="853">
+                <a:solidFill>
+                  <a:schemeClr val="tx1"/>
+                </a:solidFill>
+                <a:latin typeface="Segoe UI" panose="020B0502040204020203" pitchFamily="34" charset="0"/>
+                <a:cs typeface="Segoe UI" panose="020B0502040204020203" pitchFamily="34" charset="0"/>
+              </a:rPr>
+              <a:t>UsrTags</a:t>
+            </a:r>
+            <a:r>
+              <a:rPr lang="en-US" sz="853">
+                <a:solidFill>
+                  <a:srgbClr val="C00000"/>
+                </a:solidFill>
+                <a:latin typeface="Segoe UI" panose="020B0502040204020203" pitchFamily="34" charset="0"/>
+                <a:cs typeface="Segoe UI" panose="020B0502040204020203" pitchFamily="34" charset="0"/>
+              </a:rPr>
+              <a:t> </a:t>
+            </a:r>
+          </a:p>
+          <a:p>
+            <a:pPr marL="90488" rtl="0">
+              <a:defRPr/>
+            </a:pPr>
+            <a:r>
+              <a:rPr lang="en-US" sz="500">
+                <a:solidFill>
+                  <a:srgbClr val="C00000"/>
+                </a:solidFill>
+                <a:latin typeface="Segoe UI" panose="020B0502040204020203" pitchFamily="34" charset="0"/>
+                <a:cs typeface="Segoe UI" panose="020B0502040204020203" pitchFamily="34" charset="0"/>
+              </a:rPr>
+              <a:t>1: IsActive</a:t>
+            </a:r>
+          </a:p>
+          <a:p>
+            <a:pPr marL="90488" rtl="0">
+              <a:defRPr/>
+            </a:pPr>
+            <a:r>
+              <a:rPr lang="en-US" sz="500">
+                <a:solidFill>
+                  <a:srgbClr val="C00000"/>
+                </a:solidFill>
+                <a:latin typeface="Segoe UI" panose="020B0502040204020203" pitchFamily="34" charset="0"/>
+                <a:cs typeface="Segoe UI" panose="020B0502040204020203" pitchFamily="34" charset="0"/>
+              </a:rPr>
+              <a:t>2: ChangePass</a:t>
+            </a:r>
+          </a:p>
+          <a:p>
+            <a:pPr marL="90488" rtl="0">
+              <a:defRPr/>
+            </a:pPr>
+            <a:r>
+              <a:rPr lang="en-US" sz="500">
+                <a:solidFill>
+                  <a:srgbClr val="C00000"/>
+                </a:solidFill>
+                <a:latin typeface="Segoe UI" panose="020B0502040204020203" pitchFamily="34" charset="0"/>
+                <a:cs typeface="Segoe UI" panose="020B0502040204020203" pitchFamily="34" charset="0"/>
+              </a:rPr>
+              <a:t>4    : -          8    : -</a:t>
+            </a:r>
+          </a:p>
+          <a:p>
+            <a:pPr marL="90488" rtl="0">
+              <a:defRPr/>
+            </a:pPr>
+            <a:r>
+              <a:rPr lang="en-US" sz="500">
+                <a:solidFill>
+                  <a:srgbClr val="C00000"/>
+                </a:solidFill>
+                <a:latin typeface="Segoe UI" panose="020B0502040204020203" pitchFamily="34" charset="0"/>
+                <a:cs typeface="Segoe UI" panose="020B0502040204020203" pitchFamily="34" charset="0"/>
+              </a:rPr>
+              <a:t>16  : -          32  : -</a:t>
+            </a:r>
+          </a:p>
+          <a:p>
+            <a:pPr marL="90488" rtl="0">
+              <a:defRPr/>
+            </a:pPr>
+            <a:r>
+              <a:rPr lang="en-US" sz="500">
+                <a:solidFill>
+                  <a:srgbClr val="C00000"/>
+                </a:solidFill>
+                <a:latin typeface="Segoe UI" panose="020B0502040204020203" pitchFamily="34" charset="0"/>
+                <a:cs typeface="Segoe UI" panose="020B0502040204020203" pitchFamily="34" charset="0"/>
+              </a:rPr>
+              <a:t>64  : -          128: SuperUser</a:t>
+            </a:r>
+          </a:p>
+          <a:p>
+            <a:pPr marL="90488" rtl="0">
+              <a:defRPr/>
+            </a:pPr>
+            <a:r>
+              <a:rPr lang="en-US" sz="500">
+                <a:solidFill>
+                  <a:srgbClr val="C00000"/>
+                </a:solidFill>
+                <a:latin typeface="Segoe UI" panose="020B0502040204020203" pitchFamily="34" charset="0"/>
+                <a:cs typeface="Segoe UI" panose="020B0502040204020203" pitchFamily="34" charset="0"/>
+              </a:rPr>
+              <a:t>256: CalendarFa</a:t>
+            </a:r>
+          </a:p>
+        </p:txBody>
+      </p:sp>
+      <p:sp>
+        <p:nvSpPr>
+          <p:cNvPr id="20" name="Rectangle: Rounded Corners 44">
+            <a:extLst>
+              <a:ext uri="{FF2B5EF4-FFF2-40B4-BE49-F238E27FC236}">
+                <a16:creationId xmlns:a16="http://schemas.microsoft.com/office/drawing/2014/main" id="{C1A287B8-4523-C3A6-B4FC-EC364E463395}"/>
+              </a:ext>
+            </a:extLst>
+          </p:cNvPr>
+          <p:cNvSpPr/>
+          <p:nvPr/>
+        </p:nvSpPr>
+        <p:spPr bwMode="auto">
+          <a:xfrm>
+            <a:off x="10104553" y="236209"/>
+            <a:ext cx="1344323" cy="915820"/>
+          </a:xfrm>
+          <a:prstGeom prst="roundRect">
+            <a:avLst>
+              <a:gd name="adj" fmla="val 9941"/>
+            </a:avLst>
+          </a:prstGeom>
+          <a:solidFill>
+            <a:schemeClr val="bg1"/>
+          </a:solidFill>
+          <a:ln>
+            <a:solidFill>
+              <a:schemeClr val="tx1"/>
+            </a:solidFill>
+          </a:ln>
+          <a:effectLst/>
+        </p:spPr>
+        <p:style>
+          <a:lnRef idx="0">
+            <a:schemeClr val="accent4"/>
+          </a:lnRef>
+          <a:fillRef idx="3">
+            <a:schemeClr val="accent4"/>
+          </a:fillRef>
+          <a:effectRef idx="3">
+            <a:schemeClr val="accent4"/>
+          </a:effectRef>
+          <a:fontRef idx="minor">
+            <a:schemeClr val="lt1"/>
+          </a:fontRef>
+        </p:style>
+        <p:txBody>
+          <a:bodyPr rtlCol="1" anchor="ctr"/>
+          <a:lstStyle/>
+          <a:p>
+            <a:pPr rtl="0">
+              <a:defRPr/>
+            </a:pPr>
+            <a:r>
+              <a:rPr lang="en-US" sz="1707" b="1">
+                <a:solidFill>
+                  <a:schemeClr val="bg1"/>
+                </a:solidFill>
+                <a:highlight>
+                  <a:srgbClr val="C0C0C0"/>
+                </a:highlight>
+                <a:latin typeface="Segoe UI" panose="020B0502040204020203" pitchFamily="34" charset="0"/>
+                <a:cs typeface="Segoe UI" panose="020B0502040204020203" pitchFamily="34" charset="0"/>
+              </a:rPr>
+              <a:t>D</a:t>
+            </a:r>
+          </a:p>
+          <a:p>
+            <a:pPr rtl="0">
+              <a:defRPr/>
+            </a:pPr>
+            <a:r>
+              <a:rPr lang="en-US" sz="1280" b="1">
+                <a:solidFill>
+                  <a:schemeClr val="tx1"/>
+                </a:solidFill>
+                <a:latin typeface="Segoe UI" panose="020B0502040204020203" pitchFamily="34" charset="0"/>
+                <a:cs typeface="Segoe UI" panose="020B0502040204020203" pitchFamily="34" charset="0"/>
+              </a:rPr>
+              <a:t>Departments</a:t>
+            </a:r>
+            <a:endParaRPr sz="1280">
+              <a:solidFill>
+                <a:schemeClr val="tx1"/>
+              </a:solidFill>
+              <a:latin typeface="Segoe UI" panose="020B0502040204020203" pitchFamily="34" charset="0"/>
+              <a:cs typeface="Segoe UI" panose="020B0502040204020203" pitchFamily="34" charset="0"/>
+            </a:endParaRPr>
+          </a:p>
+          <a:p>
+            <a:pPr rtl="0">
+              <a:defRPr/>
+            </a:pPr>
+            <a:r>
+              <a:rPr lang="en-US" sz="853">
+                <a:solidFill>
+                  <a:schemeClr val="tx1"/>
+                </a:solidFill>
+                <a:latin typeface="Segoe UI" panose="020B0502040204020203" pitchFamily="34" charset="0"/>
+                <a:cs typeface="Segoe UI" panose="020B0502040204020203" pitchFamily="34" charset="0"/>
+              </a:rPr>
+              <a:t>DepartmentId</a:t>
+            </a:r>
+          </a:p>
+          <a:p>
+            <a:pPr rtl="0">
+              <a:defRPr/>
+            </a:pPr>
+            <a:r>
+              <a:rPr lang="en-US" sz="853">
+                <a:solidFill>
+                  <a:schemeClr val="tx1"/>
+                </a:solidFill>
+                <a:latin typeface="Segoe UI" panose="020B0502040204020203" pitchFamily="34" charset="0"/>
+                <a:cs typeface="Segoe UI" panose="020B0502040204020203" pitchFamily="34" charset="0"/>
+              </a:rPr>
+              <a:t>DepartmentName</a:t>
+            </a:r>
+          </a:p>
+          <a:p>
+            <a:pPr rtl="0">
+              <a:defRPr/>
+            </a:pPr>
+            <a:r>
+              <a:rPr lang="en-US" sz="853">
+                <a:solidFill>
+                  <a:schemeClr val="tx1"/>
+                </a:solidFill>
+                <a:latin typeface="Segoe UI" panose="020B0502040204020203" pitchFamily="34" charset="0"/>
+                <a:cs typeface="Segoe UI" panose="020B0502040204020203" pitchFamily="34" charset="0"/>
+              </a:rPr>
+              <a:t>DepartmentInfo</a:t>
             </a:r>
           </a:p>
         </p:txBody>
@@ -7290,7 +8679,7 @@
         </p:nvSpPr>
         <p:spPr>
           <a:xfrm>
-            <a:off x="1585325" y="6149940"/>
+            <a:off x="1106851" y="6294666"/>
             <a:ext cx="1316313" cy="1122060"/>
           </a:xfrm>
           <a:prstGeom prst="roundRect">
@@ -7413,290 +8802,10 @@
       </p:sp>
       <p:sp>
         <p:nvSpPr>
-          <p:cNvPr id="16" name="Rectangle: Rounded Corners 15">
+          <p:cNvPr id="22" name="Rectangle: Rounded Corners 44">
             <a:extLst>
               <a:ext uri="{FF2B5EF4-FFF2-40B4-BE49-F238E27FC236}">
-                <a16:creationId xmlns:a16="http://schemas.microsoft.com/office/drawing/2014/main" id="{8EB7AD94-FB73-258B-E14F-D29425205938}"/>
-              </a:ext>
-            </a:extLst>
-          </p:cNvPr>
-          <p:cNvSpPr/>
-          <p:nvPr/>
-        </p:nvSpPr>
-        <p:spPr>
-          <a:xfrm>
-            <a:off x="632108" y="6149941"/>
-            <a:ext cx="997025" cy="1301732"/>
-          </a:xfrm>
-          <a:prstGeom prst="roundRect">
-            <a:avLst>
-              <a:gd name="adj" fmla="val 8313"/>
-            </a:avLst>
-          </a:prstGeom>
-          <a:solidFill>
-            <a:schemeClr val="bg1"/>
-          </a:solidFill>
-          <a:ln>
-            <a:solidFill>
-              <a:schemeClr val="tx1">
-                <a:lumMod val="65000"/>
-                <a:lumOff val="35000"/>
-              </a:schemeClr>
-            </a:solidFill>
-          </a:ln>
-        </p:spPr>
-        <p:style>
-          <a:lnRef idx="1">
-            <a:schemeClr val="accent4"/>
-          </a:lnRef>
-          <a:fillRef idx="2">
-            <a:schemeClr val="accent4"/>
-          </a:fillRef>
-          <a:effectRef idx="1">
-            <a:schemeClr val="accent4"/>
-          </a:effectRef>
-          <a:fontRef idx="minor">
-            <a:schemeClr val="dk1"/>
-          </a:fontRef>
-        </p:style>
-        <p:txBody>
-          <a:bodyPr rtlCol="1" anchor="t"/>
-          <a:lstStyle/>
-          <a:p>
-            <a:pPr rtl="0"/>
-            <a:r>
-              <a:rPr lang="en-US" sz="1707" b="1" dirty="0">
-                <a:solidFill>
-                  <a:schemeClr val="bg1"/>
-                </a:solidFill>
-                <a:highlight>
-                  <a:srgbClr val="000000"/>
-                </a:highlight>
-              </a:rPr>
-              <a:t>P</a:t>
-            </a:r>
-            <a:r>
-              <a:rPr lang="en-US" sz="1280" b="1" dirty="0"/>
-              <a:t>rojects</a:t>
-            </a:r>
-            <a:endParaRPr lang="en-US" sz="853" b="1" dirty="0"/>
-          </a:p>
-          <a:p>
-            <a:pPr rtl="0"/>
-            <a:r>
-              <a:rPr lang="en-US" sz="853" i="1">
-                <a:solidFill>
-                  <a:schemeClr val="accent5"/>
-                </a:solidFill>
-                <a:latin typeface="Segoe UI" panose="020B0502040204020203" pitchFamily="34" charset="0"/>
-                <a:cs typeface="Segoe UI" panose="020B0502040204020203" pitchFamily="34" charset="0"/>
-              </a:rPr>
-              <a:t>ProjectId</a:t>
-            </a:r>
-          </a:p>
-          <a:p>
-            <a:pPr rtl="0"/>
-            <a:r>
-              <a:rPr lang="en-US" sz="853">
-                <a:solidFill>
-                  <a:schemeClr val="tx1"/>
-                </a:solidFill>
-              </a:rPr>
-              <a:t>UserId</a:t>
-            </a:r>
-          </a:p>
-          <a:p>
-            <a:pPr rtl="0"/>
-            <a:r>
-              <a:rPr lang="en-US" sz="853">
-                <a:solidFill>
-                  <a:schemeClr val="tx1"/>
-                </a:solidFill>
-              </a:rPr>
-              <a:t>UserType</a:t>
-            </a:r>
-          </a:p>
-          <a:p>
-            <a:pPr rtl="0">
-              <a:buNone/>
-            </a:pPr>
-            <a:r>
-              <a:rPr lang="en-US" sz="600" kern="100">
-                <a:solidFill>
-                  <a:schemeClr val="tx1"/>
-                </a:solidFill>
-                <a:latin typeface="Consolas" panose="020B0609020204030204" pitchFamily="49" charset="0"/>
-                <a:ea typeface="Calibri" panose="020F0502020204030204" pitchFamily="34" charset="0"/>
-                <a:cs typeface="Calibri Light" panose="020F0302020204030204" pitchFamily="34" charset="0"/>
-              </a:rPr>
-              <a:t> 1:Teacher</a:t>
-            </a:r>
-          </a:p>
-          <a:p>
-            <a:pPr rtl="0">
-              <a:buNone/>
-            </a:pPr>
-            <a:r>
-              <a:rPr lang="en-US" sz="600" kern="100">
-                <a:solidFill>
-                  <a:schemeClr val="tx1"/>
-                </a:solidFill>
-                <a:latin typeface="Consolas" panose="020B0609020204030204" pitchFamily="49" charset="0"/>
-                <a:ea typeface="Calibri" panose="020F0502020204030204" pitchFamily="34" charset="0"/>
-                <a:cs typeface="Calibri Light" panose="020F0302020204030204" pitchFamily="34" charset="0"/>
-              </a:rPr>
-              <a:t> 2:Student</a:t>
-            </a:r>
-            <a:endParaRPr lang="en-US" sz="853" dirty="0"/>
-          </a:p>
-          <a:p>
-            <a:pPr rtl="0"/>
-            <a:r>
-              <a:rPr lang="en-US" sz="853" dirty="0" err="1"/>
-              <a:t>ProjectName</a:t>
-            </a:r>
-            <a:endParaRPr lang="en-US" sz="853" dirty="0"/>
-          </a:p>
-          <a:p>
-            <a:pPr rtl="0"/>
-            <a:r>
-              <a:rPr lang="en-US" sz="853">
-                <a:solidFill>
-                  <a:schemeClr val="tx1"/>
-                </a:solidFill>
-              </a:rPr>
-              <a:t>ProjectTags</a:t>
-            </a:r>
-          </a:p>
-          <a:p>
-            <a:pPr rtl="0"/>
-            <a:r>
-              <a:rPr lang="en-US" sz="500" kern="100">
-                <a:solidFill>
-                  <a:srgbClr val="C00000"/>
-                </a:solidFill>
-                <a:latin typeface="Consolas" panose="020B0609020204030204" pitchFamily="49" charset="0"/>
-                <a:ea typeface="Calibri" panose="020F0502020204030204" pitchFamily="34" charset="0"/>
-                <a:cs typeface="Calibri Light" panose="020F0302020204030204" pitchFamily="34" charset="0"/>
-              </a:rPr>
-              <a:t> 1:active</a:t>
-            </a:r>
-          </a:p>
-        </p:txBody>
-      </p:sp>
-      <p:sp>
-        <p:nvSpPr>
-          <p:cNvPr id="3" name="Rectangle: Rounded Corners 2">
-            <a:extLst>
-              <a:ext uri="{FF2B5EF4-FFF2-40B4-BE49-F238E27FC236}">
-                <a16:creationId xmlns:a16="http://schemas.microsoft.com/office/drawing/2014/main" id="{4E95C3AB-3ADD-0B38-7306-5F78CAD1B483}"/>
-              </a:ext>
-            </a:extLst>
-          </p:cNvPr>
-          <p:cNvSpPr/>
-          <p:nvPr/>
-        </p:nvSpPr>
-        <p:spPr>
-          <a:xfrm>
-            <a:off x="3440149" y="6209602"/>
-            <a:ext cx="909928" cy="721108"/>
-          </a:xfrm>
-          <a:prstGeom prst="roundRect">
-            <a:avLst>
-              <a:gd name="adj" fmla="val 4805"/>
-            </a:avLst>
-          </a:prstGeom>
-          <a:solidFill>
-            <a:schemeClr val="bg1"/>
-          </a:solidFill>
-          <a:ln>
-            <a:solidFill>
-              <a:schemeClr val="tx1">
-                <a:lumMod val="65000"/>
-                <a:lumOff val="35000"/>
-              </a:schemeClr>
-            </a:solidFill>
-          </a:ln>
-        </p:spPr>
-        <p:style>
-          <a:lnRef idx="1">
-            <a:schemeClr val="accent4"/>
-          </a:lnRef>
-          <a:fillRef idx="2">
-            <a:schemeClr val="accent4"/>
-          </a:fillRef>
-          <a:effectRef idx="1">
-            <a:schemeClr val="accent4"/>
-          </a:effectRef>
-          <a:fontRef idx="minor">
-            <a:schemeClr val="dk1"/>
-          </a:fontRef>
-        </p:style>
-        <p:txBody>
-          <a:bodyPr rtlCol="1" anchor="t"/>
-          <a:lstStyle/>
-          <a:p>
-            <a:pPr rtl="0"/>
-            <a:r>
-              <a:rPr lang="en-US" sz="1707" b="1" dirty="0" err="1">
-                <a:solidFill>
-                  <a:schemeClr val="bg1"/>
-                </a:solidFill>
-                <a:highlight>
-                  <a:srgbClr val="000000"/>
-                </a:highlight>
-              </a:rPr>
-              <a:t>N</a:t>
-            </a:r>
-            <a:r>
-              <a:rPr lang="en-US" sz="1280" b="1" dirty="0" err="1"/>
-              <a:t>oteNet</a:t>
-            </a:r>
-            <a:endParaRPr lang="en-US" sz="1280" b="1" dirty="0"/>
-          </a:p>
-          <a:p>
-            <a:pPr rtl="0"/>
-            <a:r>
-              <a:rPr lang="en-US" sz="853" i="1">
-                <a:solidFill>
-                  <a:schemeClr val="accent5"/>
-                </a:solidFill>
-                <a:latin typeface="Segoe UI" panose="020B0502040204020203" pitchFamily="34" charset="0"/>
-                <a:cs typeface="Segoe UI" panose="020B0502040204020203" pitchFamily="34" charset="0"/>
-              </a:rPr>
-              <a:t>NoteNetId</a:t>
-            </a:r>
-            <a:endParaRPr lang="en-US" sz="853" i="1" dirty="0">
-              <a:solidFill>
-                <a:schemeClr val="accent5"/>
-              </a:solidFill>
-              <a:latin typeface="Segoe UI" panose="020B0502040204020203" pitchFamily="34" charset="0"/>
-              <a:cs typeface="Segoe UI" panose="020B0502040204020203" pitchFamily="34" charset="0"/>
-            </a:endParaRPr>
-          </a:p>
-          <a:p>
-            <a:pPr rtl="0"/>
-            <a:r>
-              <a:rPr lang="en-US" sz="853"/>
-              <a:t>NoteAId</a:t>
-            </a:r>
-          </a:p>
-          <a:p>
-            <a:pPr rtl="0"/>
-            <a:r>
-              <a:rPr lang="en-US" sz="853"/>
-              <a:t>NoteBId</a:t>
-            </a:r>
-            <a:endParaRPr lang="en-US" sz="853" dirty="0"/>
-          </a:p>
-        </p:txBody>
-      </p:sp>
-      <p:sp>
-        <p:nvSpPr>
-          <p:cNvPr id="17" name="Callout: Bent Line 16">
-            <a:extLst>
-              <a:ext uri="{FF2B5EF4-FFF2-40B4-BE49-F238E27FC236}">
-                <a16:creationId xmlns:a16="http://schemas.microsoft.com/office/drawing/2014/main" id="{D7A96907-C393-6D27-7271-FEC08798F246}"/>
+                <a16:creationId xmlns:a16="http://schemas.microsoft.com/office/drawing/2014/main" id="{1829AC77-A972-B3B8-4EF9-16E84E6DAF15}"/>
               </a:ext>
             </a:extLst>
           </p:cNvPr>
@@ -7705,419 +8814,8 @@
         </p:nvSpPr>
         <p:spPr bwMode="auto">
           <a:xfrm>
-            <a:off x="1796568" y="7479661"/>
-            <a:ext cx="1105070" cy="787849"/>
-          </a:xfrm>
-          <a:prstGeom prst="borderCallout2">
-            <a:avLst>
-              <a:gd name="adj1" fmla="val -1024"/>
-              <a:gd name="adj2" fmla="val 85567"/>
-              <a:gd name="adj3" fmla="val 366"/>
-              <a:gd name="adj4" fmla="val 82159"/>
-              <a:gd name="adj5" fmla="val 180"/>
-              <a:gd name="adj6" fmla="val 85711"/>
-            </a:avLst>
-          </a:prstGeom>
-          <a:noFill/>
-          <a:ln>
-            <a:prstDash val="dash"/>
-          </a:ln>
-        </p:spPr>
-        <p:style>
-          <a:lnRef idx="2">
-            <a:schemeClr val="accent1">
-              <a:shade val="15000"/>
-            </a:schemeClr>
-          </a:lnRef>
-          <a:fillRef idx="1">
-            <a:schemeClr val="accent1"/>
-          </a:fillRef>
-          <a:effectRef idx="0">
-            <a:schemeClr val="accent1"/>
-          </a:effectRef>
-          <a:fontRef idx="minor">
-            <a:schemeClr val="lt1"/>
-          </a:fontRef>
-        </p:style>
-        <p:txBody>
-          <a:bodyPr rtlCol="1" anchor="ctr"/>
-          <a:lstStyle/>
-          <a:p>
-            <a:pPr rtl="0">
-              <a:buNone/>
-            </a:pPr>
-            <a:r>
-              <a:rPr lang="en-US" sz="500" kern="100">
-                <a:solidFill>
-                  <a:schemeClr val="tx1"/>
-                </a:solidFill>
-                <a:latin typeface="Consolas" panose="020B0609020204030204" pitchFamily="49" charset="0"/>
-                <a:ea typeface="Calibri" panose="020F0502020204030204" pitchFamily="34" charset="0"/>
-                <a:cs typeface="Calibri Light" panose="020F0302020204030204" pitchFamily="34" charset="0"/>
-              </a:rPr>
-              <a:t>NoteTypes:</a:t>
-            </a:r>
-          </a:p>
-          <a:p>
-            <a:pPr rtl="0">
-              <a:buNone/>
-            </a:pPr>
-            <a:r>
-              <a:rPr lang="en-US" sz="500" kern="100">
-                <a:solidFill>
-                  <a:schemeClr val="tx1"/>
-                </a:solidFill>
-                <a:latin typeface="Consolas" panose="020B0609020204030204" pitchFamily="49" charset="0"/>
-                <a:ea typeface="Calibri" panose="020F0502020204030204" pitchFamily="34" charset="0"/>
-                <a:cs typeface="Calibri Light" panose="020F0302020204030204" pitchFamily="34" charset="0"/>
-              </a:rPr>
-              <a:t> 1: S: quickNote</a:t>
-            </a:r>
-          </a:p>
-          <a:p>
-            <a:pPr rtl="0">
-              <a:buNone/>
-            </a:pPr>
-            <a:r>
-              <a:rPr lang="en-US" sz="500" kern="100">
-                <a:solidFill>
-                  <a:schemeClr val="tx1"/>
-                </a:solidFill>
-                <a:latin typeface="Consolas" panose="020B0609020204030204" pitchFamily="49" charset="0"/>
-                <a:ea typeface="Calibri" panose="020F0502020204030204" pitchFamily="34" charset="0"/>
-                <a:cs typeface="Calibri Light" panose="020F0302020204030204" pitchFamily="34" charset="0"/>
-              </a:rPr>
-              <a:t> 2: S: sectionNote</a:t>
-            </a:r>
-          </a:p>
-          <a:p>
-            <a:pPr rtl="0">
-              <a:buNone/>
-            </a:pPr>
-            <a:r>
-              <a:rPr lang="en-US" sz="500" kern="100">
-                <a:solidFill>
-                  <a:schemeClr val="tx1"/>
-                </a:solidFill>
-                <a:latin typeface="Consolas" panose="020B0609020204030204" pitchFamily="49" charset="0"/>
-                <a:ea typeface="Calibri" panose="020F0502020204030204" pitchFamily="34" charset="0"/>
-                <a:cs typeface="Calibri Light" panose="020F0302020204030204" pitchFamily="34" charset="0"/>
-              </a:rPr>
-              <a:t>11: T: quickNote</a:t>
-            </a:r>
-          </a:p>
-          <a:p>
-            <a:pPr rtl="0">
-              <a:buNone/>
-            </a:pPr>
-            <a:r>
-              <a:rPr lang="en-US" sz="500" kern="100">
-                <a:solidFill>
-                  <a:schemeClr val="tx1"/>
-                </a:solidFill>
-                <a:latin typeface="Consolas" panose="020B0609020204030204" pitchFamily="49" charset="0"/>
-                <a:ea typeface="Calibri" panose="020F0502020204030204" pitchFamily="34" charset="0"/>
-                <a:cs typeface="Calibri Light" panose="020F0302020204030204" pitchFamily="34" charset="0"/>
-              </a:rPr>
-              <a:t>12: T: sectionNote</a:t>
-            </a:r>
-          </a:p>
-          <a:p>
-            <a:pPr rtl="0">
-              <a:buNone/>
-            </a:pPr>
-            <a:r>
-              <a:rPr lang="en-US" sz="500" kern="100">
-                <a:solidFill>
-                  <a:schemeClr val="tx1"/>
-                </a:solidFill>
-                <a:latin typeface="Consolas" panose="020B0609020204030204" pitchFamily="49" charset="0"/>
-                <a:ea typeface="Calibri" panose="020F0502020204030204" pitchFamily="34" charset="0"/>
-                <a:cs typeface="Calibri Light" panose="020F0302020204030204" pitchFamily="34" charset="0"/>
-              </a:rPr>
-              <a:t>13: T: note on Student</a:t>
-            </a:r>
-          </a:p>
-          <a:p>
-            <a:pPr rtl="0">
-              <a:buNone/>
-            </a:pPr>
-            <a:r>
-              <a:rPr lang="en-US" sz="500" kern="100">
-                <a:solidFill>
-                  <a:schemeClr val="tx1"/>
-                </a:solidFill>
-                <a:latin typeface="Consolas" panose="020B0609020204030204" pitchFamily="49" charset="0"/>
-                <a:ea typeface="Calibri" panose="020F0502020204030204" pitchFamily="34" charset="0"/>
-                <a:cs typeface="Calibri Light" panose="020F0302020204030204" pitchFamily="34" charset="0"/>
-              </a:rPr>
-              <a:t>14: T: note on Group</a:t>
-            </a:r>
-          </a:p>
-          <a:p>
-            <a:pPr rtl="0">
-              <a:buNone/>
-            </a:pPr>
-            <a:r>
-              <a:rPr lang="en-US" sz="500" kern="100">
-                <a:solidFill>
-                  <a:schemeClr val="tx1"/>
-                </a:solidFill>
-                <a:latin typeface="Consolas" panose="020B0609020204030204" pitchFamily="49" charset="0"/>
-                <a:ea typeface="Calibri" panose="020F0502020204030204" pitchFamily="34" charset="0"/>
-                <a:cs typeface="Calibri Light" panose="020F0302020204030204" pitchFamily="34" charset="0"/>
-              </a:rPr>
-              <a:t>15: T: note on Course</a:t>
-            </a:r>
-          </a:p>
-          <a:p>
-            <a:pPr rtl="0">
-              <a:buNone/>
-            </a:pPr>
-            <a:r>
-              <a:rPr lang="en-US" sz="500" kern="100">
-                <a:solidFill>
-                  <a:schemeClr val="tx1"/>
-                </a:solidFill>
-                <a:latin typeface="Consolas" panose="020B0609020204030204" pitchFamily="49" charset="0"/>
-                <a:ea typeface="Calibri" panose="020F0502020204030204" pitchFamily="34" charset="0"/>
-                <a:cs typeface="Calibri Light" panose="020F0302020204030204" pitchFamily="34" charset="0"/>
-              </a:rPr>
-              <a:t>16: T: note on Exam</a:t>
-            </a:r>
-          </a:p>
-          <a:p>
-            <a:pPr rtl="0">
-              <a:buNone/>
-            </a:pPr>
-            <a:r>
-              <a:rPr lang="en-US" sz="500" kern="100">
-                <a:solidFill>
-                  <a:schemeClr val="tx1"/>
-                </a:solidFill>
-                <a:latin typeface="Consolas" panose="020B0609020204030204" pitchFamily="49" charset="0"/>
-                <a:ea typeface="Calibri" panose="020F0502020204030204" pitchFamily="34" charset="0"/>
-                <a:cs typeface="Calibri Light" panose="020F0302020204030204" pitchFamily="34" charset="0"/>
-              </a:rPr>
-              <a:t>17: T: note on StudentExam</a:t>
-            </a:r>
-          </a:p>
-        </p:txBody>
-      </p:sp>
-      <p:sp>
-        <p:nvSpPr>
-          <p:cNvPr id="18" name="Rectangle: Rounded Corners 45">
-            <a:extLst>
-              <a:ext uri="{FF2B5EF4-FFF2-40B4-BE49-F238E27FC236}">
-                <a16:creationId xmlns:a16="http://schemas.microsoft.com/office/drawing/2014/main" id="{84CF63F6-9EC1-FF7B-5327-5C2174F26690}"/>
-              </a:ext>
-            </a:extLst>
-          </p:cNvPr>
-          <p:cNvSpPr/>
-          <p:nvPr/>
-        </p:nvSpPr>
-        <p:spPr bwMode="auto">
-          <a:xfrm>
-            <a:off x="2794325" y="588887"/>
-            <a:ext cx="1516599" cy="1411701"/>
-          </a:xfrm>
-          <a:prstGeom prst="roundRect">
-            <a:avLst>
-              <a:gd name="adj" fmla="val 8076"/>
-            </a:avLst>
-          </a:prstGeom>
-          <a:solidFill>
-            <a:schemeClr val="bg1"/>
-          </a:solidFill>
-          <a:ln w="28575">
-            <a:solidFill>
-              <a:schemeClr val="tx1"/>
-            </a:solidFill>
-            <a:prstDash val="solid"/>
-          </a:ln>
-          <a:effectLst/>
-        </p:spPr>
-        <p:style>
-          <a:lnRef idx="0">
-            <a:schemeClr val="accent4"/>
-          </a:lnRef>
-          <a:fillRef idx="3">
-            <a:schemeClr val="accent4"/>
-          </a:fillRef>
-          <a:effectRef idx="3">
-            <a:schemeClr val="accent4"/>
-          </a:effectRef>
-          <a:fontRef idx="minor">
-            <a:schemeClr val="lt1"/>
-          </a:fontRef>
-        </p:style>
-        <p:txBody>
-          <a:bodyPr rtlCol="1" anchor="ctr"/>
-          <a:lstStyle/>
-          <a:p>
-            <a:pPr algn="l" rtl="0">
-              <a:defRPr/>
-            </a:pPr>
-            <a:r>
-              <a:rPr lang="en-US" sz="1707" b="1">
-                <a:solidFill>
-                  <a:schemeClr val="bg1"/>
-                </a:solidFill>
-                <a:highlight>
-                  <a:srgbClr val="800080"/>
-                </a:highlight>
-                <a:latin typeface="Segoe UI" panose="020B0502040204020203" pitchFamily="34" charset="0"/>
-                <a:cs typeface="Segoe UI" panose="020B0502040204020203" pitchFamily="34" charset="0"/>
-              </a:rPr>
-              <a:t>CH</a:t>
-            </a:r>
-          </a:p>
-          <a:p>
-            <a:pPr rtl="0">
-              <a:defRPr/>
-            </a:pPr>
-            <a:r>
-              <a:rPr lang="en-US" sz="1280" b="1">
-                <a:solidFill>
-                  <a:schemeClr val="tx1"/>
-                </a:solidFill>
-                <a:latin typeface="Segoe UI" panose="020B0502040204020203" pitchFamily="34" charset="0"/>
-                <a:cs typeface="Segoe UI" panose="020B0502040204020203" pitchFamily="34" charset="0"/>
-              </a:rPr>
-              <a:t>Chats</a:t>
-            </a:r>
-            <a:endParaRPr sz="1280">
-              <a:solidFill>
-                <a:schemeClr val="tx1"/>
-              </a:solidFill>
-              <a:latin typeface="Segoe UI" panose="020B0502040204020203" pitchFamily="34" charset="0"/>
-              <a:cs typeface="Segoe UI" panose="020B0502040204020203" pitchFamily="34" charset="0"/>
-            </a:endParaRPr>
-          </a:p>
-          <a:p>
-            <a:pPr rtl="0">
-              <a:defRPr/>
-            </a:pPr>
-            <a:r>
-              <a:rPr lang="en-US" sz="853" i="1">
-                <a:solidFill>
-                  <a:schemeClr val="accent5"/>
-                </a:solidFill>
-                <a:latin typeface="Segoe UI" panose="020B0502040204020203" pitchFamily="34" charset="0"/>
-                <a:cs typeface="Segoe UI" panose="020B0502040204020203" pitchFamily="34" charset="0"/>
-              </a:rPr>
-              <a:t>ChatId</a:t>
-            </a:r>
-          </a:p>
-          <a:p>
-            <a:pPr rtl="0">
-              <a:defRPr/>
-            </a:pPr>
-            <a:r>
-              <a:rPr lang="en-US" sz="853">
-                <a:solidFill>
-                  <a:schemeClr val="tx1"/>
-                </a:solidFill>
-                <a:latin typeface="Segoe UI" panose="020B0502040204020203" pitchFamily="34" charset="0"/>
-                <a:cs typeface="Segoe UI" panose="020B0502040204020203" pitchFamily="34" charset="0"/>
-              </a:rPr>
-              <a:t>FromId</a:t>
-            </a:r>
-          </a:p>
-          <a:p>
-            <a:pPr rtl="0">
-              <a:defRPr/>
-            </a:pPr>
-            <a:r>
-              <a:rPr lang="en-US" sz="853">
-                <a:solidFill>
-                  <a:schemeClr val="tx1"/>
-                </a:solidFill>
-                <a:latin typeface="Segoe UI" panose="020B0502040204020203" pitchFamily="34" charset="0"/>
-                <a:cs typeface="Segoe UI" panose="020B0502040204020203" pitchFamily="34" charset="0"/>
-              </a:rPr>
-              <a:t>ToId</a:t>
-            </a:r>
-          </a:p>
-          <a:p>
-            <a:pPr rtl="0">
-              <a:defRPr/>
-            </a:pPr>
-            <a:r>
-              <a:rPr lang="en-US" sz="853">
-                <a:solidFill>
-                  <a:schemeClr val="tx1"/>
-                </a:solidFill>
-                <a:latin typeface="Segoe UI" panose="020B0502040204020203" pitchFamily="34" charset="0"/>
-                <a:cs typeface="Segoe UI" panose="020B0502040204020203" pitchFamily="34" charset="0"/>
-              </a:rPr>
-              <a:t>DateTimeSent</a:t>
-            </a:r>
-          </a:p>
-          <a:p>
-            <a:pPr rtl="0">
-              <a:defRPr/>
-            </a:pPr>
-            <a:r>
-              <a:rPr lang="en-US" sz="853">
-                <a:solidFill>
-                  <a:schemeClr val="tx1"/>
-                </a:solidFill>
-                <a:latin typeface="Segoe UI" panose="020B0502040204020203" pitchFamily="34" charset="0"/>
-                <a:cs typeface="Segoe UI" panose="020B0502040204020203" pitchFamily="34" charset="0"/>
-              </a:rPr>
-              <a:t>ChatText</a:t>
-            </a:r>
-          </a:p>
-          <a:p>
-            <a:pPr rtl="0">
-              <a:defRPr/>
-            </a:pPr>
-            <a:r>
-              <a:rPr lang="en-US" sz="853">
-                <a:solidFill>
-                  <a:schemeClr val="tx1"/>
-                </a:solidFill>
-                <a:latin typeface="Segoe UI" panose="020B0502040204020203" pitchFamily="34" charset="0"/>
-                <a:cs typeface="Segoe UI" panose="020B0502040204020203" pitchFamily="34" charset="0"/>
-              </a:rPr>
-              <a:t>ChatTags</a:t>
-            </a:r>
-          </a:p>
-          <a:p>
-            <a:pPr rtl="0">
-              <a:defRPr/>
-            </a:pPr>
-            <a:r>
-              <a:rPr lang="en-US" sz="600" kern="100">
-                <a:solidFill>
-                  <a:schemeClr val="tx1"/>
-                </a:solidFill>
-                <a:latin typeface="Consolas" panose="020B0609020204030204" pitchFamily="49" charset="0"/>
-                <a:ea typeface="Calibri" panose="020F0502020204030204" pitchFamily="34" charset="0"/>
-                <a:cs typeface="Calibri Light" panose="020F0302020204030204" pitchFamily="34" charset="0"/>
-              </a:rPr>
-              <a:t>1:Read 2:Imp 3:Bookmark 4:Del</a:t>
-            </a:r>
-          </a:p>
-        </p:txBody>
-      </p:sp>
-      <p:sp>
-        <p:nvSpPr>
-          <p:cNvPr id="25" name="Rectangle: Rounded Corners 44">
-            <a:extLst>
-              <a:ext uri="{FF2B5EF4-FFF2-40B4-BE49-F238E27FC236}">
-                <a16:creationId xmlns:a16="http://schemas.microsoft.com/office/drawing/2014/main" id="{A460627C-6A84-BFD9-020B-04D76A321D4A}"/>
-              </a:ext>
-            </a:extLst>
-          </p:cNvPr>
-          <p:cNvSpPr/>
-          <p:nvPr/>
-        </p:nvSpPr>
-        <p:spPr bwMode="auto">
-          <a:xfrm>
-            <a:off x="1544309" y="157639"/>
-            <a:ext cx="1210830" cy="1196534"/>
+            <a:off x="10120219" y="1540287"/>
+            <a:ext cx="1077711" cy="915820"/>
           </a:xfrm>
           <a:prstGeom prst="roundRect">
             <a:avLst>
@@ -8161,12 +8859,12 @@
                   <a:schemeClr val="bg1"/>
                 </a:solidFill>
                 <a:highlight>
-                  <a:srgbClr val="808000"/>
+                  <a:srgbClr val="008080"/>
                 </a:highlight>
                 <a:latin typeface="Segoe UI" panose="020B0502040204020203" pitchFamily="34" charset="0"/>
                 <a:cs typeface="Segoe UI" panose="020B0502040204020203" pitchFamily="34" charset="0"/>
               </a:rPr>
-              <a:t>CHR</a:t>
+              <a:t>UL</a:t>
             </a:r>
           </a:p>
           <a:p>
@@ -8181,7 +8879,7 @@
                 <a:latin typeface="Segoe UI" panose="020B0502040204020203" pitchFamily="34" charset="0"/>
                 <a:cs typeface="Segoe UI" panose="020B0502040204020203" pitchFamily="34" charset="0"/>
               </a:rPr>
-              <a:t>Chatrooms</a:t>
+              <a:t>usrsLogs</a:t>
             </a:r>
             <a:endParaRPr sz="1280">
               <a:solidFill>
@@ -8196,14 +8894,14 @@
               <a:defRPr/>
             </a:pPr>
             <a:r>
-              <a:rPr lang="en-US" sz="853" i="1">
-                <a:solidFill>
-                  <a:schemeClr val="accent5"/>
+              <a:rPr lang="en-US" sz="853">
+                <a:solidFill>
+                  <a:schemeClr val="tx1"/>
                 </a:solidFill>
                 <a:latin typeface="Segoe UI" panose="020B0502040204020203" pitchFamily="34" charset="0"/>
                 <a:cs typeface="Segoe UI" panose="020B0502040204020203" pitchFamily="34" charset="0"/>
               </a:rPr>
-              <a:t>ChatroomId</a:t>
+              <a:t>UserId</a:t>
             </a:r>
           </a:p>
           <a:p>
@@ -8218,7 +8916,7 @@
                 <a:latin typeface="Segoe UI" panose="020B0502040204020203" pitchFamily="34" charset="0"/>
                 <a:cs typeface="Segoe UI" panose="020B0502040204020203" pitchFamily="34" charset="0"/>
               </a:rPr>
-              <a:t>ChatroomUserId</a:t>
+              <a:t>UserLogText</a:t>
             </a:r>
           </a:p>
           <a:p>
@@ -8233,468 +8931,7 @@
                 <a:latin typeface="Segoe UI" panose="020B0502040204020203" pitchFamily="34" charset="0"/>
                 <a:cs typeface="Segoe UI" panose="020B0502040204020203" pitchFamily="34" charset="0"/>
               </a:rPr>
-              <a:t>ChatroomAdminId</a:t>
-            </a:r>
-          </a:p>
-          <a:p>
-            <a:pPr rtl="0">
-              <a:defRPr/>
-            </a:pPr>
-            <a:r>
-              <a:rPr lang="en-US" sz="853">
-                <a:solidFill>
-                  <a:schemeClr val="tx1"/>
-                </a:solidFill>
-                <a:latin typeface="Segoe UI" panose="020B0502040204020203" pitchFamily="34" charset="0"/>
-                <a:cs typeface="Segoe UI" panose="020B0502040204020203" pitchFamily="34" charset="0"/>
-              </a:rPr>
-              <a:t>ChatroomName</a:t>
-            </a:r>
-          </a:p>
-          <a:p>
-            <a:pPr rtl="0">
-              <a:defRPr/>
-            </a:pPr>
-            <a:r>
-              <a:rPr lang="en-US" sz="853">
-                <a:solidFill>
-                  <a:schemeClr val="tx1"/>
-                </a:solidFill>
-                <a:latin typeface="Segoe UI" panose="020B0502040204020203" pitchFamily="34" charset="0"/>
-                <a:cs typeface="Segoe UI" panose="020B0502040204020203" pitchFamily="34" charset="0"/>
-              </a:rPr>
-              <a:t>ChatroomTerms</a:t>
-            </a:r>
-          </a:p>
-        </p:txBody>
-      </p:sp>
-      <p:sp>
-        <p:nvSpPr>
-          <p:cNvPr id="28" name="Rectangle: Rounded Corners 44">
-            <a:extLst>
-              <a:ext uri="{FF2B5EF4-FFF2-40B4-BE49-F238E27FC236}">
-                <a16:creationId xmlns:a16="http://schemas.microsoft.com/office/drawing/2014/main" id="{96D765ED-D9C6-3463-0136-8A90C3A57F14}"/>
-              </a:ext>
-            </a:extLst>
-          </p:cNvPr>
-          <p:cNvSpPr/>
-          <p:nvPr/>
-        </p:nvSpPr>
-        <p:spPr bwMode="auto">
-          <a:xfrm>
-            <a:off x="48639" y="157639"/>
-            <a:ext cx="1445914" cy="1642462"/>
-          </a:xfrm>
-          <a:prstGeom prst="roundRect">
-            <a:avLst>
-              <a:gd name="adj" fmla="val 6742"/>
-            </a:avLst>
-          </a:prstGeom>
-          <a:solidFill>
-            <a:schemeClr val="bg1"/>
-          </a:solidFill>
-          <a:ln>
-            <a:solidFill>
-              <a:schemeClr val="tx1"/>
-            </a:solidFill>
-          </a:ln>
-          <a:effectLst/>
-        </p:spPr>
-        <p:style>
-          <a:lnRef idx="0">
-            <a:schemeClr val="accent4"/>
-          </a:lnRef>
-          <a:fillRef idx="3">
-            <a:schemeClr val="accent4"/>
-          </a:fillRef>
-          <a:effectRef idx="3">
-            <a:schemeClr val="accent4"/>
-          </a:effectRef>
-          <a:fontRef idx="minor">
-            <a:schemeClr val="lt1"/>
-          </a:fontRef>
-        </p:style>
-        <p:txBody>
-          <a:bodyPr rtlCol="1" anchor="ctr"/>
-          <a:lstStyle/>
-          <a:p>
-            <a:pPr rtl="0">
-              <a:defRPr/>
-            </a:pPr>
-            <a:r>
-              <a:rPr lang="en-US" sz="1707" b="1">
-                <a:solidFill>
-                  <a:schemeClr val="bg1"/>
-                </a:solidFill>
-                <a:highlight>
-                  <a:srgbClr val="808000"/>
-                </a:highlight>
-                <a:latin typeface="Segoe UI" panose="020B0502040204020203" pitchFamily="34" charset="0"/>
-                <a:cs typeface="Segoe UI" panose="020B0502040204020203" pitchFamily="34" charset="0"/>
-              </a:rPr>
-              <a:t>CHRP</a:t>
-            </a:r>
-          </a:p>
-          <a:p>
-            <a:pPr rtl="0">
-              <a:defRPr/>
-            </a:pPr>
-            <a:r>
-              <a:rPr lang="en-US" sz="1280" b="1">
-                <a:solidFill>
-                  <a:schemeClr val="tx1"/>
-                </a:solidFill>
-                <a:latin typeface="Segoe UI" panose="020B0502040204020203" pitchFamily="34" charset="0"/>
-                <a:cs typeface="Segoe UI" panose="020B0502040204020203" pitchFamily="34" charset="0"/>
-              </a:rPr>
-              <a:t>ChatroomPosts</a:t>
-            </a:r>
-            <a:endParaRPr sz="1280">
-              <a:solidFill>
-                <a:schemeClr val="tx1"/>
-              </a:solidFill>
-              <a:latin typeface="Segoe UI" panose="020B0502040204020203" pitchFamily="34" charset="0"/>
-              <a:cs typeface="Segoe UI" panose="020B0502040204020203" pitchFamily="34" charset="0"/>
-            </a:endParaRPr>
-          </a:p>
-          <a:p>
-            <a:pPr rtl="0">
-              <a:defRPr/>
-            </a:pPr>
-            <a:r>
-              <a:rPr lang="en-US" sz="853" i="1">
-                <a:solidFill>
-                  <a:schemeClr val="accent5"/>
-                </a:solidFill>
-                <a:latin typeface="Segoe UI" panose="020B0502040204020203" pitchFamily="34" charset="0"/>
-                <a:cs typeface="Segoe UI" panose="020B0502040204020203" pitchFamily="34" charset="0"/>
-              </a:rPr>
-              <a:t>ChatroomPostId</a:t>
-            </a:r>
-          </a:p>
-          <a:p>
-            <a:pPr rtl="0">
-              <a:defRPr/>
-            </a:pPr>
-            <a:r>
-              <a:rPr lang="en-US" sz="853">
-                <a:solidFill>
-                  <a:schemeClr val="tx1"/>
-                </a:solidFill>
-                <a:latin typeface="Segoe UI" panose="020B0502040204020203" pitchFamily="34" charset="0"/>
-                <a:cs typeface="Segoe UI" panose="020B0502040204020203" pitchFamily="34" charset="0"/>
-              </a:rPr>
-              <a:t>ChatroomId</a:t>
-            </a:r>
-          </a:p>
-          <a:p>
-            <a:pPr rtl="0">
-              <a:defRPr/>
-            </a:pPr>
-            <a:r>
-              <a:rPr lang="en-US" sz="853">
-                <a:solidFill>
-                  <a:schemeClr val="tx1"/>
-                </a:solidFill>
-                <a:latin typeface="Segoe UI" panose="020B0502040204020203" pitchFamily="34" charset="0"/>
-                <a:cs typeface="Segoe UI" panose="020B0502040204020203" pitchFamily="34" charset="0"/>
-              </a:rPr>
-              <a:t>SenderId</a:t>
-            </a:r>
-          </a:p>
-          <a:p>
-            <a:pPr rtl="0">
-              <a:defRPr/>
-            </a:pPr>
-            <a:r>
-              <a:rPr lang="en-US" sz="853">
-                <a:solidFill>
-                  <a:schemeClr val="tx1"/>
-                </a:solidFill>
-                <a:latin typeface="Segoe UI" panose="020B0502040204020203" pitchFamily="34" charset="0"/>
-                <a:cs typeface="Segoe UI" panose="020B0502040204020203" pitchFamily="34" charset="0"/>
-              </a:rPr>
-              <a:t>PostDateTime</a:t>
-            </a:r>
-          </a:p>
-          <a:p>
-            <a:pPr rtl="0">
-              <a:defRPr/>
-            </a:pPr>
-            <a:r>
-              <a:rPr lang="en-US" sz="853">
-                <a:solidFill>
-                  <a:schemeClr val="tx1"/>
-                </a:solidFill>
-                <a:latin typeface="Segoe UI" panose="020B0502040204020203" pitchFamily="34" charset="0"/>
-                <a:cs typeface="Segoe UI" panose="020B0502040204020203" pitchFamily="34" charset="0"/>
-              </a:rPr>
-              <a:t>PostText</a:t>
-            </a:r>
-          </a:p>
-          <a:p>
-            <a:pPr rtl="0">
-              <a:defRPr/>
-            </a:pPr>
-            <a:r>
-              <a:rPr lang="en-US" sz="853">
-                <a:solidFill>
-                  <a:schemeClr val="tx1"/>
-                </a:solidFill>
-                <a:latin typeface="Segoe UI" panose="020B0502040204020203" pitchFamily="34" charset="0"/>
-                <a:cs typeface="Segoe UI" panose="020B0502040204020203" pitchFamily="34" charset="0"/>
-              </a:rPr>
-              <a:t>PostTags</a:t>
-            </a:r>
-          </a:p>
-          <a:p>
-            <a:pPr rtl="0">
-              <a:defRPr/>
-            </a:pPr>
-            <a:r>
-              <a:rPr lang="en-US" sz="500">
-                <a:solidFill>
-                  <a:srgbClr val="C00000"/>
-                </a:solidFill>
-                <a:latin typeface="Segoe UI" panose="020B0502040204020203" pitchFamily="34" charset="0"/>
-                <a:cs typeface="Segoe UI" panose="020B0502040204020203" pitchFamily="34" charset="0"/>
-              </a:rPr>
-              <a:t>  1:NeedReply</a:t>
-            </a:r>
-          </a:p>
-          <a:p>
-            <a:pPr rtl="0">
-              <a:defRPr/>
-            </a:pPr>
-            <a:r>
-              <a:rPr lang="en-US" sz="500">
-                <a:solidFill>
-                  <a:srgbClr val="C00000"/>
-                </a:solidFill>
-                <a:latin typeface="Segoe UI" panose="020B0502040204020203" pitchFamily="34" charset="0"/>
-                <a:cs typeface="Segoe UI" panose="020B0502040204020203" pitchFamily="34" charset="0"/>
-              </a:rPr>
-              <a:t>  2:IsEdited</a:t>
-            </a:r>
-          </a:p>
-          <a:p>
-            <a:pPr rtl="0">
-              <a:defRPr/>
-            </a:pPr>
-            <a:r>
-              <a:rPr lang="en-US" sz="500">
-                <a:solidFill>
-                  <a:srgbClr val="C00000"/>
-                </a:solidFill>
-                <a:latin typeface="Segoe UI" panose="020B0502040204020203" pitchFamily="34" charset="0"/>
-                <a:cs typeface="Segoe UI" panose="020B0502040204020203" pitchFamily="34" charset="0"/>
-              </a:rPr>
-              <a:t>  4:IsDeleted</a:t>
-            </a:r>
-          </a:p>
-        </p:txBody>
-      </p:sp>
-      <p:sp>
-        <p:nvSpPr>
-          <p:cNvPr id="2" name="Rectangle: Rounded Corners 1">
-            <a:extLst>
-              <a:ext uri="{FF2B5EF4-FFF2-40B4-BE49-F238E27FC236}">
-                <a16:creationId xmlns:a16="http://schemas.microsoft.com/office/drawing/2014/main" id="{6A0D2D6C-AD44-BFED-2D51-29757378D5BB}"/>
-              </a:ext>
-            </a:extLst>
-          </p:cNvPr>
-          <p:cNvSpPr/>
-          <p:nvPr/>
-        </p:nvSpPr>
-        <p:spPr>
-          <a:xfrm>
-            <a:off x="2735908" y="6417263"/>
-            <a:ext cx="895415" cy="1634612"/>
-          </a:xfrm>
-          <a:prstGeom prst="roundRect">
-            <a:avLst>
-              <a:gd name="adj" fmla="val 1266"/>
-            </a:avLst>
-          </a:prstGeom>
-          <a:solidFill>
-            <a:schemeClr val="bg1"/>
-          </a:solidFill>
-          <a:ln>
-            <a:solidFill>
-              <a:schemeClr val="tx1">
-                <a:lumMod val="65000"/>
-                <a:lumOff val="35000"/>
-              </a:schemeClr>
-            </a:solidFill>
-          </a:ln>
-        </p:spPr>
-        <p:style>
-          <a:lnRef idx="1">
-            <a:schemeClr val="accent4"/>
-          </a:lnRef>
-          <a:fillRef idx="2">
-            <a:schemeClr val="accent4"/>
-          </a:fillRef>
-          <a:effectRef idx="1">
-            <a:schemeClr val="accent4"/>
-          </a:effectRef>
-          <a:fontRef idx="minor">
-            <a:schemeClr val="dk1"/>
-          </a:fontRef>
-        </p:style>
-        <p:txBody>
-          <a:bodyPr rtlCol="1" anchor="t"/>
-          <a:lstStyle/>
-          <a:p>
-            <a:pPr rtl="0"/>
-            <a:r>
-              <a:rPr lang="en-US" sz="1707" b="1" dirty="0">
-                <a:solidFill>
-                  <a:schemeClr val="bg1"/>
-                </a:solidFill>
-                <a:highlight>
-                  <a:srgbClr val="000000"/>
-                </a:highlight>
-              </a:rPr>
-              <a:t>N</a:t>
-            </a:r>
-            <a:r>
-              <a:rPr lang="en-US" sz="1280" b="1" dirty="0"/>
-              <a:t>otes</a:t>
-            </a:r>
-          </a:p>
-          <a:p>
-            <a:pPr rtl="0"/>
-            <a:r>
-              <a:rPr lang="en-US" sz="853" i="1">
-                <a:solidFill>
-                  <a:schemeClr val="accent5"/>
-                </a:solidFill>
-                <a:latin typeface="Segoe UI" panose="020B0502040204020203" pitchFamily="34" charset="0"/>
-                <a:cs typeface="Segoe UI" panose="020B0502040204020203" pitchFamily="34" charset="0"/>
-              </a:rPr>
-              <a:t>NoteId</a:t>
-            </a:r>
-          </a:p>
-          <a:p>
-            <a:pPr rtl="0"/>
-            <a:r>
-              <a:rPr lang="en-US" sz="853"/>
-              <a:t>NoteType</a:t>
-            </a:r>
-          </a:p>
-          <a:p>
-            <a:pPr rtl="0"/>
-            <a:r>
-              <a:rPr lang="en-US" sz="853"/>
-              <a:t>ReferenceId</a:t>
-            </a:r>
-          </a:p>
-          <a:p>
-            <a:pPr rtl="0"/>
-            <a:r>
-              <a:rPr lang="en-US" sz="853"/>
-              <a:t>NoteDateTime</a:t>
-            </a:r>
-            <a:endParaRPr lang="en-US" sz="853" dirty="0"/>
-          </a:p>
-          <a:p>
-            <a:pPr rtl="0"/>
-            <a:r>
-              <a:rPr lang="en-US" sz="853"/>
-              <a:t>NoteText</a:t>
-            </a:r>
-            <a:endParaRPr lang="en-US" sz="853" dirty="0"/>
-          </a:p>
-          <a:p>
-            <a:pPr rtl="0"/>
-            <a:r>
-              <a:rPr lang="en-US" sz="853">
-                <a:solidFill>
-                  <a:schemeClr val="tx1"/>
-                </a:solidFill>
-              </a:rPr>
-              <a:t>CreatorId</a:t>
-            </a:r>
-            <a:endParaRPr lang="fa-IR" sz="853">
-              <a:solidFill>
-                <a:schemeClr val="tx1"/>
-              </a:solidFill>
-            </a:endParaRPr>
-          </a:p>
-          <a:p>
-            <a:pPr rtl="0"/>
-            <a:r>
-              <a:rPr lang="en-US" sz="853">
-                <a:solidFill>
-                  <a:schemeClr val="tx1"/>
-                </a:solidFill>
-              </a:rPr>
-              <a:t>NoteTags</a:t>
-            </a:r>
-          </a:p>
-          <a:p>
-            <a:pPr rtl="0">
-              <a:buNone/>
-            </a:pPr>
-            <a:r>
-              <a:rPr lang="en-US" sz="500" kern="100">
-                <a:solidFill>
-                  <a:srgbClr val="C00000"/>
-                </a:solidFill>
-                <a:latin typeface="Consolas" panose="020B0609020204030204" pitchFamily="49" charset="0"/>
-                <a:ea typeface="Calibri" panose="020F0502020204030204" pitchFamily="34" charset="0"/>
-                <a:cs typeface="Calibri Light" panose="020F0302020204030204" pitchFamily="34" charset="0"/>
-              </a:rPr>
-              <a:t> 1:IsRtl</a:t>
-            </a:r>
-          </a:p>
-          <a:p>
-            <a:pPr rtl="0">
-              <a:buNone/>
-            </a:pPr>
-            <a:r>
-              <a:rPr lang="en-US" sz="500" kern="100">
-                <a:solidFill>
-                  <a:srgbClr val="C00000"/>
-                </a:solidFill>
-                <a:latin typeface="Consolas" panose="020B0609020204030204" pitchFamily="49" charset="0"/>
-                <a:ea typeface="Calibri" panose="020F0502020204030204" pitchFamily="34" charset="0"/>
-                <a:cs typeface="Calibri Light" panose="020F0302020204030204" pitchFamily="34" charset="0"/>
-              </a:rPr>
-              <a:t> 2:IsDone</a:t>
-            </a:r>
-          </a:p>
-          <a:p>
-            <a:pPr rtl="0">
-              <a:buNone/>
-            </a:pPr>
-            <a:r>
-              <a:rPr lang="en-US" sz="500" kern="100">
-                <a:solidFill>
-                  <a:srgbClr val="C00000"/>
-                </a:solidFill>
-                <a:latin typeface="Consolas" panose="020B0609020204030204" pitchFamily="49" charset="0"/>
-                <a:ea typeface="Calibri" panose="020F0502020204030204" pitchFamily="34" charset="0"/>
-                <a:cs typeface="Calibri Light" panose="020F0302020204030204" pitchFamily="34" charset="0"/>
-              </a:rPr>
-              <a:t> 4:IsShared</a:t>
-            </a:r>
-          </a:p>
-          <a:p>
-            <a:pPr rtl="0">
-              <a:buNone/>
-            </a:pPr>
-            <a:r>
-              <a:rPr lang="en-US" sz="500" kern="100">
-                <a:solidFill>
-                  <a:srgbClr val="C00000"/>
-                </a:solidFill>
-                <a:latin typeface="Consolas" panose="020B0609020204030204" pitchFamily="49" charset="0"/>
-                <a:ea typeface="Calibri" panose="020F0502020204030204" pitchFamily="34" charset="0"/>
-                <a:cs typeface="Calibri Light" panose="020F0302020204030204" pitchFamily="34" charset="0"/>
-              </a:rPr>
-              <a:t> 8:IsReadonly</a:t>
+              <a:t>DateTime</a:t>
             </a:r>
           </a:p>
         </p:txBody>

</xml_diff>

<commit_message>
essay tests report - ok
</commit_message>
<xml_diff>
--- a/ExaminerB/.appCatalog/ExaminerB notes 1404.pptx
+++ b/ExaminerB/.appCatalog/ExaminerB notes 1404.pptx
@@ -280,7 +280,7 @@
             </a:pPr>
             <a:fld id="{BCC18F51-09EC-435C-A3BA-64A766E099C0}" type="datetimeFigureOut">
               <a:rPr lang="fa-IR"/>
-              <a:t>03/02/1448</a:t>
+              <a:t>05/02/1448</a:t>
             </a:fld>
             <a:endParaRPr/>
           </a:p>
@@ -459,7 +459,7 @@
             </a:pPr>
             <a:fld id="{BCC18F51-09EC-435C-A3BA-64A766E099C0}" type="datetimeFigureOut">
               <a:rPr lang="fa-IR"/>
-              <a:t>03/02/1448</a:t>
+              <a:t>05/02/1448</a:t>
             </a:fld>
             <a:endParaRPr/>
           </a:p>
@@ -648,7 +648,7 @@
             </a:pPr>
             <a:fld id="{BCC18F51-09EC-435C-A3BA-64A766E099C0}" type="datetimeFigureOut">
               <a:rPr lang="fa-IR"/>
-              <a:t>03/02/1448</a:t>
+              <a:t>05/02/1448</a:t>
             </a:fld>
             <a:endParaRPr/>
           </a:p>
@@ -827,7 +827,7 @@
             </a:pPr>
             <a:fld id="{BCC18F51-09EC-435C-A3BA-64A766E099C0}" type="datetimeFigureOut">
               <a:rPr lang="fa-IR"/>
-              <a:t>03/02/1448</a:t>
+              <a:t>05/02/1448</a:t>
             </a:fld>
             <a:endParaRPr/>
           </a:p>
@@ -1079,7 +1079,7 @@
             </a:pPr>
             <a:fld id="{BCC18F51-09EC-435C-A3BA-64A766E099C0}" type="datetimeFigureOut">
               <a:rPr lang="fa-IR"/>
-              <a:t>03/02/1448</a:t>
+              <a:t>05/02/1448</a:t>
             </a:fld>
             <a:endParaRPr/>
           </a:p>
@@ -1324,7 +1324,7 @@
             </a:pPr>
             <a:fld id="{BCC18F51-09EC-435C-A3BA-64A766E099C0}" type="datetimeFigureOut">
               <a:rPr lang="fa-IR"/>
-              <a:t>03/02/1448</a:t>
+              <a:t>05/02/1448</a:t>
             </a:fld>
             <a:endParaRPr/>
           </a:p>
@@ -1706,7 +1706,7 @@
             </a:pPr>
             <a:fld id="{BCC18F51-09EC-435C-A3BA-64A766E099C0}" type="datetimeFigureOut">
               <a:rPr lang="fa-IR"/>
-              <a:t>03/02/1448</a:t>
+              <a:t>05/02/1448</a:t>
             </a:fld>
             <a:endParaRPr/>
           </a:p>
@@ -1829,7 +1829,7 @@
             </a:pPr>
             <a:fld id="{BCC18F51-09EC-435C-A3BA-64A766E099C0}" type="datetimeFigureOut">
               <a:rPr lang="fa-IR"/>
-              <a:t>03/02/1448</a:t>
+              <a:t>05/02/1448</a:t>
             </a:fld>
             <a:endParaRPr/>
           </a:p>
@@ -1928,7 +1928,7 @@
             </a:pPr>
             <a:fld id="{BCC18F51-09EC-435C-A3BA-64A766E099C0}" type="datetimeFigureOut">
               <a:rPr lang="fa-IR"/>
-              <a:t>03/02/1448</a:t>
+              <a:t>05/02/1448</a:t>
             </a:fld>
             <a:endParaRPr/>
           </a:p>
@@ -2215,7 +2215,7 @@
             </a:pPr>
             <a:fld id="{BCC18F51-09EC-435C-A3BA-64A766E099C0}" type="datetimeFigureOut">
               <a:rPr lang="fa-IR"/>
-              <a:t>03/02/1448</a:t>
+              <a:t>05/02/1448</a:t>
             </a:fld>
             <a:endParaRPr/>
           </a:p>
@@ -2479,7 +2479,7 @@
             </a:pPr>
             <a:fld id="{BCC18F51-09EC-435C-A3BA-64A766E099C0}" type="datetimeFigureOut">
               <a:rPr lang="fa-IR"/>
-              <a:t>03/02/1448</a:t>
+              <a:t>05/02/1448</a:t>
             </a:fld>
             <a:endParaRPr/>
           </a:p>
@@ -2701,7 +2701,7 @@
             </a:pPr>
             <a:fld id="{BCC18F51-09EC-435C-A3BA-64A766E099C0}" type="datetimeFigureOut">
               <a:rPr lang="fa-IR"/>
-              <a:t>03/02/1448</a:t>
+              <a:t>05/02/1448</a:t>
             </a:fld>
             <a:endParaRPr/>
           </a:p>
@@ -9277,8 +9277,8 @@
         </p:nvSpPr>
         <p:spPr bwMode="auto">
           <a:xfrm>
-            <a:off x="6765737" y="4523011"/>
-            <a:ext cx="1855657" cy="2508836"/>
+            <a:off x="6765737" y="4503438"/>
+            <a:ext cx="1855657" cy="2573059"/>
           </a:xfrm>
           <a:prstGeom prst="roundRect">
             <a:avLst>
@@ -9646,6 +9646,20 @@
                 <a:cs typeface="Calibri Light" panose="020F0302020204030204" pitchFamily="34" charset="0"/>
               </a:rPr>
               <a:t>64 IsSelected</a:t>
+            </a:r>
+          </a:p>
+          <a:p>
+            <a:pPr marL="90488" rtl="0"/>
+            <a:r>
+              <a:rPr lang="en-US" sz="500" kern="100">
+                <a:solidFill>
+                  <a:srgbClr val="C00000"/>
+                </a:solidFill>
+                <a:latin typeface="Consolas" panose="020B0609020204030204" pitchFamily="49" charset="0"/>
+                <a:ea typeface="Calibri" panose="020F0502020204030204" pitchFamily="34" charset="0"/>
+                <a:cs typeface="Calibri Light" panose="020F0302020204030204" pitchFamily="34" charset="0"/>
+              </a:rPr>
+              <a:t>128 AnswerTextAcceptedByTeacher</a:t>
             </a:r>
           </a:p>
         </p:txBody>

</xml_diff>

<commit_message>
- Todo on Notes  in progress ...
</commit_message>
<xml_diff>
--- a/ExaminerB/.appCatalog/ExaminerB notes 1404.pptx
+++ b/ExaminerB/.appCatalog/ExaminerB notes 1404.pptx
@@ -280,7 +280,7 @@
             </a:pPr>
             <a:fld id="{BCC18F51-09EC-435C-A3BA-64A766E099C0}" type="datetimeFigureOut">
               <a:rPr lang="fa-IR"/>
-              <a:t>05/02/1448</a:t>
+              <a:t>06/02/1448</a:t>
             </a:fld>
             <a:endParaRPr/>
           </a:p>
@@ -459,7 +459,7 @@
             </a:pPr>
             <a:fld id="{BCC18F51-09EC-435C-A3BA-64A766E099C0}" type="datetimeFigureOut">
               <a:rPr lang="fa-IR"/>
-              <a:t>05/02/1448</a:t>
+              <a:t>06/02/1448</a:t>
             </a:fld>
             <a:endParaRPr/>
           </a:p>
@@ -648,7 +648,7 @@
             </a:pPr>
             <a:fld id="{BCC18F51-09EC-435C-A3BA-64A766E099C0}" type="datetimeFigureOut">
               <a:rPr lang="fa-IR"/>
-              <a:t>05/02/1448</a:t>
+              <a:t>06/02/1448</a:t>
             </a:fld>
             <a:endParaRPr/>
           </a:p>
@@ -827,7 +827,7 @@
             </a:pPr>
             <a:fld id="{BCC18F51-09EC-435C-A3BA-64A766E099C0}" type="datetimeFigureOut">
               <a:rPr lang="fa-IR"/>
-              <a:t>05/02/1448</a:t>
+              <a:t>06/02/1448</a:t>
             </a:fld>
             <a:endParaRPr/>
           </a:p>
@@ -1079,7 +1079,7 @@
             </a:pPr>
             <a:fld id="{BCC18F51-09EC-435C-A3BA-64A766E099C0}" type="datetimeFigureOut">
               <a:rPr lang="fa-IR"/>
-              <a:t>05/02/1448</a:t>
+              <a:t>06/02/1448</a:t>
             </a:fld>
             <a:endParaRPr/>
           </a:p>
@@ -1324,7 +1324,7 @@
             </a:pPr>
             <a:fld id="{BCC18F51-09EC-435C-A3BA-64A766E099C0}" type="datetimeFigureOut">
               <a:rPr lang="fa-IR"/>
-              <a:t>05/02/1448</a:t>
+              <a:t>06/02/1448</a:t>
             </a:fld>
             <a:endParaRPr/>
           </a:p>
@@ -1706,7 +1706,7 @@
             </a:pPr>
             <a:fld id="{BCC18F51-09EC-435C-A3BA-64A766E099C0}" type="datetimeFigureOut">
               <a:rPr lang="fa-IR"/>
-              <a:t>05/02/1448</a:t>
+              <a:t>06/02/1448</a:t>
             </a:fld>
             <a:endParaRPr/>
           </a:p>
@@ -1829,7 +1829,7 @@
             </a:pPr>
             <a:fld id="{BCC18F51-09EC-435C-A3BA-64A766E099C0}" type="datetimeFigureOut">
               <a:rPr lang="fa-IR"/>
-              <a:t>05/02/1448</a:t>
+              <a:t>06/02/1448</a:t>
             </a:fld>
             <a:endParaRPr/>
           </a:p>
@@ -1928,7 +1928,7 @@
             </a:pPr>
             <a:fld id="{BCC18F51-09EC-435C-A3BA-64A766E099C0}" type="datetimeFigureOut">
               <a:rPr lang="fa-IR"/>
-              <a:t>05/02/1448</a:t>
+              <a:t>06/02/1448</a:t>
             </a:fld>
             <a:endParaRPr/>
           </a:p>
@@ -2215,7 +2215,7 @@
             </a:pPr>
             <a:fld id="{BCC18F51-09EC-435C-A3BA-64A766E099C0}" type="datetimeFigureOut">
               <a:rPr lang="fa-IR"/>
-              <a:t>05/02/1448</a:t>
+              <a:t>06/02/1448</a:t>
             </a:fld>
             <a:endParaRPr/>
           </a:p>
@@ -2479,7 +2479,7 @@
             </a:pPr>
             <a:fld id="{BCC18F51-09EC-435C-A3BA-64A766E099C0}" type="datetimeFigureOut">
               <a:rPr lang="fa-IR"/>
-              <a:t>05/02/1448</a:t>
+              <a:t>06/02/1448</a:t>
             </a:fld>
             <a:endParaRPr/>
           </a:p>
@@ -2701,7 +2701,7 @@
             </a:pPr>
             <a:fld id="{BCC18F51-09EC-435C-A3BA-64A766E099C0}" type="datetimeFigureOut">
               <a:rPr lang="fa-IR"/>
-              <a:t>05/02/1448</a:t>
+              <a:t>06/02/1448</a:t>
             </a:fld>
             <a:endParaRPr/>
           </a:p>
@@ -9865,7 +9865,7 @@
         </p:nvSpPr>
         <p:spPr bwMode="auto">
           <a:xfrm>
-            <a:off x="1154352" y="6690674"/>
+            <a:off x="1311283" y="6765485"/>
             <a:ext cx="1105070" cy="787849"/>
           </a:xfrm>
           <a:prstGeom prst="borderCallout2">
@@ -10550,8 +10550,8 @@
         </p:nvSpPr>
         <p:spPr>
           <a:xfrm>
-            <a:off x="139591" y="6459549"/>
-            <a:ext cx="976113" cy="1787289"/>
+            <a:off x="139591" y="6480621"/>
+            <a:ext cx="1105070" cy="1975950"/>
           </a:xfrm>
           <a:prstGeom prst="roundRect">
             <a:avLst>
@@ -10642,6 +10642,13 @@
               <a:rPr lang="en-US" sz="853"/>
               <a:t>NoteDateTime</a:t>
             </a:r>
+          </a:p>
+          <a:p>
+            <a:pPr rtl="0"/>
+            <a:r>
+              <a:rPr lang="en-US" sz="853"/>
+              <a:t>NoteDueDateTime</a:t>
+            </a:r>
             <a:endParaRPr lang="en-US" sz="853" dirty="0"/>
           </a:p>
           <a:p>
@@ -10696,9 +10703,7 @@
             </a:r>
           </a:p>
           <a:p>
-            <a:pPr rtl="0">
-              <a:buNone/>
-            </a:pPr>
+            <a:pPr rtl="0"/>
             <a:r>
               <a:rPr lang="en-US" sz="500" kern="100">
                 <a:solidFill>
@@ -10708,7 +10713,7 @@
                 <a:ea typeface="Calibri" panose="020F0502020204030204" pitchFamily="34" charset="0"/>
                 <a:cs typeface="Calibri Light" panose="020F0302020204030204" pitchFamily="34" charset="0"/>
               </a:rPr>
-              <a:t> 2:IsDone</a:t>
+              <a:t> 2:IsTodo</a:t>
             </a:r>
           </a:p>
           <a:p>
@@ -10724,7 +10729,7 @@
                 <a:ea typeface="Calibri" panose="020F0502020204030204" pitchFamily="34" charset="0"/>
                 <a:cs typeface="Calibri Light" panose="020F0302020204030204" pitchFamily="34" charset="0"/>
               </a:rPr>
-              <a:t> 4:IsShared</a:t>
+              <a:t> 4:IsDone</a:t>
             </a:r>
           </a:p>
           <a:p>
@@ -10740,7 +10745,23 @@
                 <a:ea typeface="Calibri" panose="020F0502020204030204" pitchFamily="34" charset="0"/>
                 <a:cs typeface="Calibri Light" panose="020F0302020204030204" pitchFamily="34" charset="0"/>
               </a:rPr>
-              <a:t> 8:IsReadonly</a:t>
+              <a:t> 8:IsShared</a:t>
+            </a:r>
+          </a:p>
+          <a:p>
+            <a:pPr rtl="0">
+              <a:buNone/>
+            </a:pPr>
+            <a:r>
+              <a:rPr lang="en-US" sz="500" kern="100">
+                <a:solidFill>
+                  <a:srgbClr val="C00000"/>
+                </a:solidFill>
+                <a:latin typeface="Consolas" panose="020B0609020204030204" pitchFamily="49" charset="0"/>
+                <a:ea typeface="Calibri" panose="020F0502020204030204" pitchFamily="34" charset="0"/>
+                <a:cs typeface="Calibri Light" panose="020F0302020204030204" pitchFamily="34" charset="0"/>
+              </a:rPr>
+              <a:t>16:IsReadonly</a:t>
             </a:r>
           </a:p>
         </p:txBody>
@@ -10759,7 +10780,7 @@
         </p:nvSpPr>
         <p:spPr>
           <a:xfrm>
-            <a:off x="928564" y="7596296"/>
+            <a:off x="1048111" y="7703030"/>
             <a:ext cx="954729" cy="900550"/>
           </a:xfrm>
           <a:prstGeom prst="roundRect">

</xml_diff>

<commit_message>
-shoe reminder for Due notes -settings for 3~7 days reminder
</commit_message>
<xml_diff>
--- a/ExaminerB/.appCatalog/ExaminerB notes 1404.pptx
+++ b/ExaminerB/.appCatalog/ExaminerB notes 1404.pptx
@@ -280,7 +280,7 @@
             </a:pPr>
             <a:fld id="{BCC18F51-09EC-435C-A3BA-64A766E099C0}" type="datetimeFigureOut">
               <a:rPr lang="fa-IR"/>
-              <a:t>06/02/1448</a:t>
+              <a:t>07/02/1448</a:t>
             </a:fld>
             <a:endParaRPr/>
           </a:p>
@@ -459,7 +459,7 @@
             </a:pPr>
             <a:fld id="{BCC18F51-09EC-435C-A3BA-64A766E099C0}" type="datetimeFigureOut">
               <a:rPr lang="fa-IR"/>
-              <a:t>06/02/1448</a:t>
+              <a:t>07/02/1448</a:t>
             </a:fld>
             <a:endParaRPr/>
           </a:p>
@@ -648,7 +648,7 @@
             </a:pPr>
             <a:fld id="{BCC18F51-09EC-435C-A3BA-64A766E099C0}" type="datetimeFigureOut">
               <a:rPr lang="fa-IR"/>
-              <a:t>06/02/1448</a:t>
+              <a:t>07/02/1448</a:t>
             </a:fld>
             <a:endParaRPr/>
           </a:p>
@@ -827,7 +827,7 @@
             </a:pPr>
             <a:fld id="{BCC18F51-09EC-435C-A3BA-64A766E099C0}" type="datetimeFigureOut">
               <a:rPr lang="fa-IR"/>
-              <a:t>06/02/1448</a:t>
+              <a:t>07/02/1448</a:t>
             </a:fld>
             <a:endParaRPr/>
           </a:p>
@@ -1079,7 +1079,7 @@
             </a:pPr>
             <a:fld id="{BCC18F51-09EC-435C-A3BA-64A766E099C0}" type="datetimeFigureOut">
               <a:rPr lang="fa-IR"/>
-              <a:t>06/02/1448</a:t>
+              <a:t>07/02/1448</a:t>
             </a:fld>
             <a:endParaRPr/>
           </a:p>
@@ -1324,7 +1324,7 @@
             </a:pPr>
             <a:fld id="{BCC18F51-09EC-435C-A3BA-64A766E099C0}" type="datetimeFigureOut">
               <a:rPr lang="fa-IR"/>
-              <a:t>06/02/1448</a:t>
+              <a:t>07/02/1448</a:t>
             </a:fld>
             <a:endParaRPr/>
           </a:p>
@@ -1706,7 +1706,7 @@
             </a:pPr>
             <a:fld id="{BCC18F51-09EC-435C-A3BA-64A766E099C0}" type="datetimeFigureOut">
               <a:rPr lang="fa-IR"/>
-              <a:t>06/02/1448</a:t>
+              <a:t>07/02/1448</a:t>
             </a:fld>
             <a:endParaRPr/>
           </a:p>
@@ -1829,7 +1829,7 @@
             </a:pPr>
             <a:fld id="{BCC18F51-09EC-435C-A3BA-64A766E099C0}" type="datetimeFigureOut">
               <a:rPr lang="fa-IR"/>
-              <a:t>06/02/1448</a:t>
+              <a:t>07/02/1448</a:t>
             </a:fld>
             <a:endParaRPr/>
           </a:p>
@@ -1928,7 +1928,7 @@
             </a:pPr>
             <a:fld id="{BCC18F51-09EC-435C-A3BA-64A766E099C0}" type="datetimeFigureOut">
               <a:rPr lang="fa-IR"/>
-              <a:t>06/02/1448</a:t>
+              <a:t>07/02/1448</a:t>
             </a:fld>
             <a:endParaRPr/>
           </a:p>
@@ -2215,7 +2215,7 @@
             </a:pPr>
             <a:fld id="{BCC18F51-09EC-435C-A3BA-64A766E099C0}" type="datetimeFigureOut">
               <a:rPr lang="fa-IR"/>
-              <a:t>06/02/1448</a:t>
+              <a:t>07/02/1448</a:t>
             </a:fld>
             <a:endParaRPr/>
           </a:p>
@@ -2479,7 +2479,7 @@
             </a:pPr>
             <a:fld id="{BCC18F51-09EC-435C-A3BA-64A766E099C0}" type="datetimeFigureOut">
               <a:rPr lang="fa-IR"/>
-              <a:t>06/02/1448</a:t>
+              <a:t>07/02/1448</a:t>
             </a:fld>
             <a:endParaRPr/>
           </a:p>
@@ -2701,7 +2701,7 @@
             </a:pPr>
             <a:fld id="{BCC18F51-09EC-435C-A3BA-64A766E099C0}" type="datetimeFigureOut">
               <a:rPr lang="fa-IR"/>
-              <a:t>06/02/1448</a:t>
+              <a:t>07/02/1448</a:t>
             </a:fld>
             <a:endParaRPr/>
           </a:p>
@@ -11056,8 +11056,8 @@
         </p:nvSpPr>
         <p:spPr bwMode="auto">
           <a:xfrm>
-            <a:off x="3888036" y="90839"/>
-            <a:ext cx="1366068" cy="1748618"/>
+            <a:off x="3829694" y="90838"/>
+            <a:ext cx="1424410" cy="1936967"/>
           </a:xfrm>
           <a:prstGeom prst="roundRect">
             <a:avLst>
@@ -11295,7 +11295,7 @@
                 <a:latin typeface="Segoe UI" panose="020B0502040204020203" pitchFamily="34" charset="0"/>
                 <a:cs typeface="Segoe UI" panose="020B0502040204020203" pitchFamily="34" charset="0"/>
               </a:rPr>
-              <a:t>16  : -          32  : -</a:t>
+              <a:t>16  : ShowDueNotes</a:t>
             </a:r>
           </a:p>
           <a:p>
@@ -11310,7 +11310,37 @@
                 <a:latin typeface="Segoe UI" panose="020B0502040204020203" pitchFamily="34" charset="0"/>
                 <a:cs typeface="Segoe UI" panose="020B0502040204020203" pitchFamily="34" charset="0"/>
               </a:rPr>
-              <a:t>64  : -          128: SuperUser</a:t>
+              <a:t>32  : DueNotesDays=7 (default=3)</a:t>
+            </a:r>
+          </a:p>
+          <a:p>
+            <a:pPr marL="90488" rtl="0">
+              <a:defRPr/>
+            </a:pPr>
+            <a:r>
+              <a:rPr lang="en-US" sz="500">
+                <a:solidFill>
+                  <a:srgbClr val="C00000"/>
+                </a:solidFill>
+                <a:latin typeface="Segoe UI" panose="020B0502040204020203" pitchFamily="34" charset="0"/>
+                <a:cs typeface="Segoe UI" panose="020B0502040204020203" pitchFamily="34" charset="0"/>
+              </a:rPr>
+              <a:t>64  : -  </a:t>
+            </a:r>
+          </a:p>
+          <a:p>
+            <a:pPr marL="90488" rtl="0">
+              <a:defRPr/>
+            </a:pPr>
+            <a:r>
+              <a:rPr lang="en-US" sz="500">
+                <a:solidFill>
+                  <a:srgbClr val="C00000"/>
+                </a:solidFill>
+                <a:latin typeface="Segoe UI" panose="020B0502040204020203" pitchFamily="34" charset="0"/>
+                <a:cs typeface="Segoe UI" panose="020B0502040204020203" pitchFamily="34" charset="0"/>
+              </a:rPr>
+              <a:t>128: SuperUser</a:t>
             </a:r>
           </a:p>
           <a:p>
@@ -11618,7 +11648,7 @@
         </p:nvSpPr>
         <p:spPr bwMode="auto">
           <a:xfrm>
-            <a:off x="5007411" y="1296045"/>
+            <a:off x="5112172" y="1296045"/>
             <a:ext cx="1077711" cy="915820"/>
           </a:xfrm>
           <a:prstGeom prst="roundRect">

</xml_diff>

<commit_message>
-utc date and time on save / update corrected
</commit_message>
<xml_diff>
--- a/ExaminerB/.appCatalog/ExaminerB notes 1404.pptx
+++ b/ExaminerB/.appCatalog/ExaminerB notes 1404.pptx
@@ -280,7 +280,7 @@
             </a:pPr>
             <a:fld id="{BCC18F51-09EC-435C-A3BA-64A766E099C0}" type="datetimeFigureOut">
               <a:rPr lang="fa-IR"/>
-              <a:t>07/02/1448</a:t>
+              <a:t>08/02/1448</a:t>
             </a:fld>
             <a:endParaRPr/>
           </a:p>
@@ -459,7 +459,7 @@
             </a:pPr>
             <a:fld id="{BCC18F51-09EC-435C-A3BA-64A766E099C0}" type="datetimeFigureOut">
               <a:rPr lang="fa-IR"/>
-              <a:t>07/02/1448</a:t>
+              <a:t>08/02/1448</a:t>
             </a:fld>
             <a:endParaRPr/>
           </a:p>
@@ -648,7 +648,7 @@
             </a:pPr>
             <a:fld id="{BCC18F51-09EC-435C-A3BA-64A766E099C0}" type="datetimeFigureOut">
               <a:rPr lang="fa-IR"/>
-              <a:t>07/02/1448</a:t>
+              <a:t>08/02/1448</a:t>
             </a:fld>
             <a:endParaRPr/>
           </a:p>
@@ -827,7 +827,7 @@
             </a:pPr>
             <a:fld id="{BCC18F51-09EC-435C-A3BA-64A766E099C0}" type="datetimeFigureOut">
               <a:rPr lang="fa-IR"/>
-              <a:t>07/02/1448</a:t>
+              <a:t>08/02/1448</a:t>
             </a:fld>
             <a:endParaRPr/>
           </a:p>
@@ -1079,7 +1079,7 @@
             </a:pPr>
             <a:fld id="{BCC18F51-09EC-435C-A3BA-64A766E099C0}" type="datetimeFigureOut">
               <a:rPr lang="fa-IR"/>
-              <a:t>07/02/1448</a:t>
+              <a:t>08/02/1448</a:t>
             </a:fld>
             <a:endParaRPr/>
           </a:p>
@@ -1324,7 +1324,7 @@
             </a:pPr>
             <a:fld id="{BCC18F51-09EC-435C-A3BA-64A766E099C0}" type="datetimeFigureOut">
               <a:rPr lang="fa-IR"/>
-              <a:t>07/02/1448</a:t>
+              <a:t>08/02/1448</a:t>
             </a:fld>
             <a:endParaRPr/>
           </a:p>
@@ -1706,7 +1706,7 @@
             </a:pPr>
             <a:fld id="{BCC18F51-09EC-435C-A3BA-64A766E099C0}" type="datetimeFigureOut">
               <a:rPr lang="fa-IR"/>
-              <a:t>07/02/1448</a:t>
+              <a:t>08/02/1448</a:t>
             </a:fld>
             <a:endParaRPr/>
           </a:p>
@@ -1829,7 +1829,7 @@
             </a:pPr>
             <a:fld id="{BCC18F51-09EC-435C-A3BA-64A766E099C0}" type="datetimeFigureOut">
               <a:rPr lang="fa-IR"/>
-              <a:t>07/02/1448</a:t>
+              <a:t>08/02/1448</a:t>
             </a:fld>
             <a:endParaRPr/>
           </a:p>
@@ -1928,7 +1928,7 @@
             </a:pPr>
             <a:fld id="{BCC18F51-09EC-435C-A3BA-64A766E099C0}" type="datetimeFigureOut">
               <a:rPr lang="fa-IR"/>
-              <a:t>07/02/1448</a:t>
+              <a:t>08/02/1448</a:t>
             </a:fld>
             <a:endParaRPr/>
           </a:p>
@@ -2215,7 +2215,7 @@
             </a:pPr>
             <a:fld id="{BCC18F51-09EC-435C-A3BA-64A766E099C0}" type="datetimeFigureOut">
               <a:rPr lang="fa-IR"/>
-              <a:t>07/02/1448</a:t>
+              <a:t>08/02/1448</a:t>
             </a:fld>
             <a:endParaRPr/>
           </a:p>
@@ -2479,7 +2479,7 @@
             </a:pPr>
             <a:fld id="{BCC18F51-09EC-435C-A3BA-64A766E099C0}" type="datetimeFigureOut">
               <a:rPr lang="fa-IR"/>
-              <a:t>07/02/1448</a:t>
+              <a:t>08/02/1448</a:t>
             </a:fld>
             <a:endParaRPr/>
           </a:p>
@@ -2701,7 +2701,7 @@
             </a:pPr>
             <a:fld id="{BCC18F51-09EC-435C-A3BA-64A766E099C0}" type="datetimeFigureOut">
               <a:rPr lang="fa-IR"/>
-              <a:t>07/02/1448</a:t>
+              <a:t>08/02/1448</a:t>
             </a:fld>
             <a:endParaRPr/>
           </a:p>

</xml_diff>